<commit_message>
feat: template PPTX com branding FUNFARME para relatórios
- Cria reports/assets/ com logos otimizados (FUNFARME, Hospital de Base, NTI)
- Cria scripts/cria-template-pptx.py para gerar o template com branding
- Atualiza gera-relatorio.py para usar o template (clona slides, substitui placeholders)
- Regenera relatório de junho com o novo template

Co-Authored-By: Claude Sonnet 4.6 <noreply@anthropic.com>
</commit_message>
<xml_diff>
--- a/reports/2026-06_resumo-mensal.pptx
+++ b/reports/2026-06_resumo-mensal.pptx
@@ -10,6 +10,8 @@
     <p:sldId id="258" r:id="rId9"/>
     <p:sldId id="259" r:id="rId10"/>
     <p:sldId id="260" r:id="rId11"/>
+    <p:sldId id="261" r:id="rId12"/>
+    <p:sldId id="262" r:id="rId13"/>
   </p:sldIdLst>
   <p:sldSz cx="12191695" cy="6858000" type="screen4x3"/>
   <p:notesSz cx="6858000" cy="9144000"/>
@@ -3094,14 +3096,148 @@
       <p:grpSpPr/>
       <p:sp>
         <p:nvSpPr>
-          <p:cNvPr id="2" name="TextBox 1"/>
+          <p:cNvPr id="2" name="Rectangle 1"/>
+          <p:cNvSpPr/>
+          <p:nvPr/>
+        </p:nvSpPr>
+        <p:spPr>
+          <a:xfrm>
+            <a:off x="0" y="0"/>
+            <a:ext cx="12191695" cy="3200400"/>
+          </a:xfrm>
+          <a:prstGeom prst="rect">
+            <a:avLst/>
+          </a:prstGeom>
+          <a:solidFill>
+            <a:srgbClr val="00897B"/>
+          </a:solidFill>
+          <a:ln>
+            <a:noFill/>
+          </a:ln>
+        </p:spPr>
+        <p:style>
+          <a:lnRef idx="1">
+            <a:schemeClr val="accent1"/>
+          </a:lnRef>
+          <a:fillRef idx="3">
+            <a:schemeClr val="accent1"/>
+          </a:fillRef>
+          <a:effectRef idx="2">
+            <a:schemeClr val="accent1"/>
+          </a:effectRef>
+          <a:fontRef idx="minor">
+            <a:schemeClr val="lt1"/>
+          </a:fontRef>
+        </p:style>
+        <p:txBody>
+          <a:bodyPr rtlCol="0" anchor="ctr"/>
+          <a:lstStyle/>
+          <a:p>
+            <a:pPr algn="ctr"/>
+          </a:p>
+        </p:txBody>
+      </p:sp>
+      <p:sp>
+        <p:nvSpPr>
+          <p:cNvPr id="3" name="Rectangle 2"/>
+          <p:cNvSpPr/>
+          <p:nvPr/>
+        </p:nvSpPr>
+        <p:spPr>
+          <a:xfrm>
+            <a:off x="0" y="3200400"/>
+            <a:ext cx="12191695" cy="54864"/>
+          </a:xfrm>
+          <a:prstGeom prst="rect">
+            <a:avLst/>
+          </a:prstGeom>
+          <a:solidFill>
+            <a:srgbClr val="00BCD4"/>
+          </a:solidFill>
+          <a:ln>
+            <a:noFill/>
+          </a:ln>
+        </p:spPr>
+        <p:style>
+          <a:lnRef idx="1">
+            <a:schemeClr val="accent1"/>
+          </a:lnRef>
+          <a:fillRef idx="3">
+            <a:schemeClr val="accent1"/>
+          </a:fillRef>
+          <a:effectRef idx="2">
+            <a:schemeClr val="accent1"/>
+          </a:effectRef>
+          <a:fontRef idx="minor">
+            <a:schemeClr val="lt1"/>
+          </a:fontRef>
+        </p:style>
+        <p:txBody>
+          <a:bodyPr rtlCol="0" anchor="ctr"/>
+          <a:lstStyle/>
+          <a:p>
+            <a:pPr algn="ctr"/>
+          </a:p>
+        </p:txBody>
+      </p:sp>
+      <p:pic>
+        <p:nvPicPr>
+          <p:cNvPr id="4" name="Picture 3" descr="funfarme.jpg"/>
+          <p:cNvPicPr>
+            <a:picLocks noChangeAspect="1"/>
+          </p:cNvPicPr>
+          <p:nvPr/>
+        </p:nvPicPr>
+        <p:blipFill>
+          <a:blip r:embed="rId2"/>
+          <a:stretch>
+            <a:fillRect/>
+          </a:stretch>
+        </p:blipFill>
+        <p:spPr>
+          <a:xfrm>
+            <a:off x="9326880" y="274320"/>
+            <a:ext cx="1005840" cy="1005840"/>
+          </a:xfrm>
+          <a:prstGeom prst="rect">
+            <a:avLst/>
+          </a:prstGeom>
+        </p:spPr>
+      </p:pic>
+      <p:pic>
+        <p:nvPicPr>
+          <p:cNvPr id="5" name="Picture 4" descr="hospital-de-base.png"/>
+          <p:cNvPicPr>
+            <a:picLocks noChangeAspect="1"/>
+          </p:cNvPicPr>
+          <p:nvPr/>
+        </p:nvPicPr>
+        <p:blipFill>
+          <a:blip r:embed="rId3"/>
+          <a:stretch>
+            <a:fillRect/>
+          </a:stretch>
+        </p:blipFill>
+        <p:spPr>
+          <a:xfrm>
+            <a:off x="10607040" y="320040"/>
+            <a:ext cx="1411550" cy="822960"/>
+          </a:xfrm>
+          <a:prstGeom prst="rect">
+            <a:avLst/>
+          </a:prstGeom>
+        </p:spPr>
+      </p:pic>
+      <p:sp>
+        <p:nvSpPr>
+          <p:cNvPr id="6" name="TextBox 5"/>
           <p:cNvSpPr txBox="1"/>
           <p:nvPr/>
         </p:nvSpPr>
         <p:spPr>
           <a:xfrm>
-            <a:off x="914400" y="2286000"/>
-            <a:ext cx="10058400" cy="1828800"/>
+            <a:off x="914400" y="914400"/>
+            <a:ext cx="7772400" cy="914400"/>
           </a:xfrm>
           <a:prstGeom prst="rect">
             <a:avLst/>
@@ -3109,33 +3245,517 @@
           <a:noFill/>
         </p:spPr>
         <p:txBody>
-          <a:bodyPr wrap="none">
+          <a:bodyPr wrap="square">
             <a:spAutoFit/>
           </a:bodyPr>
           <a:lstStyle/>
           <a:p>
+            <a:pPr algn="l">
+              <a:defRPr sz="4400" b="1">
+                <a:solidFill>
+                  <a:srgbClr val="FFFFFF"/>
+                </a:solidFill>
+                <a:latin typeface="Calibri"/>
+              </a:defRPr>
+            </a:pPr>
+            <a:r>
+              <a:t>RELATÓRIO MENSAL</a:t>
+            </a:r>
+          </a:p>
+        </p:txBody>
+      </p:sp>
+      <p:sp>
+        <p:nvSpPr>
+          <p:cNvPr id="7" name="TextBox 6"/>
+          <p:cNvSpPr txBox="1"/>
+          <p:nvPr/>
+        </p:nvSpPr>
+        <p:spPr>
+          <a:xfrm>
+            <a:off x="914400" y="1828800"/>
+            <a:ext cx="7772400" cy="548640"/>
+          </a:xfrm>
+          <a:prstGeom prst="rect">
+            <a:avLst/>
+          </a:prstGeom>
+          <a:noFill/>
+        </p:spPr>
+        <p:txBody>
+          <a:bodyPr wrap="square">
+            <a:spAutoFit/>
+          </a:bodyPr>
+          <a:lstStyle/>
+          <a:p>
+            <a:pPr algn="l">
+              <a:defRPr sz="2600" b="0">
+                <a:solidFill>
+                  <a:srgbClr val="E0F2F1"/>
+                </a:solidFill>
+                <a:latin typeface="Calibri"/>
+              </a:defRPr>
+            </a:pPr>
+            <a:r>
+              <a:t>Junho 2026</a:t>
+            </a:r>
+          </a:p>
+        </p:txBody>
+      </p:sp>
+      <p:sp>
+        <p:nvSpPr>
+          <p:cNvPr id="8" name="TextBox 7"/>
+          <p:cNvSpPr txBox="1"/>
+          <p:nvPr/>
+        </p:nvSpPr>
+        <p:spPr>
+          <a:xfrm>
+            <a:off x="914400" y="2377440"/>
+            <a:ext cx="7772400" cy="457200"/>
+          </a:xfrm>
+          <a:prstGeom prst="rect">
+            <a:avLst/>
+          </a:prstGeom>
+          <a:noFill/>
+        </p:spPr>
+        <p:txBody>
+          <a:bodyPr wrap="square">
+            <a:spAutoFit/>
+          </a:bodyPr>
+          <a:lstStyle/>
+          <a:p>
+            <a:pPr algn="l">
+              <a:defRPr sz="1600" b="0">
+                <a:solidFill>
+                  <a:srgbClr val="E0F2F1"/>
+                </a:solidFill>
+                <a:latin typeface="Calibri"/>
+              </a:defRPr>
+            </a:pPr>
+            <a:r>
+              <a:t>TI Laboratório Central — FUNFARME</a:t>
+            </a:r>
+          </a:p>
+        </p:txBody>
+      </p:sp>
+      <p:sp>
+        <p:nvSpPr>
+          <p:cNvPr id="9" name="Rectangle 8"/>
+          <p:cNvSpPr/>
+          <p:nvPr/>
+        </p:nvSpPr>
+        <p:spPr>
+          <a:xfrm>
+            <a:off x="914400" y="3840480"/>
+            <a:ext cx="2926080" cy="1828800"/>
+          </a:xfrm>
+          <a:prstGeom prst="rect">
+            <a:avLst/>
+          </a:prstGeom>
+          <a:solidFill>
+            <a:srgbClr val="F5F5F5"/>
+          </a:solidFill>
+          <a:ln>
+            <a:noFill/>
+          </a:ln>
+        </p:spPr>
+        <p:style>
+          <a:lnRef idx="1">
+            <a:schemeClr val="accent1"/>
+          </a:lnRef>
+          <a:fillRef idx="3">
+            <a:schemeClr val="accent1"/>
+          </a:fillRef>
+          <a:effectRef idx="2">
+            <a:schemeClr val="accent1"/>
+          </a:effectRef>
+          <a:fontRef idx="minor">
+            <a:schemeClr val="lt1"/>
+          </a:fontRef>
+        </p:style>
+        <p:txBody>
+          <a:bodyPr rtlCol="0" anchor="ctr"/>
+          <a:lstStyle/>
+          <a:p>
+            <a:pPr algn="ctr"/>
+          </a:p>
+        </p:txBody>
+      </p:sp>
+      <p:sp>
+        <p:nvSpPr>
+          <p:cNvPr id="10" name="TextBox 9"/>
+          <p:cNvSpPr txBox="1"/>
+          <p:nvPr/>
+        </p:nvSpPr>
+        <p:spPr>
+          <a:xfrm>
+            <a:off x="914400" y="3977639"/>
+            <a:ext cx="2926080" cy="365760"/>
+          </a:xfrm>
+          <a:prstGeom prst="rect">
+            <a:avLst/>
+          </a:prstGeom>
+          <a:noFill/>
+        </p:spPr>
+        <p:txBody>
+          <a:bodyPr wrap="square">
+            <a:spAutoFit/>
+          </a:bodyPr>
+          <a:lstStyle/>
+          <a:p>
             <a:pPr algn="ctr">
-              <a:defRPr sz="3600" b="1"/>
+              <a:defRPr sz="1300" b="0">
+                <a:solidFill>
+                  <a:srgbClr val="757575"/>
+                </a:solidFill>
+                <a:latin typeface="Calibri"/>
+              </a:defRPr>
             </a:pPr>
             <a:r>
-              <a:t>Resumo Mensal — Junho 2026</a:t>
-            </a:r>
-          </a:p>
+              <a:t>Tarefas concluídas</a:t>
+            </a:r>
+          </a:p>
+        </p:txBody>
+      </p:sp>
+      <p:sp>
+        <p:nvSpPr>
+          <p:cNvPr id="11" name="TextBox 10"/>
+          <p:cNvSpPr txBox="1"/>
+          <p:nvPr/>
+        </p:nvSpPr>
+        <p:spPr>
+          <a:xfrm>
+            <a:off x="914400" y="4389120"/>
+            <a:ext cx="2926080" cy="914400"/>
+          </a:xfrm>
+          <a:prstGeom prst="rect">
+            <a:avLst/>
+          </a:prstGeom>
+          <a:noFill/>
+        </p:spPr>
+        <p:txBody>
+          <a:bodyPr wrap="square">
+            <a:spAutoFit/>
+          </a:bodyPr>
+          <a:lstStyle/>
           <a:p>
             <a:pPr algn="ctr">
-              <a:defRPr sz="2000"/>
+              <a:defRPr sz="5200" b="1">
+                <a:solidFill>
+                  <a:srgbClr val="00897B"/>
+                </a:solidFill>
+                <a:latin typeface="Calibri"/>
+              </a:defRPr>
             </a:pPr>
             <a:r>
-              <a:t>TI Laboratório — FUNFARME</a:t>
-            </a:r>
-          </a:p>
-          <a:p>
-            <a:br/>
+              <a:t>16</a:t>
+            </a:r>
+          </a:p>
+        </p:txBody>
+      </p:sp>
+      <p:sp>
+        <p:nvSpPr>
+          <p:cNvPr id="12" name="Rectangle 11"/>
+          <p:cNvSpPr/>
+          <p:nvPr/>
+        </p:nvSpPr>
+        <p:spPr>
+          <a:xfrm>
+            <a:off x="4663440" y="3840480"/>
+            <a:ext cx="2926080" cy="1828800"/>
+          </a:xfrm>
+          <a:prstGeom prst="rect">
+            <a:avLst/>
+          </a:prstGeom>
+          <a:solidFill>
+            <a:srgbClr val="F5F5F5"/>
+          </a:solidFill>
+          <a:ln>
+            <a:noFill/>
+          </a:ln>
+        </p:spPr>
+        <p:style>
+          <a:lnRef idx="1">
+            <a:schemeClr val="accent1"/>
+          </a:lnRef>
+          <a:fillRef idx="3">
+            <a:schemeClr val="accent1"/>
+          </a:fillRef>
+          <a:effectRef idx="2">
+            <a:schemeClr val="accent1"/>
+          </a:effectRef>
+          <a:fontRef idx="minor">
+            <a:schemeClr val="lt1"/>
+          </a:fontRef>
+        </p:style>
+        <p:txBody>
+          <a:bodyPr rtlCol="0" anchor="ctr"/>
+          <a:lstStyle/>
+          <a:p>
+            <a:pPr algn="ctr"/>
+          </a:p>
+        </p:txBody>
+      </p:sp>
+      <p:sp>
+        <p:nvSpPr>
+          <p:cNvPr id="13" name="TextBox 12"/>
+          <p:cNvSpPr txBox="1"/>
+          <p:nvPr/>
+        </p:nvSpPr>
+        <p:spPr>
+          <a:xfrm>
+            <a:off x="4663440" y="3977639"/>
+            <a:ext cx="2926080" cy="365760"/>
+          </a:xfrm>
+          <a:prstGeom prst="rect">
+            <a:avLst/>
+          </a:prstGeom>
+          <a:noFill/>
+        </p:spPr>
+        <p:txBody>
+          <a:bodyPr wrap="square">
+            <a:spAutoFit/>
+          </a:bodyPr>
+          <a:lstStyle/>
+          <a:p>
             <a:pPr algn="ctr">
-              <a:defRPr sz="1800"/>
+              <a:defRPr sz="1300" b="0">
+                <a:solidFill>
+                  <a:srgbClr val="757575"/>
+                </a:solidFill>
+                <a:latin typeface="Calibri"/>
+              </a:defRPr>
             </a:pPr>
             <a:r>
-              <a:t>16 tarefas concluídas</a:t>
+              <a:t>Pendentes</a:t>
+            </a:r>
+          </a:p>
+        </p:txBody>
+      </p:sp>
+      <p:sp>
+        <p:nvSpPr>
+          <p:cNvPr id="14" name="TextBox 13"/>
+          <p:cNvSpPr txBox="1"/>
+          <p:nvPr/>
+        </p:nvSpPr>
+        <p:spPr>
+          <a:xfrm>
+            <a:off x="4663440" y="4389120"/>
+            <a:ext cx="2926080" cy="914400"/>
+          </a:xfrm>
+          <a:prstGeom prst="rect">
+            <a:avLst/>
+          </a:prstGeom>
+          <a:noFill/>
+        </p:spPr>
+        <p:txBody>
+          <a:bodyPr wrap="square">
+            <a:spAutoFit/>
+          </a:bodyPr>
+          <a:lstStyle/>
+          <a:p>
+            <a:pPr algn="ctr">
+              <a:defRPr sz="5200" b="1">
+                <a:solidFill>
+                  <a:srgbClr val="212121"/>
+                </a:solidFill>
+                <a:latin typeface="Calibri"/>
+              </a:defRPr>
+            </a:pPr>
+            <a:r>
+              <a:t>10</a:t>
+            </a:r>
+          </a:p>
+        </p:txBody>
+      </p:sp>
+      <p:sp>
+        <p:nvSpPr>
+          <p:cNvPr id="15" name="Rectangle 14"/>
+          <p:cNvSpPr/>
+          <p:nvPr/>
+        </p:nvSpPr>
+        <p:spPr>
+          <a:xfrm>
+            <a:off x="8412480" y="3840480"/>
+            <a:ext cx="2926080" cy="1828800"/>
+          </a:xfrm>
+          <a:prstGeom prst="rect">
+            <a:avLst/>
+          </a:prstGeom>
+          <a:solidFill>
+            <a:srgbClr val="F5F5F5"/>
+          </a:solidFill>
+          <a:ln>
+            <a:noFill/>
+          </a:ln>
+        </p:spPr>
+        <p:style>
+          <a:lnRef idx="1">
+            <a:schemeClr val="accent1"/>
+          </a:lnRef>
+          <a:fillRef idx="3">
+            <a:schemeClr val="accent1"/>
+          </a:fillRef>
+          <a:effectRef idx="2">
+            <a:schemeClr val="accent1"/>
+          </a:effectRef>
+          <a:fontRef idx="minor">
+            <a:schemeClr val="lt1"/>
+          </a:fontRef>
+        </p:style>
+        <p:txBody>
+          <a:bodyPr rtlCol="0" anchor="ctr"/>
+          <a:lstStyle/>
+          <a:p>
+            <a:pPr algn="ctr"/>
+          </a:p>
+        </p:txBody>
+      </p:sp>
+      <p:sp>
+        <p:nvSpPr>
+          <p:cNvPr id="16" name="TextBox 15"/>
+          <p:cNvSpPr txBox="1"/>
+          <p:nvPr/>
+        </p:nvSpPr>
+        <p:spPr>
+          <a:xfrm>
+            <a:off x="8412480" y="3977639"/>
+            <a:ext cx="2926080" cy="365760"/>
+          </a:xfrm>
+          <a:prstGeom prst="rect">
+            <a:avLst/>
+          </a:prstGeom>
+          <a:noFill/>
+        </p:spPr>
+        <p:txBody>
+          <a:bodyPr wrap="square">
+            <a:spAutoFit/>
+          </a:bodyPr>
+          <a:lstStyle/>
+          <a:p>
+            <a:pPr algn="ctr">
+              <a:defRPr sz="1300" b="0">
+                <a:solidFill>
+                  <a:srgbClr val="757575"/>
+                </a:solidFill>
+                <a:latin typeface="Calibri"/>
+              </a:defRPr>
+            </a:pPr>
+            <a:r>
+              <a:t>Incidentes</a:t>
+            </a:r>
+          </a:p>
+        </p:txBody>
+      </p:sp>
+      <p:sp>
+        <p:nvSpPr>
+          <p:cNvPr id="17" name="TextBox 16"/>
+          <p:cNvSpPr txBox="1"/>
+          <p:nvPr/>
+        </p:nvSpPr>
+        <p:spPr>
+          <a:xfrm>
+            <a:off x="8412480" y="4389120"/>
+            <a:ext cx="2926080" cy="914400"/>
+          </a:xfrm>
+          <a:prstGeom prst="rect">
+            <a:avLst/>
+          </a:prstGeom>
+          <a:noFill/>
+        </p:spPr>
+        <p:txBody>
+          <a:bodyPr wrap="square">
+            <a:spAutoFit/>
+          </a:bodyPr>
+          <a:lstStyle/>
+          <a:p>
+            <a:pPr algn="ctr">
+              <a:defRPr sz="5200" b="1">
+                <a:solidFill>
+                  <a:srgbClr val="212121"/>
+                </a:solidFill>
+                <a:latin typeface="Calibri"/>
+              </a:defRPr>
+            </a:pPr>
+            <a:r>
+              <a:t>1</a:t>
+            </a:r>
+          </a:p>
+        </p:txBody>
+      </p:sp>
+      <p:sp>
+        <p:nvSpPr>
+          <p:cNvPr id="18" name="Rectangle 17"/>
+          <p:cNvSpPr/>
+          <p:nvPr/>
+        </p:nvSpPr>
+        <p:spPr>
+          <a:xfrm>
+            <a:off x="0" y="6309360"/>
+            <a:ext cx="12191695" cy="548640"/>
+          </a:xfrm>
+          <a:prstGeom prst="rect">
+            <a:avLst/>
+          </a:prstGeom>
+          <a:solidFill>
+            <a:srgbClr val="F5F5F5"/>
+          </a:solidFill>
+          <a:ln>
+            <a:noFill/>
+          </a:ln>
+        </p:spPr>
+        <p:style>
+          <a:lnRef idx="1">
+            <a:schemeClr val="accent1"/>
+          </a:lnRef>
+          <a:fillRef idx="3">
+            <a:schemeClr val="accent1"/>
+          </a:fillRef>
+          <a:effectRef idx="2">
+            <a:schemeClr val="accent1"/>
+          </a:effectRef>
+          <a:fontRef idx="minor">
+            <a:schemeClr val="lt1"/>
+          </a:fontRef>
+        </p:style>
+        <p:txBody>
+          <a:bodyPr rtlCol="0" anchor="ctr"/>
+          <a:lstStyle/>
+          <a:p>
+            <a:pPr algn="ctr"/>
+          </a:p>
+        </p:txBody>
+      </p:sp>
+      <p:sp>
+        <p:nvSpPr>
+          <p:cNvPr id="19" name="TextBox 18"/>
+          <p:cNvSpPr txBox="1"/>
+          <p:nvPr/>
+        </p:nvSpPr>
+        <p:spPr>
+          <a:xfrm>
+            <a:off x="914400" y="6355080"/>
+            <a:ext cx="10058400" cy="365760"/>
+          </a:xfrm>
+          <a:prstGeom prst="rect">
+            <a:avLst/>
+          </a:prstGeom>
+          <a:noFill/>
+        </p:spPr>
+        <p:txBody>
+          <a:bodyPr wrap="square">
+            <a:spAutoFit/>
+          </a:bodyPr>
+          <a:lstStyle/>
+          <a:p>
+            <a:pPr algn="ctr">
+              <a:defRPr sz="1000" b="0">
+                <a:solidFill>
+                  <a:srgbClr val="757575"/>
+                </a:solidFill>
+                <a:latin typeface="Calibri"/>
+              </a:defRPr>
+            </a:pPr>
+            <a:r>
+              <a:t>FUNFARME — Fundação Faculdade Regional de Medicina · São José do Rio Preto — SP</a:t>
             </a:r>
           </a:p>
         </p:txBody>
@@ -3160,14 +3780,100 @@
       <p:grpSpPr/>
       <p:sp>
         <p:nvSpPr>
-          <p:cNvPr id="2" name="TextBox 1"/>
+          <p:cNvPr id="2" name="Rectangle 1"/>
+          <p:cNvSpPr/>
+          <p:nvPr/>
+        </p:nvSpPr>
+        <p:spPr>
+          <a:xfrm>
+            <a:off x="0" y="0"/>
+            <a:ext cx="12191695" cy="1005840"/>
+          </a:xfrm>
+          <a:prstGeom prst="rect">
+            <a:avLst/>
+          </a:prstGeom>
+          <a:solidFill>
+            <a:srgbClr val="00897B"/>
+          </a:solidFill>
+          <a:ln>
+            <a:noFill/>
+          </a:ln>
+        </p:spPr>
+        <p:style>
+          <a:lnRef idx="1">
+            <a:schemeClr val="accent1"/>
+          </a:lnRef>
+          <a:fillRef idx="3">
+            <a:schemeClr val="accent1"/>
+          </a:fillRef>
+          <a:effectRef idx="2">
+            <a:schemeClr val="accent1"/>
+          </a:effectRef>
+          <a:fontRef idx="minor">
+            <a:schemeClr val="lt1"/>
+          </a:fontRef>
+        </p:style>
+        <p:txBody>
+          <a:bodyPr rtlCol="0" anchor="ctr"/>
+          <a:lstStyle/>
+          <a:p>
+            <a:pPr algn="ctr"/>
+          </a:p>
+        </p:txBody>
+      </p:sp>
+      <p:sp>
+        <p:nvSpPr>
+          <p:cNvPr id="3" name="Rectangle 2"/>
+          <p:cNvSpPr/>
+          <p:nvPr/>
+        </p:nvSpPr>
+        <p:spPr>
+          <a:xfrm>
+            <a:off x="0" y="1005840"/>
+            <a:ext cx="12191695" cy="36576"/>
+          </a:xfrm>
+          <a:prstGeom prst="rect">
+            <a:avLst/>
+          </a:prstGeom>
+          <a:solidFill>
+            <a:srgbClr val="00BCD4"/>
+          </a:solidFill>
+          <a:ln>
+            <a:noFill/>
+          </a:ln>
+        </p:spPr>
+        <p:style>
+          <a:lnRef idx="1">
+            <a:schemeClr val="accent1"/>
+          </a:lnRef>
+          <a:fillRef idx="3">
+            <a:schemeClr val="accent1"/>
+          </a:fillRef>
+          <a:effectRef idx="2">
+            <a:schemeClr val="accent1"/>
+          </a:effectRef>
+          <a:fontRef idx="minor">
+            <a:schemeClr val="lt1"/>
+          </a:fontRef>
+        </p:style>
+        <p:txBody>
+          <a:bodyPr rtlCol="0" anchor="ctr"/>
+          <a:lstStyle/>
+          <a:p>
+            <a:pPr algn="ctr"/>
+          </a:p>
+        </p:txBody>
+      </p:sp>
+      <p:sp>
+        <p:nvSpPr>
+          <p:cNvPr id="4" name="TextBox 3"/>
           <p:cNvSpPr txBox="1"/>
           <p:nvPr/>
         </p:nvSpPr>
         <p:spPr>
           <a:xfrm>
-            <a:off x="457200" y="274320"/>
-            <a:ext cx="10972800" cy="731520"/>
+            <a:off x="731520" y="228600"/>
+            <a:ext cx="9144000" cy="548640"/>
           </a:xfrm>
           <a:prstGeom prst="rect">
             <a:avLst/>
@@ -3175,13 +3881,18 @@
           <a:noFill/>
         </p:spPr>
         <p:txBody>
-          <a:bodyPr wrap="none">
+          <a:bodyPr wrap="square">
             <a:spAutoFit/>
           </a:bodyPr>
           <a:lstStyle/>
           <a:p>
-            <a:pPr>
-              <a:defRPr sz="2800" b="1"/>
+            <a:pPr algn="l">
+              <a:defRPr sz="2800" b="1">
+                <a:solidFill>
+                  <a:srgbClr val="FFFFFF"/>
+                </a:solidFill>
+                <a:latin typeface="Calibri"/>
+              </a:defRPr>
             </a:pPr>
             <a:r>
               <a:t>Resumo por Categoria</a:t>
@@ -3189,16 +3900,40 @@
           </a:p>
         </p:txBody>
       </p:sp>
-      <p:sp>
-        <p:nvSpPr>
-          <p:cNvPr id="3" name="TextBox 2"/>
+      <p:pic>
+        <p:nvPicPr>
+          <p:cNvPr id="5" name="Picture 4" descr="nti.png"/>
+          <p:cNvPicPr>
+            <a:picLocks noChangeAspect="1"/>
+          </p:cNvPicPr>
+          <p:nvPr/>
+        </p:nvPicPr>
+        <p:blipFill>
+          <a:blip r:embed="rId2"/>
+          <a:stretch>
+            <a:fillRect/>
+          </a:stretch>
+        </p:blipFill>
+        <p:spPr>
+          <a:xfrm>
+            <a:off x="10241280" y="182880"/>
+            <a:ext cx="1626669" cy="594360"/>
+          </a:xfrm>
+          <a:prstGeom prst="rect">
+            <a:avLst/>
+          </a:prstGeom>
+        </p:spPr>
+      </p:pic>
+      <p:sp>
+        <p:nvSpPr>
+          <p:cNvPr id="6" name="TextBox 5"/>
           <p:cNvSpPr txBox="1"/>
           <p:nvPr/>
         </p:nvSpPr>
         <p:spPr>
           <a:xfrm>
-            <a:off x="914400" y="1188720"/>
-            <a:ext cx="9144000" cy="411480"/>
+            <a:off x="731520" y="1463040"/>
+            <a:ext cx="10058400" cy="4572000"/>
           </a:xfrm>
           <a:prstGeom prst="rect">
             <a:avLst/>
@@ -3206,30 +3941,80 @@
           <a:noFill/>
         </p:spPr>
         <p:txBody>
-          <a:bodyPr wrap="none">
+          <a:bodyPr wrap="square">
             <a:spAutoFit/>
           </a:bodyPr>
           <a:lstStyle/>
           <a:p>
-            <a:pPr>
-              <a:defRPr sz="1800"/>
+            <a:pPr algn="l">
+              <a:defRPr sz="1600" b="0">
+                <a:solidFill>
+                  <a:srgbClr val="212121"/>
+                </a:solidFill>
+                <a:latin typeface="Calibri"/>
+              </a:defRPr>
             </a:pPr>
             <a:r>
-              <a:t>Shift LIS: 15 tarefas</a:t>
-            </a:r>
-          </a:p>
-        </p:txBody>
-      </p:sp>
-      <p:sp>
-        <p:nvSpPr>
-          <p:cNvPr id="4" name="TextBox 3"/>
+              <a:t>Shift LIS: 15 tarefas
+Shift Automação: 1 tarefa
+Total: 16</a:t>
+            </a:r>
+          </a:p>
+        </p:txBody>
+      </p:sp>
+      <p:sp>
+        <p:nvSpPr>
+          <p:cNvPr id="7" name="Rectangle 6"/>
+          <p:cNvSpPr/>
+          <p:nvPr/>
+        </p:nvSpPr>
+        <p:spPr>
+          <a:xfrm>
+            <a:off x="0" y="6309360"/>
+            <a:ext cx="12191695" cy="548640"/>
+          </a:xfrm>
+          <a:prstGeom prst="rect">
+            <a:avLst/>
+          </a:prstGeom>
+          <a:solidFill>
+            <a:srgbClr val="F5F5F5"/>
+          </a:solidFill>
+          <a:ln>
+            <a:noFill/>
+          </a:ln>
+        </p:spPr>
+        <p:style>
+          <a:lnRef idx="1">
+            <a:schemeClr val="accent1"/>
+          </a:lnRef>
+          <a:fillRef idx="3">
+            <a:schemeClr val="accent1"/>
+          </a:fillRef>
+          <a:effectRef idx="2">
+            <a:schemeClr val="accent1"/>
+          </a:effectRef>
+          <a:fontRef idx="minor">
+            <a:schemeClr val="lt1"/>
+          </a:fontRef>
+        </p:style>
+        <p:txBody>
+          <a:bodyPr rtlCol="0" anchor="ctr"/>
+          <a:lstStyle/>
+          <a:p>
+            <a:pPr algn="ctr"/>
+          </a:p>
+        </p:txBody>
+      </p:sp>
+      <p:sp>
+        <p:nvSpPr>
+          <p:cNvPr id="8" name="TextBox 7"/>
           <p:cNvSpPr txBox="1"/>
           <p:nvPr/>
         </p:nvSpPr>
         <p:spPr>
           <a:xfrm>
-            <a:off x="914400" y="1645920"/>
-            <a:ext cx="9144000" cy="411480"/>
+            <a:off x="731520" y="6355080"/>
+            <a:ext cx="4572000" cy="365760"/>
           </a:xfrm>
           <a:prstGeom prst="rect">
             <a:avLst/>
@@ -3237,30 +4022,35 @@
           <a:noFill/>
         </p:spPr>
         <p:txBody>
-          <a:bodyPr wrap="none">
+          <a:bodyPr wrap="square">
             <a:spAutoFit/>
           </a:bodyPr>
           <a:lstStyle/>
           <a:p>
-            <a:pPr>
-              <a:defRPr sz="1800"/>
+            <a:pPr algn="l">
+              <a:defRPr sz="1000" b="0">
+                <a:solidFill>
+                  <a:srgbClr val="757575"/>
+                </a:solidFill>
+                <a:latin typeface="Calibri"/>
+              </a:defRPr>
             </a:pPr>
             <a:r>
-              <a:t>Shift Automação: 1 tarefa</a:t>
-            </a:r>
-          </a:p>
-        </p:txBody>
-      </p:sp>
-      <p:sp>
-        <p:nvSpPr>
-          <p:cNvPr id="5" name="TextBox 4"/>
+              <a:t>Junho 2026</a:t>
+            </a:r>
+          </a:p>
+        </p:txBody>
+      </p:sp>
+      <p:sp>
+        <p:nvSpPr>
+          <p:cNvPr id="9" name="TextBox 8"/>
           <p:cNvSpPr txBox="1"/>
           <p:nvPr/>
         </p:nvSpPr>
         <p:spPr>
           <a:xfrm>
-            <a:off x="914400" y="2286000"/>
-            <a:ext cx="9144000" cy="457200"/>
+            <a:off x="6400800" y="6355080"/>
+            <a:ext cx="5029200" cy="365760"/>
           </a:xfrm>
           <a:prstGeom prst="rect">
             <a:avLst/>
@@ -3268,16 +4058,21 @@
           <a:noFill/>
         </p:spPr>
         <p:txBody>
-          <a:bodyPr wrap="none">
+          <a:bodyPr wrap="square">
             <a:spAutoFit/>
           </a:bodyPr>
           <a:lstStyle/>
           <a:p>
-            <a:pPr>
-              <a:defRPr sz="2000" b="1"/>
+            <a:pPr algn="r">
+              <a:defRPr sz="1000" b="0">
+                <a:solidFill>
+                  <a:srgbClr val="757575"/>
+                </a:solidFill>
+                <a:latin typeface="Calibri"/>
+              </a:defRPr>
             </a:pPr>
             <a:r>
-              <a:t>Total: 16</a:t>
+              <a:t>TI Laboratório — FUNFARME</a:t>
             </a:r>
           </a:p>
         </p:txBody>
@@ -3302,45 +4097,100 @@
       <p:grpSpPr/>
       <p:sp>
         <p:nvSpPr>
-          <p:cNvPr id="2" name="TextBox 1"/>
+          <p:cNvPr id="2" name="Rectangle 1"/>
+          <p:cNvSpPr/>
+          <p:nvPr/>
+        </p:nvSpPr>
+        <p:spPr>
+          <a:xfrm>
+            <a:off x="0" y="0"/>
+            <a:ext cx="12191695" cy="1005840"/>
+          </a:xfrm>
+          <a:prstGeom prst="rect">
+            <a:avLst/>
+          </a:prstGeom>
+          <a:solidFill>
+            <a:srgbClr val="00897B"/>
+          </a:solidFill>
+          <a:ln>
+            <a:noFill/>
+          </a:ln>
+        </p:spPr>
+        <p:style>
+          <a:lnRef idx="1">
+            <a:schemeClr val="accent1"/>
+          </a:lnRef>
+          <a:fillRef idx="3">
+            <a:schemeClr val="accent1"/>
+          </a:fillRef>
+          <a:effectRef idx="2">
+            <a:schemeClr val="accent1"/>
+          </a:effectRef>
+          <a:fontRef idx="minor">
+            <a:schemeClr val="lt1"/>
+          </a:fontRef>
+        </p:style>
+        <p:txBody>
+          <a:bodyPr rtlCol="0" anchor="ctr"/>
+          <a:lstStyle/>
+          <a:p>
+            <a:pPr algn="ctr"/>
+          </a:p>
+        </p:txBody>
+      </p:sp>
+      <p:sp>
+        <p:nvSpPr>
+          <p:cNvPr id="3" name="Rectangle 2"/>
+          <p:cNvSpPr/>
+          <p:nvPr/>
+        </p:nvSpPr>
+        <p:spPr>
+          <a:xfrm>
+            <a:off x="0" y="1005840"/>
+            <a:ext cx="12191695" cy="36576"/>
+          </a:xfrm>
+          <a:prstGeom prst="rect">
+            <a:avLst/>
+          </a:prstGeom>
+          <a:solidFill>
+            <a:srgbClr val="00BCD4"/>
+          </a:solidFill>
+          <a:ln>
+            <a:noFill/>
+          </a:ln>
+        </p:spPr>
+        <p:style>
+          <a:lnRef idx="1">
+            <a:schemeClr val="accent1"/>
+          </a:lnRef>
+          <a:fillRef idx="3">
+            <a:schemeClr val="accent1"/>
+          </a:fillRef>
+          <a:effectRef idx="2">
+            <a:schemeClr val="accent1"/>
+          </a:effectRef>
+          <a:fontRef idx="minor">
+            <a:schemeClr val="lt1"/>
+          </a:fontRef>
+        </p:style>
+        <p:txBody>
+          <a:bodyPr rtlCol="0" anchor="ctr"/>
+          <a:lstStyle/>
+          <a:p>
+            <a:pPr algn="ctr"/>
+          </a:p>
+        </p:txBody>
+      </p:sp>
+      <p:sp>
+        <p:nvSpPr>
+          <p:cNvPr id="4" name="TextBox 3"/>
           <p:cNvSpPr txBox="1"/>
           <p:nvPr/>
         </p:nvSpPr>
         <p:spPr>
           <a:xfrm>
-            <a:off x="457200" y="274320"/>
-            <a:ext cx="10972800" cy="731520"/>
-          </a:xfrm>
-          <a:prstGeom prst="rect">
-            <a:avLst/>
-          </a:prstGeom>
-          <a:noFill/>
-        </p:spPr>
-        <p:txBody>
-          <a:bodyPr wrap="none">
-            <a:spAutoFit/>
-          </a:bodyPr>
-          <a:lstStyle/>
-          <a:p>
-            <a:pPr>
-              <a:defRPr sz="2400" b="1"/>
-            </a:pPr>
-            <a:r>
-              <a:t>Shift LIS (15)</a:t>
-            </a:r>
-          </a:p>
-        </p:txBody>
-      </p:sp>
-      <p:sp>
-        <p:nvSpPr>
-          <p:cNvPr id="3" name="TextBox 2"/>
-          <p:cNvSpPr txBox="1"/>
-          <p:nvPr/>
-        </p:nvSpPr>
-        <p:spPr>
-          <a:xfrm>
-            <a:off x="731520" y="1188720"/>
-            <a:ext cx="10058400" cy="5029200"/>
+            <a:off x="731520" y="228600"/>
+            <a:ext cx="9144000" cy="548640"/>
           </a:xfrm>
           <a:prstGeom prst="rect">
             <a:avLst/>
@@ -3353,168 +4203,194 @@
           </a:bodyPr>
           <a:lstStyle/>
           <a:p>
-            <a:pPr>
-              <a:spcAft>
-                <a:spcPts val="400"/>
-              </a:spcAft>
-              <a:defRPr sz="1400"/>
+            <a:pPr algn="l">
+              <a:defRPr sz="2800" b="1">
+                <a:solidFill>
+                  <a:srgbClr val="FFFFFF"/>
+                </a:solidFill>
+                <a:latin typeface="Calibri"/>
+              </a:defRPr>
             </a:pPr>
             <a:r>
-              <a:t>• Máscara SDHEA (01/06)</a:t>
-            </a:r>
-          </a:p>
-          <a:p>
-            <a:pPr>
-              <a:spcAft>
-                <a:spcPts val="400"/>
-              </a:spcAft>
-              <a:defRPr sz="1400"/>
+              <a:t>Distribuição Semanal</a:t>
+            </a:r>
+          </a:p>
+        </p:txBody>
+      </p:sp>
+      <p:pic>
+        <p:nvPicPr>
+          <p:cNvPr id="5" name="Picture 4" descr="nti.png"/>
+          <p:cNvPicPr>
+            <a:picLocks noChangeAspect="1"/>
+          </p:cNvPicPr>
+          <p:nvPr/>
+        </p:nvPicPr>
+        <p:blipFill>
+          <a:blip r:embed="rId2"/>
+          <a:stretch>
+            <a:fillRect/>
+          </a:stretch>
+        </p:blipFill>
+        <p:spPr>
+          <a:xfrm>
+            <a:off x="10241280" y="182880"/>
+            <a:ext cx="1626669" cy="594360"/>
+          </a:xfrm>
+          <a:prstGeom prst="rect">
+            <a:avLst/>
+          </a:prstGeom>
+        </p:spPr>
+      </p:pic>
+      <p:sp>
+        <p:nvSpPr>
+          <p:cNvPr id="6" name="TextBox 5"/>
+          <p:cNvSpPr txBox="1"/>
+          <p:nvPr/>
+        </p:nvSpPr>
+        <p:spPr>
+          <a:xfrm>
+            <a:off x="731520" y="1463040"/>
+            <a:ext cx="10058400" cy="4572000"/>
+          </a:xfrm>
+          <a:prstGeom prst="rect">
+            <a:avLst/>
+          </a:prstGeom>
+          <a:noFill/>
+        </p:spPr>
+        <p:txBody>
+          <a:bodyPr wrap="square">
+            <a:spAutoFit/>
+          </a:bodyPr>
+          <a:lstStyle/>
+          <a:p>
+            <a:pPr algn="l">
+              <a:defRPr sz="1600" b="0">
+                <a:solidFill>
+                  <a:srgbClr val="212121"/>
+                </a:solidFill>
+                <a:latin typeface="Calibri"/>
+              </a:defRPr>
             </a:pPr>
             <a:r>
-              <a:t>• Máscara ANFETUR (01/06)</a:t>
-            </a:r>
-          </a:p>
-          <a:p>
-            <a:pPr>
-              <a:spcAft>
-                <a:spcPts val="400"/>
-              </a:spcAft>
-              <a:defRPr sz="1400"/>
+              <a:t>Semana 1 (01/06–07/06): 3 tarefas
+Semana 2 (08/06–14/06): 5 tarefas
+Semana 3 (15/06–21/06): 8 tarefas
+</a:t>
+            </a:r>
+          </a:p>
+        </p:txBody>
+      </p:sp>
+      <p:sp>
+        <p:nvSpPr>
+          <p:cNvPr id="7" name="Rectangle 6"/>
+          <p:cNvSpPr/>
+          <p:nvPr/>
+        </p:nvSpPr>
+        <p:spPr>
+          <a:xfrm>
+            <a:off x="0" y="6309360"/>
+            <a:ext cx="12191695" cy="548640"/>
+          </a:xfrm>
+          <a:prstGeom prst="rect">
+            <a:avLst/>
+          </a:prstGeom>
+          <a:solidFill>
+            <a:srgbClr val="F5F5F5"/>
+          </a:solidFill>
+          <a:ln>
+            <a:noFill/>
+          </a:ln>
+        </p:spPr>
+        <p:style>
+          <a:lnRef idx="1">
+            <a:schemeClr val="accent1"/>
+          </a:lnRef>
+          <a:fillRef idx="3">
+            <a:schemeClr val="accent1"/>
+          </a:fillRef>
+          <a:effectRef idx="2">
+            <a:schemeClr val="accent1"/>
+          </a:effectRef>
+          <a:fontRef idx="minor">
+            <a:schemeClr val="lt1"/>
+          </a:fontRef>
+        </p:style>
+        <p:txBody>
+          <a:bodyPr rtlCol="0" anchor="ctr"/>
+          <a:lstStyle/>
+          <a:p>
+            <a:pPr algn="ctr"/>
+          </a:p>
+        </p:txBody>
+      </p:sp>
+      <p:sp>
+        <p:nvSpPr>
+          <p:cNvPr id="8" name="TextBox 7"/>
+          <p:cNvSpPr txBox="1"/>
+          <p:nvPr/>
+        </p:nvSpPr>
+        <p:spPr>
+          <a:xfrm>
+            <a:off x="731520" y="6355080"/>
+            <a:ext cx="4572000" cy="365760"/>
+          </a:xfrm>
+          <a:prstGeom prst="rect">
+            <a:avLst/>
+          </a:prstGeom>
+          <a:noFill/>
+        </p:spPr>
+        <p:txBody>
+          <a:bodyPr wrap="square">
+            <a:spAutoFit/>
+          </a:bodyPr>
+          <a:lstStyle/>
+          <a:p>
+            <a:pPr algn="l">
+              <a:defRPr sz="1000" b="0">
+                <a:solidFill>
+                  <a:srgbClr val="757575"/>
+                </a:solidFill>
+                <a:latin typeface="Calibri"/>
+              </a:defRPr>
             </a:pPr>
             <a:r>
-              <a:t>• Máscara PQUINASE (03/06)</a:t>
-            </a:r>
-          </a:p>
-          <a:p>
-            <a:pPr>
-              <a:spcAft>
-                <a:spcPts val="400"/>
-              </a:spcAft>
-              <a:defRPr sz="1400"/>
+              <a:t>Junho 2026</a:t>
+            </a:r>
+          </a:p>
+        </p:txBody>
+      </p:sp>
+      <p:sp>
+        <p:nvSpPr>
+          <p:cNvPr id="9" name="TextBox 8"/>
+          <p:cNvSpPr txBox="1"/>
+          <p:nvPr/>
+        </p:nvSpPr>
+        <p:spPr>
+          <a:xfrm>
+            <a:off x="6400800" y="6355080"/>
+            <a:ext cx="5029200" cy="365760"/>
+          </a:xfrm>
+          <a:prstGeom prst="rect">
+            <a:avLst/>
+          </a:prstGeom>
+          <a:noFill/>
+        </p:spPr>
+        <p:txBody>
+          <a:bodyPr wrap="square">
+            <a:spAutoFit/>
+          </a:bodyPr>
+          <a:lstStyle/>
+          <a:p>
+            <a:pPr algn="r">
+              <a:defRPr sz="1000" b="0">
+                <a:solidFill>
+                  <a:srgbClr val="757575"/>
+                </a:solidFill>
+                <a:latin typeface="Calibri"/>
+              </a:defRPr>
             </a:pPr>
             <a:r>
-              <a:t>• Máscara OSMOUR (09/06)</a:t>
-            </a:r>
-          </a:p>
-          <a:p>
-            <a:pPr>
-              <a:spcAft>
-                <a:spcPts val="400"/>
-              </a:spcAft>
-              <a:defRPr sz="1400"/>
-            </a:pPr>
-            <a:r>
-              <a:t>• Máscara EBETV1 (09/06)</a:t>
-            </a:r>
-          </a:p>
-          <a:p>
-            <a:pPr>
-              <a:spcAft>
-                <a:spcPts val="400"/>
-              </a:spcAft>
-              <a:defRPr sz="1400"/>
-            </a:pPr>
-            <a:r>
-              <a:t>• Máscara BCRT315I (12/06)</a:t>
-            </a:r>
-          </a:p>
-          <a:p>
-            <a:pPr>
-              <a:spcAft>
-                <a:spcPts val="400"/>
-              </a:spcAft>
-              <a:defRPr sz="1400"/>
-            </a:pPr>
-            <a:r>
-              <a:t>• Máscara DEMPARK — Fleury / inativo MV (12/06)</a:t>
-            </a:r>
-          </a:p>
-          <a:p>
-            <a:pPr>
-              <a:spcAft>
-                <a:spcPts val="400"/>
-              </a:spcAft>
-              <a:defRPr sz="1400"/>
-            </a:pPr>
-            <a:r>
-              <a:t>• Máscara LIPODIS — Fleury / inativo MV (12/06)</a:t>
-            </a:r>
-          </a:p>
-          <a:p>
-            <a:pPr>
-              <a:spcAft>
-                <a:spcPts val="400"/>
-              </a:spcAft>
-              <a:defRPr sz="1400"/>
-            </a:pPr>
-            <a:r>
-              <a:t>• Máscara CBFB (15/06)</a:t>
-            </a:r>
-          </a:p>
-          <a:p>
-            <a:pPr>
-              <a:spcAft>
-                <a:spcPts val="400"/>
-              </a:spcAft>
-              <a:defRPr sz="1400"/>
-            </a:pPr>
-            <a:r>
-              <a:t>• Máscara M1 (15/06)</a:t>
-            </a:r>
-          </a:p>
-          <a:p>
-            <a:pPr>
-              <a:spcAft>
-                <a:spcPts val="400"/>
-              </a:spcAft>
-              <a:defRPr sz="1400"/>
-            </a:pPr>
-            <a:r>
-              <a:t>• Máscara VIT125 (17/06)</a:t>
-            </a:r>
-          </a:p>
-          <a:p>
-            <a:pPr>
-              <a:spcAft>
-                <a:spcPts val="400"/>
-              </a:spcAft>
-              <a:defRPr sz="1400"/>
-            </a:pPr>
-            <a:r>
-              <a:t>• Máscara C3 (17/06)</a:t>
-            </a:r>
-          </a:p>
-          <a:p>
-            <a:pPr>
-              <a:spcAft>
-                <a:spcPts val="400"/>
-              </a:spcAft>
-              <a:defRPr sz="1400"/>
-            </a:pPr>
-            <a:r>
-              <a:t>• Máscara PEPI (17/06)</a:t>
-            </a:r>
-          </a:p>
-          <a:p>
-            <a:pPr>
-              <a:spcAft>
-                <a:spcPts val="400"/>
-              </a:spcAft>
-              <a:defRPr sz="1400"/>
-            </a:pPr>
-            <a:r>
-              <a:t>• Máscara COQ10 (17/06)</a:t>
-            </a:r>
-          </a:p>
-          <a:p>
-            <a:pPr>
-              <a:spcAft>
-                <a:spcPts val="400"/>
-              </a:spcAft>
-              <a:defRPr sz="1400"/>
-            </a:pPr>
-            <a:r>
-              <a:t>• Máscara DOEIMU (18/06)</a:t>
+              <a:t>TI Laboratório — FUNFARME</a:t>
             </a:r>
           </a:p>
         </p:txBody>
@@ -3539,45 +4415,100 @@
       <p:grpSpPr/>
       <p:sp>
         <p:nvSpPr>
-          <p:cNvPr id="2" name="TextBox 1"/>
+          <p:cNvPr id="2" name="Rectangle 1"/>
+          <p:cNvSpPr/>
+          <p:nvPr/>
+        </p:nvSpPr>
+        <p:spPr>
+          <a:xfrm>
+            <a:off x="0" y="0"/>
+            <a:ext cx="12191695" cy="1005840"/>
+          </a:xfrm>
+          <a:prstGeom prst="rect">
+            <a:avLst/>
+          </a:prstGeom>
+          <a:solidFill>
+            <a:srgbClr val="00897B"/>
+          </a:solidFill>
+          <a:ln>
+            <a:noFill/>
+          </a:ln>
+        </p:spPr>
+        <p:style>
+          <a:lnRef idx="1">
+            <a:schemeClr val="accent1"/>
+          </a:lnRef>
+          <a:fillRef idx="3">
+            <a:schemeClr val="accent1"/>
+          </a:fillRef>
+          <a:effectRef idx="2">
+            <a:schemeClr val="accent1"/>
+          </a:effectRef>
+          <a:fontRef idx="minor">
+            <a:schemeClr val="lt1"/>
+          </a:fontRef>
+        </p:style>
+        <p:txBody>
+          <a:bodyPr rtlCol="0" anchor="ctr"/>
+          <a:lstStyle/>
+          <a:p>
+            <a:pPr algn="ctr"/>
+          </a:p>
+        </p:txBody>
+      </p:sp>
+      <p:sp>
+        <p:nvSpPr>
+          <p:cNvPr id="3" name="Rectangle 2"/>
+          <p:cNvSpPr/>
+          <p:nvPr/>
+        </p:nvSpPr>
+        <p:spPr>
+          <a:xfrm>
+            <a:off x="0" y="1005840"/>
+            <a:ext cx="12191695" cy="36576"/>
+          </a:xfrm>
+          <a:prstGeom prst="rect">
+            <a:avLst/>
+          </a:prstGeom>
+          <a:solidFill>
+            <a:srgbClr val="00BCD4"/>
+          </a:solidFill>
+          <a:ln>
+            <a:noFill/>
+          </a:ln>
+        </p:spPr>
+        <p:style>
+          <a:lnRef idx="1">
+            <a:schemeClr val="accent1"/>
+          </a:lnRef>
+          <a:fillRef idx="3">
+            <a:schemeClr val="accent1"/>
+          </a:fillRef>
+          <a:effectRef idx="2">
+            <a:schemeClr val="accent1"/>
+          </a:effectRef>
+          <a:fontRef idx="minor">
+            <a:schemeClr val="lt1"/>
+          </a:fontRef>
+        </p:style>
+        <p:txBody>
+          <a:bodyPr rtlCol="0" anchor="ctr"/>
+          <a:lstStyle/>
+          <a:p>
+            <a:pPr algn="ctr"/>
+          </a:p>
+        </p:txBody>
+      </p:sp>
+      <p:sp>
+        <p:nvSpPr>
+          <p:cNvPr id="4" name="TextBox 3"/>
           <p:cNvSpPr txBox="1"/>
           <p:nvPr/>
         </p:nvSpPr>
         <p:spPr>
           <a:xfrm>
-            <a:off x="457200" y="274320"/>
-            <a:ext cx="10972800" cy="731520"/>
-          </a:xfrm>
-          <a:prstGeom prst="rect">
-            <a:avLst/>
-          </a:prstGeom>
-          <a:noFill/>
-        </p:spPr>
-        <p:txBody>
-          <a:bodyPr wrap="none">
-            <a:spAutoFit/>
-          </a:bodyPr>
-          <a:lstStyle/>
-          <a:p>
-            <a:pPr>
-              <a:defRPr sz="2400" b="1"/>
-            </a:pPr>
-            <a:r>
-              <a:t>Shift Automação (1)</a:t>
-            </a:r>
-          </a:p>
-        </p:txBody>
-      </p:sp>
-      <p:sp>
-        <p:nvSpPr>
-          <p:cNvPr id="3" name="TextBox 2"/>
-          <p:cNvSpPr txBox="1"/>
-          <p:nvPr/>
-        </p:nvSpPr>
-        <p:spPr>
-          <a:xfrm>
-            <a:off x="731520" y="1188720"/>
-            <a:ext cx="10058400" cy="5029200"/>
+            <a:off x="731520" y="228600"/>
+            <a:ext cx="9144000" cy="548640"/>
           </a:xfrm>
           <a:prstGeom prst="rect">
             <a:avLst/>
@@ -3590,14 +4521,205 @@
           </a:bodyPr>
           <a:lstStyle/>
           <a:p>
-            <a:pPr>
-              <a:spcAft>
-                <a:spcPts val="400"/>
-              </a:spcAft>
-              <a:defRPr sz="1400"/>
+            <a:pPr algn="l">
+              <a:defRPr sz="2800" b="1">
+                <a:solidFill>
+                  <a:srgbClr val="FFFFFF"/>
+                </a:solidFill>
+                <a:latin typeface="Calibri"/>
+              </a:defRPr>
             </a:pPr>
             <a:r>
-              <a:t>• ABL-800 — interface do gasômetro do HCM configurada para incorporar resultados de hemoglobinas (18/06)</a:t>
+              <a:t>Shift LIS (15)</a:t>
+            </a:r>
+          </a:p>
+        </p:txBody>
+      </p:sp>
+      <p:pic>
+        <p:nvPicPr>
+          <p:cNvPr id="5" name="Picture 4" descr="nti.png"/>
+          <p:cNvPicPr>
+            <a:picLocks noChangeAspect="1"/>
+          </p:cNvPicPr>
+          <p:nvPr/>
+        </p:nvPicPr>
+        <p:blipFill>
+          <a:blip r:embed="rId2"/>
+          <a:stretch>
+            <a:fillRect/>
+          </a:stretch>
+        </p:blipFill>
+        <p:spPr>
+          <a:xfrm>
+            <a:off x="10241280" y="182880"/>
+            <a:ext cx="1626669" cy="594360"/>
+          </a:xfrm>
+          <a:prstGeom prst="rect">
+            <a:avLst/>
+          </a:prstGeom>
+        </p:spPr>
+      </p:pic>
+      <p:sp>
+        <p:nvSpPr>
+          <p:cNvPr id="6" name="TextBox 5"/>
+          <p:cNvSpPr txBox="1"/>
+          <p:nvPr/>
+        </p:nvSpPr>
+        <p:spPr>
+          <a:xfrm>
+            <a:off x="731520" y="1463040"/>
+            <a:ext cx="10515600" cy="4572000"/>
+          </a:xfrm>
+          <a:prstGeom prst="rect">
+            <a:avLst/>
+          </a:prstGeom>
+          <a:noFill/>
+        </p:spPr>
+        <p:txBody>
+          <a:bodyPr wrap="square">
+            <a:spAutoFit/>
+          </a:bodyPr>
+          <a:lstStyle/>
+          <a:p>
+            <a:pPr algn="l">
+              <a:defRPr sz="1400" b="0">
+                <a:solidFill>
+                  <a:srgbClr val="212121"/>
+                </a:solidFill>
+                <a:latin typeface="Calibri"/>
+              </a:defRPr>
+            </a:pPr>
+            <a:r>
+              <a:t>• Máscara SDHEA (01/06)
+• Máscara ANFETUR (01/06)
+• Máscara PQUINASE (03/06)
+• Máscara OSMOUR (09/06)
+• Máscara EBETV1 (09/06)
+• Máscara BCRT315I (12/06)
+• Máscara DEMPARK — Fleury / inativo MV (12/06)
+• Máscara LIPODIS — Fleury / inativo MV (12/06)
+• Máscara CBFB (15/06)
+• Máscara M1 (15/06)
+• Máscara VIT125 (17/06)
+• Máscara C3 (17/06)
+• Máscara PEPI (17/06)
+• Máscara COQ10 (17/06)
+• Máscara DOEIMU (18/06)</a:t>
+            </a:r>
+          </a:p>
+        </p:txBody>
+      </p:sp>
+      <p:sp>
+        <p:nvSpPr>
+          <p:cNvPr id="7" name="Rectangle 6"/>
+          <p:cNvSpPr/>
+          <p:nvPr/>
+        </p:nvSpPr>
+        <p:spPr>
+          <a:xfrm>
+            <a:off x="0" y="6309360"/>
+            <a:ext cx="12191695" cy="548640"/>
+          </a:xfrm>
+          <a:prstGeom prst="rect">
+            <a:avLst/>
+          </a:prstGeom>
+          <a:solidFill>
+            <a:srgbClr val="F5F5F5"/>
+          </a:solidFill>
+          <a:ln>
+            <a:noFill/>
+          </a:ln>
+        </p:spPr>
+        <p:style>
+          <a:lnRef idx="1">
+            <a:schemeClr val="accent1"/>
+          </a:lnRef>
+          <a:fillRef idx="3">
+            <a:schemeClr val="accent1"/>
+          </a:fillRef>
+          <a:effectRef idx="2">
+            <a:schemeClr val="accent1"/>
+          </a:effectRef>
+          <a:fontRef idx="minor">
+            <a:schemeClr val="lt1"/>
+          </a:fontRef>
+        </p:style>
+        <p:txBody>
+          <a:bodyPr rtlCol="0" anchor="ctr"/>
+          <a:lstStyle/>
+          <a:p>
+            <a:pPr algn="ctr"/>
+          </a:p>
+        </p:txBody>
+      </p:sp>
+      <p:sp>
+        <p:nvSpPr>
+          <p:cNvPr id="8" name="TextBox 7"/>
+          <p:cNvSpPr txBox="1"/>
+          <p:nvPr/>
+        </p:nvSpPr>
+        <p:spPr>
+          <a:xfrm>
+            <a:off x="731520" y="6355080"/>
+            <a:ext cx="4572000" cy="365760"/>
+          </a:xfrm>
+          <a:prstGeom prst="rect">
+            <a:avLst/>
+          </a:prstGeom>
+          <a:noFill/>
+        </p:spPr>
+        <p:txBody>
+          <a:bodyPr wrap="square">
+            <a:spAutoFit/>
+          </a:bodyPr>
+          <a:lstStyle/>
+          <a:p>
+            <a:pPr algn="l">
+              <a:defRPr sz="1000" b="0">
+                <a:solidFill>
+                  <a:srgbClr val="757575"/>
+                </a:solidFill>
+                <a:latin typeface="Calibri"/>
+              </a:defRPr>
+            </a:pPr>
+            <a:r>
+              <a:t>Junho 2026</a:t>
+            </a:r>
+          </a:p>
+        </p:txBody>
+      </p:sp>
+      <p:sp>
+        <p:nvSpPr>
+          <p:cNvPr id="9" name="TextBox 8"/>
+          <p:cNvSpPr txBox="1"/>
+          <p:nvPr/>
+        </p:nvSpPr>
+        <p:spPr>
+          <a:xfrm>
+            <a:off x="6400800" y="6355080"/>
+            <a:ext cx="5029200" cy="365760"/>
+          </a:xfrm>
+          <a:prstGeom prst="rect">
+            <a:avLst/>
+          </a:prstGeom>
+          <a:noFill/>
+        </p:spPr>
+        <p:txBody>
+          <a:bodyPr wrap="square">
+            <a:spAutoFit/>
+          </a:bodyPr>
+          <a:lstStyle/>
+          <a:p>
+            <a:pPr algn="r">
+              <a:defRPr sz="1000" b="0">
+                <a:solidFill>
+                  <a:srgbClr val="757575"/>
+                </a:solidFill>
+                <a:latin typeface="Calibri"/>
+              </a:defRPr>
+            </a:pPr>
+            <a:r>
+              <a:t>TI Laboratório — FUNFARME</a:t>
             </a:r>
           </a:p>
         </p:txBody>
@@ -3622,45 +4744,100 @@
       <p:grpSpPr/>
       <p:sp>
         <p:nvSpPr>
-          <p:cNvPr id="2" name="TextBox 1"/>
+          <p:cNvPr id="2" name="Rectangle 1"/>
+          <p:cNvSpPr/>
+          <p:nvPr/>
+        </p:nvSpPr>
+        <p:spPr>
+          <a:xfrm>
+            <a:off x="0" y="0"/>
+            <a:ext cx="12191695" cy="1005840"/>
+          </a:xfrm>
+          <a:prstGeom prst="rect">
+            <a:avLst/>
+          </a:prstGeom>
+          <a:solidFill>
+            <a:srgbClr val="00897B"/>
+          </a:solidFill>
+          <a:ln>
+            <a:noFill/>
+          </a:ln>
+        </p:spPr>
+        <p:style>
+          <a:lnRef idx="1">
+            <a:schemeClr val="accent1"/>
+          </a:lnRef>
+          <a:fillRef idx="3">
+            <a:schemeClr val="accent1"/>
+          </a:fillRef>
+          <a:effectRef idx="2">
+            <a:schemeClr val="accent1"/>
+          </a:effectRef>
+          <a:fontRef idx="minor">
+            <a:schemeClr val="lt1"/>
+          </a:fontRef>
+        </p:style>
+        <p:txBody>
+          <a:bodyPr rtlCol="0" anchor="ctr"/>
+          <a:lstStyle/>
+          <a:p>
+            <a:pPr algn="ctr"/>
+          </a:p>
+        </p:txBody>
+      </p:sp>
+      <p:sp>
+        <p:nvSpPr>
+          <p:cNvPr id="3" name="Rectangle 2"/>
+          <p:cNvSpPr/>
+          <p:nvPr/>
+        </p:nvSpPr>
+        <p:spPr>
+          <a:xfrm>
+            <a:off x="0" y="1005840"/>
+            <a:ext cx="12191695" cy="36576"/>
+          </a:xfrm>
+          <a:prstGeom prst="rect">
+            <a:avLst/>
+          </a:prstGeom>
+          <a:solidFill>
+            <a:srgbClr val="00BCD4"/>
+          </a:solidFill>
+          <a:ln>
+            <a:noFill/>
+          </a:ln>
+        </p:spPr>
+        <p:style>
+          <a:lnRef idx="1">
+            <a:schemeClr val="accent1"/>
+          </a:lnRef>
+          <a:fillRef idx="3">
+            <a:schemeClr val="accent1"/>
+          </a:fillRef>
+          <a:effectRef idx="2">
+            <a:schemeClr val="accent1"/>
+          </a:effectRef>
+          <a:fontRef idx="minor">
+            <a:schemeClr val="lt1"/>
+          </a:fontRef>
+        </p:style>
+        <p:txBody>
+          <a:bodyPr rtlCol="0" anchor="ctr"/>
+          <a:lstStyle/>
+          <a:p>
+            <a:pPr algn="ctr"/>
+          </a:p>
+        </p:txBody>
+      </p:sp>
+      <p:sp>
+        <p:nvSpPr>
+          <p:cNvPr id="4" name="TextBox 3"/>
           <p:cNvSpPr txBox="1"/>
           <p:nvPr/>
         </p:nvSpPr>
         <p:spPr>
           <a:xfrm>
-            <a:off x="457200" y="274320"/>
-            <a:ext cx="10972800" cy="731520"/>
-          </a:xfrm>
-          <a:prstGeom prst="rect">
-            <a:avLst/>
-          </a:prstGeom>
-          <a:noFill/>
-        </p:spPr>
-        <p:txBody>
-          <a:bodyPr wrap="none">
-            <a:spAutoFit/>
-          </a:bodyPr>
-          <a:lstStyle/>
-          <a:p>
-            <a:pPr>
-              <a:defRPr sz="2400" b="1"/>
-            </a:pPr>
-            <a:r>
-              <a:t>Pendências</a:t>
-            </a:r>
-          </a:p>
-        </p:txBody>
-      </p:sp>
-      <p:sp>
-        <p:nvSpPr>
-          <p:cNvPr id="3" name="TextBox 2"/>
-          <p:cNvSpPr txBox="1"/>
-          <p:nvPr/>
-        </p:nvSpPr>
-        <p:spPr>
-          <a:xfrm>
-            <a:off x="731520" y="1188720"/>
-            <a:ext cx="10058400" cy="5029200"/>
+            <a:off x="731520" y="228600"/>
+            <a:ext cx="9144000" cy="548640"/>
           </a:xfrm>
           <a:prstGeom prst="rect">
             <a:avLst/>
@@ -3673,91 +4850,830 @@
           </a:bodyPr>
           <a:lstStyle/>
           <a:p>
-            <a:pPr>
-              <a:spcAft>
-                <a:spcPts val="400"/>
-              </a:spcAft>
-              <a:defRPr sz="1400"/>
+            <a:pPr algn="l">
+              <a:defRPr sz="2800" b="1">
+                <a:solidFill>
+                  <a:srgbClr val="FFFFFF"/>
+                </a:solidFill>
+                <a:latin typeface="Calibri"/>
+              </a:defRPr>
             </a:pPr>
             <a:r>
-              <a:t>• [Shift Automação] MAX ION 800 — preparação para testes de novo analisador de eletrólitos; verificar sítio de instalação e contatar cliente com interfaceamento configurado</a:t>
-            </a:r>
-          </a:p>
-          <a:p>
-            <a:pPr>
-              <a:spcAft>
-                <a:spcPts val="400"/>
-              </a:spcAft>
-              <a:defRPr sz="1400"/>
+              <a:t>Shift Automação (1)</a:t>
+            </a:r>
+          </a:p>
+        </p:txBody>
+      </p:sp>
+      <p:pic>
+        <p:nvPicPr>
+          <p:cNvPr id="5" name="Picture 4" descr="nti.png"/>
+          <p:cNvPicPr>
+            <a:picLocks noChangeAspect="1"/>
+          </p:cNvPicPr>
+          <p:nvPr/>
+        </p:nvPicPr>
+        <p:blipFill>
+          <a:blip r:embed="rId2"/>
+          <a:stretch>
+            <a:fillRect/>
+          </a:stretch>
+        </p:blipFill>
+        <p:spPr>
+          <a:xfrm>
+            <a:off x="10241280" y="182880"/>
+            <a:ext cx="1626669" cy="594360"/>
+          </a:xfrm>
+          <a:prstGeom prst="rect">
+            <a:avLst/>
+          </a:prstGeom>
+        </p:spPr>
+      </p:pic>
+      <p:sp>
+        <p:nvSpPr>
+          <p:cNvPr id="6" name="TextBox 5"/>
+          <p:cNvSpPr txBox="1"/>
+          <p:nvPr/>
+        </p:nvSpPr>
+        <p:spPr>
+          <a:xfrm>
+            <a:off x="731520" y="1463040"/>
+            <a:ext cx="10515600" cy="4572000"/>
+          </a:xfrm>
+          <a:prstGeom prst="rect">
+            <a:avLst/>
+          </a:prstGeom>
+          <a:noFill/>
+        </p:spPr>
+        <p:txBody>
+          <a:bodyPr wrap="square">
+            <a:spAutoFit/>
+          </a:bodyPr>
+          <a:lstStyle/>
+          <a:p>
+            <a:pPr algn="l">
+              <a:defRPr sz="1400" b="0">
+                <a:solidFill>
+                  <a:srgbClr val="212121"/>
+                </a:solidFill>
+                <a:latin typeface="Calibri"/>
+              </a:defRPr>
             </a:pPr>
             <a:r>
-              <a:t>• [Shift LIS] Máscara C216 — novo procedimento, enviar e-mail</a:t>
-            </a:r>
-          </a:p>
-          <a:p>
-            <a:pPr>
-              <a:spcAft>
-                <a:spcPts val="400"/>
-              </a:spcAft>
-              <a:defRPr sz="1400"/>
+              <a:t>• ABL-800 — interface do gasômetro do HCM configurada para incorporar resultados de hemoglobinas (18/06)</a:t>
+            </a:r>
+          </a:p>
+        </p:txBody>
+      </p:sp>
+      <p:sp>
+        <p:nvSpPr>
+          <p:cNvPr id="7" name="Rectangle 6"/>
+          <p:cNvSpPr/>
+          <p:nvPr/>
+        </p:nvSpPr>
+        <p:spPr>
+          <a:xfrm>
+            <a:off x="0" y="6309360"/>
+            <a:ext cx="12191695" cy="548640"/>
+          </a:xfrm>
+          <a:prstGeom prst="rect">
+            <a:avLst/>
+          </a:prstGeom>
+          <a:solidFill>
+            <a:srgbClr val="F5F5F5"/>
+          </a:solidFill>
+          <a:ln>
+            <a:noFill/>
+          </a:ln>
+        </p:spPr>
+        <p:style>
+          <a:lnRef idx="1">
+            <a:schemeClr val="accent1"/>
+          </a:lnRef>
+          <a:fillRef idx="3">
+            <a:schemeClr val="accent1"/>
+          </a:fillRef>
+          <a:effectRef idx="2">
+            <a:schemeClr val="accent1"/>
+          </a:effectRef>
+          <a:fontRef idx="minor">
+            <a:schemeClr val="lt1"/>
+          </a:fontRef>
+        </p:style>
+        <p:txBody>
+          <a:bodyPr rtlCol="0" anchor="ctr"/>
+          <a:lstStyle/>
+          <a:p>
+            <a:pPr algn="ctr"/>
+          </a:p>
+        </p:txBody>
+      </p:sp>
+      <p:sp>
+        <p:nvSpPr>
+          <p:cNvPr id="8" name="TextBox 7"/>
+          <p:cNvSpPr txBox="1"/>
+          <p:nvPr/>
+        </p:nvSpPr>
+        <p:spPr>
+          <a:xfrm>
+            <a:off x="731520" y="6355080"/>
+            <a:ext cx="4572000" cy="365760"/>
+          </a:xfrm>
+          <a:prstGeom prst="rect">
+            <a:avLst/>
+          </a:prstGeom>
+          <a:noFill/>
+        </p:spPr>
+        <p:txBody>
+          <a:bodyPr wrap="square">
+            <a:spAutoFit/>
+          </a:bodyPr>
+          <a:lstStyle/>
+          <a:p>
+            <a:pPr algn="l">
+              <a:defRPr sz="1000" b="0">
+                <a:solidFill>
+                  <a:srgbClr val="757575"/>
+                </a:solidFill>
+                <a:latin typeface="Calibri"/>
+              </a:defRPr>
             </a:pPr>
             <a:r>
-              <a:t>• [Shift LIS] Máscara RECALCRE — pegar laudo referência com apoio</a:t>
-            </a:r>
-          </a:p>
-          <a:p>
-            <a:pPr>
-              <a:spcAft>
-                <a:spcPts val="400"/>
-              </a:spcAft>
-              <a:defRPr sz="1400"/>
+              <a:t>Junho 2026</a:t>
+            </a:r>
+          </a:p>
+        </p:txBody>
+      </p:sp>
+      <p:sp>
+        <p:nvSpPr>
+          <p:cNvPr id="9" name="TextBox 8"/>
+          <p:cNvSpPr txBox="1"/>
+          <p:nvPr/>
+        </p:nvSpPr>
+        <p:spPr>
+          <a:xfrm>
+            <a:off x="6400800" y="6355080"/>
+            <a:ext cx="5029200" cy="365760"/>
+          </a:xfrm>
+          <a:prstGeom prst="rect">
+            <a:avLst/>
+          </a:prstGeom>
+          <a:noFill/>
+        </p:spPr>
+        <p:txBody>
+          <a:bodyPr wrap="square">
+            <a:spAutoFit/>
+          </a:bodyPr>
+          <a:lstStyle/>
+          <a:p>
+            <a:pPr algn="r">
+              <a:defRPr sz="1000" b="0">
+                <a:solidFill>
+                  <a:srgbClr val="757575"/>
+                </a:solidFill>
+                <a:latin typeface="Calibri"/>
+              </a:defRPr>
             </a:pPr>
             <a:r>
-              <a:t>• [Shift LIS] Máscara IGE I5 — enviar e-mail</a:t>
-            </a:r>
-          </a:p>
-          <a:p>
-            <a:pPr>
-              <a:spcAft>
-                <a:spcPts val="400"/>
-              </a:spcAft>
-              <a:defRPr sz="1400"/>
+              <a:t>TI Laboratório — FUNFARME</a:t>
+            </a:r>
+          </a:p>
+        </p:txBody>
+      </p:sp>
+    </p:spTree>
+  </p:cSld>
+  <p:clrMapOvr>
+    <a:masterClrMapping/>
+  </p:clrMapOvr>
+</p:sld>
+</file>
+
+<file path=ppt/slides/slide6.xml><?xml version="1.0" encoding="utf-8"?>
+<p:sld xmlns:a="http://schemas.openxmlformats.org/drawingml/2006/main" xmlns:p="http://schemas.openxmlformats.org/presentationml/2006/main" xmlns:r="http://schemas.openxmlformats.org/officeDocument/2006/relationships">
+  <p:cSld>
+    <p:spTree>
+      <p:nvGrpSpPr>
+        <p:cNvPr id="1" name=""/>
+        <p:cNvGrpSpPr/>
+        <p:nvPr/>
+      </p:nvGrpSpPr>
+      <p:grpSpPr/>
+      <p:sp>
+        <p:nvSpPr>
+          <p:cNvPr id="2" name="Rectangle 1"/>
+          <p:cNvSpPr/>
+          <p:nvPr/>
+        </p:nvSpPr>
+        <p:spPr>
+          <a:xfrm>
+            <a:off x="0" y="0"/>
+            <a:ext cx="12191695" cy="1005840"/>
+          </a:xfrm>
+          <a:prstGeom prst="rect">
+            <a:avLst/>
+          </a:prstGeom>
+          <a:solidFill>
+            <a:srgbClr val="005F56"/>
+          </a:solidFill>
+          <a:ln>
+            <a:noFill/>
+          </a:ln>
+        </p:spPr>
+        <p:style>
+          <a:lnRef idx="1">
+            <a:schemeClr val="accent1"/>
+          </a:lnRef>
+          <a:fillRef idx="3">
+            <a:schemeClr val="accent1"/>
+          </a:fillRef>
+          <a:effectRef idx="2">
+            <a:schemeClr val="accent1"/>
+          </a:effectRef>
+          <a:fontRef idx="minor">
+            <a:schemeClr val="lt1"/>
+          </a:fontRef>
+        </p:style>
+        <p:txBody>
+          <a:bodyPr rtlCol="0" anchor="ctr"/>
+          <a:lstStyle/>
+          <a:p>
+            <a:pPr algn="ctr"/>
+          </a:p>
+        </p:txBody>
+      </p:sp>
+      <p:sp>
+        <p:nvSpPr>
+          <p:cNvPr id="3" name="Rectangle 2"/>
+          <p:cNvSpPr/>
+          <p:nvPr/>
+        </p:nvSpPr>
+        <p:spPr>
+          <a:xfrm>
+            <a:off x="0" y="1005840"/>
+            <a:ext cx="12191695" cy="36576"/>
+          </a:xfrm>
+          <a:prstGeom prst="rect">
+            <a:avLst/>
+          </a:prstGeom>
+          <a:solidFill>
+            <a:srgbClr val="00BCD4"/>
+          </a:solidFill>
+          <a:ln>
+            <a:noFill/>
+          </a:ln>
+        </p:spPr>
+        <p:style>
+          <a:lnRef idx="1">
+            <a:schemeClr val="accent1"/>
+          </a:lnRef>
+          <a:fillRef idx="3">
+            <a:schemeClr val="accent1"/>
+          </a:fillRef>
+          <a:effectRef idx="2">
+            <a:schemeClr val="accent1"/>
+          </a:effectRef>
+          <a:fontRef idx="minor">
+            <a:schemeClr val="lt1"/>
+          </a:fontRef>
+        </p:style>
+        <p:txBody>
+          <a:bodyPr rtlCol="0" anchor="ctr"/>
+          <a:lstStyle/>
+          <a:p>
+            <a:pPr algn="ctr"/>
+          </a:p>
+        </p:txBody>
+      </p:sp>
+      <p:sp>
+        <p:nvSpPr>
+          <p:cNvPr id="4" name="TextBox 3"/>
+          <p:cNvSpPr txBox="1"/>
+          <p:nvPr/>
+        </p:nvSpPr>
+        <p:spPr>
+          <a:xfrm>
+            <a:off x="731520" y="228600"/>
+            <a:ext cx="9144000" cy="548640"/>
+          </a:xfrm>
+          <a:prstGeom prst="rect">
+            <a:avLst/>
+          </a:prstGeom>
+          <a:noFill/>
+        </p:spPr>
+        <p:txBody>
+          <a:bodyPr wrap="square">
+            <a:spAutoFit/>
+          </a:bodyPr>
+          <a:lstStyle/>
+          <a:p>
+            <a:pPr algn="l">
+              <a:defRPr sz="2800" b="1">
+                <a:solidFill>
+                  <a:srgbClr val="FFFFFF"/>
+                </a:solidFill>
+                <a:latin typeface="Calibri"/>
+              </a:defRPr>
             </a:pPr>
             <a:r>
-              <a:t>• [Shift LIS] Máscara Metil. Russell P.G. — painel genético Pardini, esperando informações</a:t>
-            </a:r>
-          </a:p>
-          <a:p>
-            <a:pPr>
-              <a:spcAft>
-                <a:spcPts val="400"/>
-              </a:spcAft>
-              <a:defRPr sz="1400"/>
+              <a:t>Pendências</a:t>
+            </a:r>
+          </a:p>
+        </p:txBody>
+      </p:sp>
+      <p:pic>
+        <p:nvPicPr>
+          <p:cNvPr id="5" name="Picture 4" descr="nti.png"/>
+          <p:cNvPicPr>
+            <a:picLocks noChangeAspect="1"/>
+          </p:cNvPicPr>
+          <p:nvPr/>
+        </p:nvPicPr>
+        <p:blipFill>
+          <a:blip r:embed="rId2"/>
+          <a:stretch>
+            <a:fillRect/>
+          </a:stretch>
+        </p:blipFill>
+        <p:spPr>
+          <a:xfrm>
+            <a:off x="10241280" y="182880"/>
+            <a:ext cx="1626669" cy="594360"/>
+          </a:xfrm>
+          <a:prstGeom prst="rect">
+            <a:avLst/>
+          </a:prstGeom>
+        </p:spPr>
+      </p:pic>
+      <p:sp>
+        <p:nvSpPr>
+          <p:cNvPr id="6" name="TextBox 5"/>
+          <p:cNvSpPr txBox="1"/>
+          <p:nvPr/>
+        </p:nvSpPr>
+        <p:spPr>
+          <a:xfrm>
+            <a:off x="731520" y="1463040"/>
+            <a:ext cx="10515600" cy="4572000"/>
+          </a:xfrm>
+          <a:prstGeom prst="rect">
+            <a:avLst/>
+          </a:prstGeom>
+          <a:noFill/>
+        </p:spPr>
+        <p:txBody>
+          <a:bodyPr wrap="square">
+            <a:spAutoFit/>
+          </a:bodyPr>
+          <a:lstStyle/>
+          <a:p>
+            <a:pPr algn="l">
+              <a:defRPr sz="1400" b="0">
+                <a:solidFill>
+                  <a:srgbClr val="212121"/>
+                </a:solidFill>
+                <a:latin typeface="Calibri"/>
+              </a:defRPr>
             </a:pPr>
             <a:r>
-              <a:t>• [Shift LIS] Máscara PB19PCR — esperando validação, troca de setor Apoio → Biomol</a:t>
-            </a:r>
-          </a:p>
-          <a:p>
-            <a:pPr>
-              <a:spcAft>
-                <a:spcPts val="400"/>
-              </a:spcAft>
-              <a:defRPr sz="1400"/>
+              <a:t>• [Shift Automação] MAX ION 800 — preparação para testes de novo analisador de eletrólitos; verificar sítio de instalação e contatar cliente com interfaceamento configurado
+• [Shift LIS] Máscara C216 — novo procedimento, enviar e-mail
+• [Shift LIS] Máscara RECALCRE — pegar laudo referência com apoio
+• [Shift LIS] Máscara IGE I5 — enviar e-mail
+• [Municípios] Capacitar técnicos de TI dos municípios para suporte autônomo (pós-bloqueio de acesso remoto externo)
+• [Rede/Servidores] Avaliar alternativa de acesso remoto para Shift ao SRV-AUTOMA (pós-bloqueio AnyDesk)
+• [Shift LIS] Máscara Metil. Russell P.G. — painel genético Pardini, esperando informações
+• [Shift LIS] Máscara PB19PCR — esperando validação, troca de setor Apoio → Biomol
+• [Shift LIS] Máscara IMUNOF24 — em progresso
+• [Shift LIS] Máscara MECP2 — esperando informações sobre laudo</a:t>
+            </a:r>
+          </a:p>
+        </p:txBody>
+      </p:sp>
+      <p:sp>
+        <p:nvSpPr>
+          <p:cNvPr id="7" name="Rectangle 6"/>
+          <p:cNvSpPr/>
+          <p:nvPr/>
+        </p:nvSpPr>
+        <p:spPr>
+          <a:xfrm>
+            <a:off x="0" y="6309360"/>
+            <a:ext cx="12191695" cy="548640"/>
+          </a:xfrm>
+          <a:prstGeom prst="rect">
+            <a:avLst/>
+          </a:prstGeom>
+          <a:solidFill>
+            <a:srgbClr val="F5F5F5"/>
+          </a:solidFill>
+          <a:ln>
+            <a:noFill/>
+          </a:ln>
+        </p:spPr>
+        <p:style>
+          <a:lnRef idx="1">
+            <a:schemeClr val="accent1"/>
+          </a:lnRef>
+          <a:fillRef idx="3">
+            <a:schemeClr val="accent1"/>
+          </a:fillRef>
+          <a:effectRef idx="2">
+            <a:schemeClr val="accent1"/>
+          </a:effectRef>
+          <a:fontRef idx="minor">
+            <a:schemeClr val="lt1"/>
+          </a:fontRef>
+        </p:style>
+        <p:txBody>
+          <a:bodyPr rtlCol="0" anchor="ctr"/>
+          <a:lstStyle/>
+          <a:p>
+            <a:pPr algn="ctr"/>
+          </a:p>
+        </p:txBody>
+      </p:sp>
+      <p:sp>
+        <p:nvSpPr>
+          <p:cNvPr id="8" name="TextBox 7"/>
+          <p:cNvSpPr txBox="1"/>
+          <p:nvPr/>
+        </p:nvSpPr>
+        <p:spPr>
+          <a:xfrm>
+            <a:off x="731520" y="6355080"/>
+            <a:ext cx="4572000" cy="365760"/>
+          </a:xfrm>
+          <a:prstGeom prst="rect">
+            <a:avLst/>
+          </a:prstGeom>
+          <a:noFill/>
+        </p:spPr>
+        <p:txBody>
+          <a:bodyPr wrap="square">
+            <a:spAutoFit/>
+          </a:bodyPr>
+          <a:lstStyle/>
+          <a:p>
+            <a:pPr algn="l">
+              <a:defRPr sz="1000" b="0">
+                <a:solidFill>
+                  <a:srgbClr val="757575"/>
+                </a:solidFill>
+                <a:latin typeface="Calibri"/>
+              </a:defRPr>
             </a:pPr>
             <a:r>
-              <a:t>• [Shift LIS] Máscara IMUNOF24 — em progresso</a:t>
-            </a:r>
-          </a:p>
-          <a:p>
-            <a:pPr>
-              <a:spcAft>
-                <a:spcPts val="400"/>
-              </a:spcAft>
-              <a:defRPr sz="1400"/>
+              <a:t>Junho 2026</a:t>
+            </a:r>
+          </a:p>
+        </p:txBody>
+      </p:sp>
+      <p:sp>
+        <p:nvSpPr>
+          <p:cNvPr id="9" name="TextBox 8"/>
+          <p:cNvSpPr txBox="1"/>
+          <p:nvPr/>
+        </p:nvSpPr>
+        <p:spPr>
+          <a:xfrm>
+            <a:off x="6400800" y="6355080"/>
+            <a:ext cx="5029200" cy="365760"/>
+          </a:xfrm>
+          <a:prstGeom prst="rect">
+            <a:avLst/>
+          </a:prstGeom>
+          <a:noFill/>
+        </p:spPr>
+        <p:txBody>
+          <a:bodyPr wrap="square">
+            <a:spAutoFit/>
+          </a:bodyPr>
+          <a:lstStyle/>
+          <a:p>
+            <a:pPr algn="r">
+              <a:defRPr sz="1000" b="0">
+                <a:solidFill>
+                  <a:srgbClr val="757575"/>
+                </a:solidFill>
+                <a:latin typeface="Calibri"/>
+              </a:defRPr>
             </a:pPr>
             <a:r>
-              <a:t>• [Shift LIS] Máscara MECP2 — esperando informações sobre laudo</a:t>
+              <a:t>TI Laboratório — FUNFARME</a:t>
+            </a:r>
+          </a:p>
+        </p:txBody>
+      </p:sp>
+    </p:spTree>
+  </p:cSld>
+  <p:clrMapOvr>
+    <a:masterClrMapping/>
+  </p:clrMapOvr>
+</p:sld>
+</file>
+
+<file path=ppt/slides/slide7.xml><?xml version="1.0" encoding="utf-8"?>
+<p:sld xmlns:a="http://schemas.openxmlformats.org/drawingml/2006/main" xmlns:p="http://schemas.openxmlformats.org/presentationml/2006/main" xmlns:r="http://schemas.openxmlformats.org/officeDocument/2006/relationships">
+  <p:cSld>
+    <p:spTree>
+      <p:nvGrpSpPr>
+        <p:cNvPr id="1" name=""/>
+        <p:cNvGrpSpPr/>
+        <p:nvPr/>
+      </p:nvGrpSpPr>
+      <p:grpSpPr/>
+      <p:sp>
+        <p:nvSpPr>
+          <p:cNvPr id="2" name="Rectangle 1"/>
+          <p:cNvSpPr/>
+          <p:nvPr/>
+        </p:nvSpPr>
+        <p:spPr>
+          <a:xfrm>
+            <a:off x="0" y="0"/>
+            <a:ext cx="12191695" cy="1005840"/>
+          </a:xfrm>
+          <a:prstGeom prst="rect">
+            <a:avLst/>
+          </a:prstGeom>
+          <a:solidFill>
+            <a:srgbClr val="005F56"/>
+          </a:solidFill>
+          <a:ln>
+            <a:noFill/>
+          </a:ln>
+        </p:spPr>
+        <p:style>
+          <a:lnRef idx="1">
+            <a:schemeClr val="accent1"/>
+          </a:lnRef>
+          <a:fillRef idx="3">
+            <a:schemeClr val="accent1"/>
+          </a:fillRef>
+          <a:effectRef idx="2">
+            <a:schemeClr val="accent1"/>
+          </a:effectRef>
+          <a:fontRef idx="minor">
+            <a:schemeClr val="lt1"/>
+          </a:fontRef>
+        </p:style>
+        <p:txBody>
+          <a:bodyPr rtlCol="0" anchor="ctr"/>
+          <a:lstStyle/>
+          <a:p>
+            <a:pPr algn="ctr"/>
+          </a:p>
+        </p:txBody>
+      </p:sp>
+      <p:sp>
+        <p:nvSpPr>
+          <p:cNvPr id="3" name="Rectangle 2"/>
+          <p:cNvSpPr/>
+          <p:nvPr/>
+        </p:nvSpPr>
+        <p:spPr>
+          <a:xfrm>
+            <a:off x="0" y="1005840"/>
+            <a:ext cx="12191695" cy="36576"/>
+          </a:xfrm>
+          <a:prstGeom prst="rect">
+            <a:avLst/>
+          </a:prstGeom>
+          <a:solidFill>
+            <a:srgbClr val="00BCD4"/>
+          </a:solidFill>
+          <a:ln>
+            <a:noFill/>
+          </a:ln>
+        </p:spPr>
+        <p:style>
+          <a:lnRef idx="1">
+            <a:schemeClr val="accent1"/>
+          </a:lnRef>
+          <a:fillRef idx="3">
+            <a:schemeClr val="accent1"/>
+          </a:fillRef>
+          <a:effectRef idx="2">
+            <a:schemeClr val="accent1"/>
+          </a:effectRef>
+          <a:fontRef idx="minor">
+            <a:schemeClr val="lt1"/>
+          </a:fontRef>
+        </p:style>
+        <p:txBody>
+          <a:bodyPr rtlCol="0" anchor="ctr"/>
+          <a:lstStyle/>
+          <a:p>
+            <a:pPr algn="ctr"/>
+          </a:p>
+        </p:txBody>
+      </p:sp>
+      <p:sp>
+        <p:nvSpPr>
+          <p:cNvPr id="4" name="TextBox 3"/>
+          <p:cNvSpPr txBox="1"/>
+          <p:nvPr/>
+        </p:nvSpPr>
+        <p:spPr>
+          <a:xfrm>
+            <a:off x="731520" y="228600"/>
+            <a:ext cx="9144000" cy="548640"/>
+          </a:xfrm>
+          <a:prstGeom prst="rect">
+            <a:avLst/>
+          </a:prstGeom>
+          <a:noFill/>
+        </p:spPr>
+        <p:txBody>
+          <a:bodyPr wrap="square">
+            <a:spAutoFit/>
+          </a:bodyPr>
+          <a:lstStyle/>
+          <a:p>
+            <a:pPr algn="l">
+              <a:defRPr sz="2800" b="1">
+                <a:solidFill>
+                  <a:srgbClr val="FFFFFF"/>
+                </a:solidFill>
+                <a:latin typeface="Calibri"/>
+              </a:defRPr>
+            </a:pPr>
+            <a:r>
+              <a:t>Incidentes</a:t>
+            </a:r>
+          </a:p>
+        </p:txBody>
+      </p:sp>
+      <p:pic>
+        <p:nvPicPr>
+          <p:cNvPr id="5" name="Picture 4" descr="nti.png"/>
+          <p:cNvPicPr>
+            <a:picLocks noChangeAspect="1"/>
+          </p:cNvPicPr>
+          <p:nvPr/>
+        </p:nvPicPr>
+        <p:blipFill>
+          <a:blip r:embed="rId2"/>
+          <a:stretch>
+            <a:fillRect/>
+          </a:stretch>
+        </p:blipFill>
+        <p:spPr>
+          <a:xfrm>
+            <a:off x="10241280" y="182880"/>
+            <a:ext cx="1626669" cy="594360"/>
+          </a:xfrm>
+          <a:prstGeom prst="rect">
+            <a:avLst/>
+          </a:prstGeom>
+        </p:spPr>
+      </p:pic>
+      <p:sp>
+        <p:nvSpPr>
+          <p:cNvPr id="6" name="TextBox 5"/>
+          <p:cNvSpPr txBox="1"/>
+          <p:nvPr/>
+        </p:nvSpPr>
+        <p:spPr>
+          <a:xfrm>
+            <a:off x="731520" y="1463040"/>
+            <a:ext cx="10515600" cy="4572000"/>
+          </a:xfrm>
+          <a:prstGeom prst="rect">
+            <a:avLst/>
+          </a:prstGeom>
+          <a:noFill/>
+        </p:spPr>
+        <p:txBody>
+          <a:bodyPr wrap="square">
+            <a:spAutoFit/>
+          </a:bodyPr>
+          <a:lstStyle/>
+          <a:p>
+            <a:pPr algn="l">
+              <a:defRPr sz="1400" b="0">
+                <a:solidFill>
+                  <a:srgbClr val="212121"/>
+                </a:solidFill>
+                <a:latin typeface="Calibri"/>
+              </a:defRPr>
+            </a:pPr>
+            <a:r>
+              <a:t>• 2026-06-16 — Bloqueio de ferramentas de acesso remoto externo</a:t>
+            </a:r>
+          </a:p>
+        </p:txBody>
+      </p:sp>
+      <p:sp>
+        <p:nvSpPr>
+          <p:cNvPr id="7" name="Rectangle 6"/>
+          <p:cNvSpPr/>
+          <p:nvPr/>
+        </p:nvSpPr>
+        <p:spPr>
+          <a:xfrm>
+            <a:off x="0" y="6309360"/>
+            <a:ext cx="12191695" cy="548640"/>
+          </a:xfrm>
+          <a:prstGeom prst="rect">
+            <a:avLst/>
+          </a:prstGeom>
+          <a:solidFill>
+            <a:srgbClr val="F5F5F5"/>
+          </a:solidFill>
+          <a:ln>
+            <a:noFill/>
+          </a:ln>
+        </p:spPr>
+        <p:style>
+          <a:lnRef idx="1">
+            <a:schemeClr val="accent1"/>
+          </a:lnRef>
+          <a:fillRef idx="3">
+            <a:schemeClr val="accent1"/>
+          </a:fillRef>
+          <a:effectRef idx="2">
+            <a:schemeClr val="accent1"/>
+          </a:effectRef>
+          <a:fontRef idx="minor">
+            <a:schemeClr val="lt1"/>
+          </a:fontRef>
+        </p:style>
+        <p:txBody>
+          <a:bodyPr rtlCol="0" anchor="ctr"/>
+          <a:lstStyle/>
+          <a:p>
+            <a:pPr algn="ctr"/>
+          </a:p>
+        </p:txBody>
+      </p:sp>
+      <p:sp>
+        <p:nvSpPr>
+          <p:cNvPr id="8" name="TextBox 7"/>
+          <p:cNvSpPr txBox="1"/>
+          <p:nvPr/>
+        </p:nvSpPr>
+        <p:spPr>
+          <a:xfrm>
+            <a:off x="731520" y="6355080"/>
+            <a:ext cx="4572000" cy="365760"/>
+          </a:xfrm>
+          <a:prstGeom prst="rect">
+            <a:avLst/>
+          </a:prstGeom>
+          <a:noFill/>
+        </p:spPr>
+        <p:txBody>
+          <a:bodyPr wrap="square">
+            <a:spAutoFit/>
+          </a:bodyPr>
+          <a:lstStyle/>
+          <a:p>
+            <a:pPr algn="l">
+              <a:defRPr sz="1000" b="0">
+                <a:solidFill>
+                  <a:srgbClr val="757575"/>
+                </a:solidFill>
+                <a:latin typeface="Calibri"/>
+              </a:defRPr>
+            </a:pPr>
+            <a:r>
+              <a:t>Junho 2026</a:t>
+            </a:r>
+          </a:p>
+        </p:txBody>
+      </p:sp>
+      <p:sp>
+        <p:nvSpPr>
+          <p:cNvPr id="9" name="TextBox 8"/>
+          <p:cNvSpPr txBox="1"/>
+          <p:nvPr/>
+        </p:nvSpPr>
+        <p:spPr>
+          <a:xfrm>
+            <a:off x="6400800" y="6355080"/>
+            <a:ext cx="5029200" cy="365760"/>
+          </a:xfrm>
+          <a:prstGeom prst="rect">
+            <a:avLst/>
+          </a:prstGeom>
+          <a:noFill/>
+        </p:spPr>
+        <p:txBody>
+          <a:bodyPr wrap="square">
+            <a:spAutoFit/>
+          </a:bodyPr>
+          <a:lstStyle/>
+          <a:p>
+            <a:pPr algn="r">
+              <a:defRPr sz="1000" b="0">
+                <a:solidFill>
+                  <a:srgbClr val="757575"/>
+                </a:solidFill>
+                <a:latin typeface="Calibri"/>
+              </a:defRPr>
+            </a:pPr>
+            <a:r>
+              <a:t>TI Laboratório — FUNFARME</a:t>
             </a:r>
           </a:p>
         </p:txBody>

</xml_diff>

<commit_message>
docs: relatório mensal de junho 2026 — 30 tarefas, 4 incidentes
Co-Authored-By: Claude Sonnet 4.6 <noreply@anthropic.com>
</commit_message>
<xml_diff>
--- a/reports/2026-06_resumo-mensal.pptx
+++ b/reports/2026-06_resumo-mensal.pptx
@@ -12,6 +12,9 @@
     <p:sldId id="260" r:id="rId11"/>
     <p:sldId id="261" r:id="rId12"/>
     <p:sldId id="262" r:id="rId13"/>
+    <p:sldId id="263" r:id="rId14"/>
+    <p:sldId id="264" r:id="rId15"/>
+    <p:sldId id="265" r:id="rId16"/>
   </p:sldIdLst>
   <p:sldSz cx="12191695" cy="6858000" type="screen4x3"/>
   <p:notesSz cx="6858000" cy="9144000"/>
@@ -3446,7 +3449,7 @@
               </a:defRPr>
             </a:pPr>
             <a:r>
-              <a:t>16</a:t>
+              <a:t>30</a:t>
             </a:r>
           </a:p>
         </p:txBody>
@@ -3561,7 +3564,7 @@
               </a:defRPr>
             </a:pPr>
             <a:r>
-              <a:t>10</a:t>
+              <a:t>1</a:t>
             </a:r>
           </a:p>
         </p:txBody>
@@ -3676,7 +3679,7 @@
               </a:defRPr>
             </a:pPr>
             <a:r>
-              <a:t>1</a:t>
+              <a:t>4</a:t>
             </a:r>
           </a:p>
         </p:txBody>
@@ -3756,6 +3759,324 @@
             </a:pPr>
             <a:r>
               <a:t>FUNFARME — Fundação Faculdade Regional de Medicina · São José do Rio Preto — SP</a:t>
+            </a:r>
+          </a:p>
+        </p:txBody>
+      </p:sp>
+    </p:spTree>
+  </p:cSld>
+  <p:clrMapOvr>
+    <a:masterClrMapping/>
+  </p:clrMapOvr>
+</p:sld>
+</file>
+
+<file path=ppt/slides/slide10.xml><?xml version="1.0" encoding="utf-8"?>
+<p:sld xmlns:a="http://schemas.openxmlformats.org/drawingml/2006/main" xmlns:p="http://schemas.openxmlformats.org/presentationml/2006/main" xmlns:r="http://schemas.openxmlformats.org/officeDocument/2006/relationships">
+  <p:cSld>
+    <p:spTree>
+      <p:nvGrpSpPr>
+        <p:cNvPr id="1" name=""/>
+        <p:cNvGrpSpPr/>
+        <p:nvPr/>
+      </p:nvGrpSpPr>
+      <p:grpSpPr/>
+      <p:sp>
+        <p:nvSpPr>
+          <p:cNvPr id="2" name="Rectangle 1"/>
+          <p:cNvSpPr/>
+          <p:nvPr/>
+        </p:nvSpPr>
+        <p:spPr>
+          <a:xfrm>
+            <a:off x="0" y="0"/>
+            <a:ext cx="12191695" cy="1005840"/>
+          </a:xfrm>
+          <a:prstGeom prst="rect">
+            <a:avLst/>
+          </a:prstGeom>
+          <a:solidFill>
+            <a:srgbClr val="005F56"/>
+          </a:solidFill>
+          <a:ln>
+            <a:noFill/>
+          </a:ln>
+        </p:spPr>
+        <p:style>
+          <a:lnRef idx="1">
+            <a:schemeClr val="accent1"/>
+          </a:lnRef>
+          <a:fillRef idx="3">
+            <a:schemeClr val="accent1"/>
+          </a:fillRef>
+          <a:effectRef idx="2">
+            <a:schemeClr val="accent1"/>
+          </a:effectRef>
+          <a:fontRef idx="minor">
+            <a:schemeClr val="lt1"/>
+          </a:fontRef>
+        </p:style>
+        <p:txBody>
+          <a:bodyPr rtlCol="0" anchor="ctr"/>
+          <a:lstStyle/>
+          <a:p>
+            <a:pPr algn="ctr"/>
+          </a:p>
+        </p:txBody>
+      </p:sp>
+      <p:sp>
+        <p:nvSpPr>
+          <p:cNvPr id="3" name="Rectangle 2"/>
+          <p:cNvSpPr/>
+          <p:nvPr/>
+        </p:nvSpPr>
+        <p:spPr>
+          <a:xfrm>
+            <a:off x="0" y="1005840"/>
+            <a:ext cx="12191695" cy="36576"/>
+          </a:xfrm>
+          <a:prstGeom prst="rect">
+            <a:avLst/>
+          </a:prstGeom>
+          <a:solidFill>
+            <a:srgbClr val="00BCD4"/>
+          </a:solidFill>
+          <a:ln>
+            <a:noFill/>
+          </a:ln>
+        </p:spPr>
+        <p:style>
+          <a:lnRef idx="1">
+            <a:schemeClr val="accent1"/>
+          </a:lnRef>
+          <a:fillRef idx="3">
+            <a:schemeClr val="accent1"/>
+          </a:fillRef>
+          <a:effectRef idx="2">
+            <a:schemeClr val="accent1"/>
+          </a:effectRef>
+          <a:fontRef idx="minor">
+            <a:schemeClr val="lt1"/>
+          </a:fontRef>
+        </p:style>
+        <p:txBody>
+          <a:bodyPr rtlCol="0" anchor="ctr"/>
+          <a:lstStyle/>
+          <a:p>
+            <a:pPr algn="ctr"/>
+          </a:p>
+        </p:txBody>
+      </p:sp>
+      <p:sp>
+        <p:nvSpPr>
+          <p:cNvPr id="4" name="TextBox 3"/>
+          <p:cNvSpPr txBox="1"/>
+          <p:nvPr/>
+        </p:nvSpPr>
+        <p:spPr>
+          <a:xfrm>
+            <a:off x="731520" y="228600"/>
+            <a:ext cx="9144000" cy="548640"/>
+          </a:xfrm>
+          <a:prstGeom prst="rect">
+            <a:avLst/>
+          </a:prstGeom>
+          <a:noFill/>
+        </p:spPr>
+        <p:txBody>
+          <a:bodyPr wrap="square">
+            <a:spAutoFit/>
+          </a:bodyPr>
+          <a:lstStyle/>
+          <a:p>
+            <a:pPr algn="l">
+              <a:defRPr sz="2800" b="1">
+                <a:solidFill>
+                  <a:srgbClr val="FFFFFF"/>
+                </a:solidFill>
+                <a:latin typeface="Calibri"/>
+              </a:defRPr>
+            </a:pPr>
+            <a:r>
+              <a:t>Incidentes</a:t>
+            </a:r>
+          </a:p>
+        </p:txBody>
+      </p:sp>
+      <p:pic>
+        <p:nvPicPr>
+          <p:cNvPr id="5" name="Picture 4" descr="nti.png"/>
+          <p:cNvPicPr>
+            <a:picLocks noChangeAspect="1"/>
+          </p:cNvPicPr>
+          <p:nvPr/>
+        </p:nvPicPr>
+        <p:blipFill>
+          <a:blip r:embed="rId2"/>
+          <a:stretch>
+            <a:fillRect/>
+          </a:stretch>
+        </p:blipFill>
+        <p:spPr>
+          <a:xfrm>
+            <a:off x="10241280" y="182880"/>
+            <a:ext cx="1626669" cy="594360"/>
+          </a:xfrm>
+          <a:prstGeom prst="rect">
+            <a:avLst/>
+          </a:prstGeom>
+        </p:spPr>
+      </p:pic>
+      <p:sp>
+        <p:nvSpPr>
+          <p:cNvPr id="6" name="TextBox 5"/>
+          <p:cNvSpPr txBox="1"/>
+          <p:nvPr/>
+        </p:nvSpPr>
+        <p:spPr>
+          <a:xfrm>
+            <a:off x="731520" y="1463040"/>
+            <a:ext cx="10515600" cy="4572000"/>
+          </a:xfrm>
+          <a:prstGeom prst="rect">
+            <a:avLst/>
+          </a:prstGeom>
+          <a:noFill/>
+        </p:spPr>
+        <p:txBody>
+          <a:bodyPr wrap="square">
+            <a:spAutoFit/>
+          </a:bodyPr>
+          <a:lstStyle/>
+          <a:p>
+            <a:pPr algn="l">
+              <a:defRPr sz="1400" b="0">
+                <a:solidFill>
+                  <a:srgbClr val="212121"/>
+                </a:solidFill>
+                <a:latin typeface="Calibri"/>
+              </a:defRPr>
+            </a:pPr>
+            <a:r>
+              <a:t>• 2026-06-16 — I1 — Bloqueio de ferramentas de acesso remoto externo
+• 2026-06-25 — I2 — Divergência de user-id entre Shift e MV — Caroline
+• 2026-06-25 — I3 — Imagens Cobas 6500 II não consumidas — 15/05/2026
+• 2026-06-25 — I4 — Queda geral do Shift LIS</a:t>
+            </a:r>
+          </a:p>
+        </p:txBody>
+      </p:sp>
+      <p:sp>
+        <p:nvSpPr>
+          <p:cNvPr id="7" name="Rectangle 6"/>
+          <p:cNvSpPr/>
+          <p:nvPr/>
+        </p:nvSpPr>
+        <p:spPr>
+          <a:xfrm>
+            <a:off x="0" y="6309360"/>
+            <a:ext cx="12191695" cy="548640"/>
+          </a:xfrm>
+          <a:prstGeom prst="rect">
+            <a:avLst/>
+          </a:prstGeom>
+          <a:solidFill>
+            <a:srgbClr val="F5F5F5"/>
+          </a:solidFill>
+          <a:ln>
+            <a:noFill/>
+          </a:ln>
+        </p:spPr>
+        <p:style>
+          <a:lnRef idx="1">
+            <a:schemeClr val="accent1"/>
+          </a:lnRef>
+          <a:fillRef idx="3">
+            <a:schemeClr val="accent1"/>
+          </a:fillRef>
+          <a:effectRef idx="2">
+            <a:schemeClr val="accent1"/>
+          </a:effectRef>
+          <a:fontRef idx="minor">
+            <a:schemeClr val="lt1"/>
+          </a:fontRef>
+        </p:style>
+        <p:txBody>
+          <a:bodyPr rtlCol="0" anchor="ctr"/>
+          <a:lstStyle/>
+          <a:p>
+            <a:pPr algn="ctr"/>
+          </a:p>
+        </p:txBody>
+      </p:sp>
+      <p:sp>
+        <p:nvSpPr>
+          <p:cNvPr id="8" name="TextBox 7"/>
+          <p:cNvSpPr txBox="1"/>
+          <p:nvPr/>
+        </p:nvSpPr>
+        <p:spPr>
+          <a:xfrm>
+            <a:off x="731520" y="6355080"/>
+            <a:ext cx="4572000" cy="365760"/>
+          </a:xfrm>
+          <a:prstGeom prst="rect">
+            <a:avLst/>
+          </a:prstGeom>
+          <a:noFill/>
+        </p:spPr>
+        <p:txBody>
+          <a:bodyPr wrap="square">
+            <a:spAutoFit/>
+          </a:bodyPr>
+          <a:lstStyle/>
+          <a:p>
+            <a:pPr algn="l">
+              <a:defRPr sz="1000" b="0">
+                <a:solidFill>
+                  <a:srgbClr val="757575"/>
+                </a:solidFill>
+                <a:latin typeface="Calibri"/>
+              </a:defRPr>
+            </a:pPr>
+            <a:r>
+              <a:t>Junho 2026</a:t>
+            </a:r>
+          </a:p>
+        </p:txBody>
+      </p:sp>
+      <p:sp>
+        <p:nvSpPr>
+          <p:cNvPr id="9" name="TextBox 8"/>
+          <p:cNvSpPr txBox="1"/>
+          <p:nvPr/>
+        </p:nvSpPr>
+        <p:spPr>
+          <a:xfrm>
+            <a:off x="6400800" y="6355080"/>
+            <a:ext cx="5029200" cy="365760"/>
+          </a:xfrm>
+          <a:prstGeom prst="rect">
+            <a:avLst/>
+          </a:prstGeom>
+          <a:noFill/>
+        </p:spPr>
+        <p:txBody>
+          <a:bodyPr wrap="square">
+            <a:spAutoFit/>
+          </a:bodyPr>
+          <a:lstStyle/>
+          <a:p>
+            <a:pPr algn="r">
+              <a:defRPr sz="1000" b="0">
+                <a:solidFill>
+                  <a:srgbClr val="757575"/>
+                </a:solidFill>
+                <a:latin typeface="Calibri"/>
+              </a:defRPr>
+            </a:pPr>
+            <a:r>
+              <a:t>TI Laboratório — FUNFARME</a:t>
             </a:r>
           </a:p>
         </p:txBody>
@@ -3955,9 +4276,12 @@
               </a:defRPr>
             </a:pPr>
             <a:r>
-              <a:t>Shift LIS: 15 tarefas
-Shift Automação: 1 tarefa
-Total: 16</a:t>
+              <a:t>Shift LIS: 22 tarefas
+Rede/Servidores: 2 tarefas
+Shift Integração: 2 tarefas
+Shift Automação: 2 tarefas
+Municípios: 2 tarefas
+Total: 30</a:t>
             </a:r>
           </a:p>
         </p:txBody>
@@ -4272,9 +4596,11 @@
               </a:defRPr>
             </a:pPr>
             <a:r>
-              <a:t>Semana 1 (01/06–07/06): 3 tarefas
+              <a:t>Semana 1 (01/06–07/06): 4 tarefas
 Semana 2 (08/06–14/06): 5 tarefas
 Semana 3 (15/06–21/06): 8 tarefas
+Semana 4 (22/06–28/06): 9 tarefas
+Semana 5 (29/06–30/06): 4 tarefas
 </a:t>
             </a:r>
           </a:p>
@@ -4530,7 +4856,7 @@
               </a:defRPr>
             </a:pPr>
             <a:r>
-              <a:t>Shift LIS (15)</a:t>
+              <a:t>Shift LIS (22)</a:t>
             </a:r>
           </a:p>
         </p:txBody>
@@ -4604,7 +4930,14 @@
 • Máscara C3 (17/06)
 • Máscara PEPI (17/06)
 • Máscara COQ10 (17/06)
-• Máscara DOEIMU (18/06)</a:t>
+• Máscara DOEIMU (18/06)
+• Máscara RECALCRE (25/06)
+• Máscara IGE I5 (25/06)
+• Máscara MECP2 (25/06)
+• Máscara IMUNOF24 (25/06)
+• Máscara PB19PCR (25/06)
+• Máscara Metil. Russell P.G. — painel genético Pardini (25/06)
+• Máscara C216 — novo procedimento (25/06)</a:t>
             </a:r>
           </a:p>
         </p:txBody>
@@ -4859,7 +5192,7 @@
               </a:defRPr>
             </a:pPr>
             <a:r>
-              <a:t>Shift Automação (1)</a:t>
+              <a:t>Rede/Servidores (2)</a:t>
             </a:r>
           </a:p>
         </p:txBody>
@@ -4919,7 +5252,8 @@
               </a:defRPr>
             </a:pPr>
             <a:r>
-              <a:t>• ABL-800 — interface do gasômetro do HCM configurada para incorporar resultados de hemoglobinas (18/06)</a:t>
+              <a:t>• Avaliar alternativa de acesso remoto para Shift ao SRV-AUTOMA — equipe de redes avaliará riscos; acesso remoto permanece bloqueado por enquanto (25/06)
+• Cofre KeePass criado e senhas de docs/credenciais.md armazenadas (29/06)</a:t>
             </a:r>
           </a:p>
         </p:txBody>
@@ -5072,7 +5406,7 @@
             <a:avLst/>
           </a:prstGeom>
           <a:solidFill>
-            <a:srgbClr val="005F56"/>
+            <a:srgbClr val="00897B"/>
           </a:solidFill>
           <a:ln>
             <a:noFill/>
@@ -5174,7 +5508,7 @@
               </a:defRPr>
             </a:pPr>
             <a:r>
-              <a:t>Pendências</a:t>
+              <a:t>Shift Integração (2)</a:t>
             </a:r>
           </a:p>
         </p:txBody>
@@ -5234,16 +5568,8 @@
               </a:defRPr>
             </a:pPr>
             <a:r>
-              <a:t>• [Shift Automação] MAX ION 800 — preparação para testes de novo analisador de eletrólitos; verificar sítio de instalação e contatar cliente com interfaceamento configurado
-• [Shift LIS] Máscara C216 — novo procedimento, enviar e-mail
-• [Shift LIS] Máscara RECALCRE — pegar laudo referência com apoio
-• [Shift LIS] Máscara IGE I5 — enviar e-mail
-• [Municípios] Capacitar técnicos de TI dos municípios para suporte autônomo (pós-bloqueio de acesso remoto externo)
-• [Rede/Servidores] Avaliar alternativa de acesso remoto para Shift ao SRV-AUTOMA (pós-bloqueio AnyDesk)
-• [Shift LIS] Máscara Metil. Russell P.G. — painel genético Pardini, esperando informações
-• [Shift LIS] Máscara PB19PCR — esperando validação, troca de setor Apoio → Biomol
-• [Shift LIS] Máscara IMUNOF24 — em progresso
-• [Shift LIS] Máscara MECP2 — esperando informações sobre laudo</a:t>
+              <a:t>• De/para antimicrobiano — Isoniazida (código Shift 635 → código MV 231) (29/06)
+• Criação da unidade de coleta "AMB CENTRO DE TRATAMENTO LABIOPALATAL" e de/para de integração (código Shift 423 → código MV 1230) (29/06)</a:t>
             </a:r>
           </a:p>
         </p:txBody>
@@ -5396,7 +5722,7 @@
             <a:avLst/>
           </a:prstGeom>
           <a:solidFill>
-            <a:srgbClr val="005F56"/>
+            <a:srgbClr val="00897B"/>
           </a:solidFill>
           <a:ln>
             <a:noFill/>
@@ -5498,7 +5824,7 @@
               </a:defRPr>
             </a:pPr>
             <a:r>
-              <a:t>Incidentes</a:t>
+              <a:t>Shift Automação (2)</a:t>
             </a:r>
           </a:p>
         </p:txBody>
@@ -5558,7 +5884,639 @@
               </a:defRPr>
             </a:pPr>
             <a:r>
-              <a:t>• 2026-06-16 — Bloqueio de ferramentas de acesso remoto externo</a:t>
+              <a:t>• ABL-800 — interface do gasômetro do HCM configurada para incorporar resultados de hemoglobinas (18/06)
+• CMV PCR (biomol) — tradução automática de resultado negativo: "-" → "Negativo", eliminando necessidade de correção manual pelos colaboradores (29/06)</a:t>
+            </a:r>
+          </a:p>
+        </p:txBody>
+      </p:sp>
+      <p:sp>
+        <p:nvSpPr>
+          <p:cNvPr id="7" name="Rectangle 6"/>
+          <p:cNvSpPr/>
+          <p:nvPr/>
+        </p:nvSpPr>
+        <p:spPr>
+          <a:xfrm>
+            <a:off x="0" y="6309360"/>
+            <a:ext cx="12191695" cy="548640"/>
+          </a:xfrm>
+          <a:prstGeom prst="rect">
+            <a:avLst/>
+          </a:prstGeom>
+          <a:solidFill>
+            <a:srgbClr val="F5F5F5"/>
+          </a:solidFill>
+          <a:ln>
+            <a:noFill/>
+          </a:ln>
+        </p:spPr>
+        <p:style>
+          <a:lnRef idx="1">
+            <a:schemeClr val="accent1"/>
+          </a:lnRef>
+          <a:fillRef idx="3">
+            <a:schemeClr val="accent1"/>
+          </a:fillRef>
+          <a:effectRef idx="2">
+            <a:schemeClr val="accent1"/>
+          </a:effectRef>
+          <a:fontRef idx="minor">
+            <a:schemeClr val="lt1"/>
+          </a:fontRef>
+        </p:style>
+        <p:txBody>
+          <a:bodyPr rtlCol="0" anchor="ctr"/>
+          <a:lstStyle/>
+          <a:p>
+            <a:pPr algn="ctr"/>
+          </a:p>
+        </p:txBody>
+      </p:sp>
+      <p:sp>
+        <p:nvSpPr>
+          <p:cNvPr id="8" name="TextBox 7"/>
+          <p:cNvSpPr txBox="1"/>
+          <p:nvPr/>
+        </p:nvSpPr>
+        <p:spPr>
+          <a:xfrm>
+            <a:off x="731520" y="6355080"/>
+            <a:ext cx="4572000" cy="365760"/>
+          </a:xfrm>
+          <a:prstGeom prst="rect">
+            <a:avLst/>
+          </a:prstGeom>
+          <a:noFill/>
+        </p:spPr>
+        <p:txBody>
+          <a:bodyPr wrap="square">
+            <a:spAutoFit/>
+          </a:bodyPr>
+          <a:lstStyle/>
+          <a:p>
+            <a:pPr algn="l">
+              <a:defRPr sz="1000" b="0">
+                <a:solidFill>
+                  <a:srgbClr val="757575"/>
+                </a:solidFill>
+                <a:latin typeface="Calibri"/>
+              </a:defRPr>
+            </a:pPr>
+            <a:r>
+              <a:t>Junho 2026</a:t>
+            </a:r>
+          </a:p>
+        </p:txBody>
+      </p:sp>
+      <p:sp>
+        <p:nvSpPr>
+          <p:cNvPr id="9" name="TextBox 8"/>
+          <p:cNvSpPr txBox="1"/>
+          <p:nvPr/>
+        </p:nvSpPr>
+        <p:spPr>
+          <a:xfrm>
+            <a:off x="6400800" y="6355080"/>
+            <a:ext cx="5029200" cy="365760"/>
+          </a:xfrm>
+          <a:prstGeom prst="rect">
+            <a:avLst/>
+          </a:prstGeom>
+          <a:noFill/>
+        </p:spPr>
+        <p:txBody>
+          <a:bodyPr wrap="square">
+            <a:spAutoFit/>
+          </a:bodyPr>
+          <a:lstStyle/>
+          <a:p>
+            <a:pPr algn="r">
+              <a:defRPr sz="1000" b="0">
+                <a:solidFill>
+                  <a:srgbClr val="757575"/>
+                </a:solidFill>
+                <a:latin typeface="Calibri"/>
+              </a:defRPr>
+            </a:pPr>
+            <a:r>
+              <a:t>TI Laboratório — FUNFARME</a:t>
+            </a:r>
+          </a:p>
+        </p:txBody>
+      </p:sp>
+    </p:spTree>
+  </p:cSld>
+  <p:clrMapOvr>
+    <a:masterClrMapping/>
+  </p:clrMapOvr>
+</p:sld>
+</file>
+
+<file path=ppt/slides/slide8.xml><?xml version="1.0" encoding="utf-8"?>
+<p:sld xmlns:a="http://schemas.openxmlformats.org/drawingml/2006/main" xmlns:p="http://schemas.openxmlformats.org/presentationml/2006/main" xmlns:r="http://schemas.openxmlformats.org/officeDocument/2006/relationships">
+  <p:cSld>
+    <p:spTree>
+      <p:nvGrpSpPr>
+        <p:cNvPr id="1" name=""/>
+        <p:cNvGrpSpPr/>
+        <p:nvPr/>
+      </p:nvGrpSpPr>
+      <p:grpSpPr/>
+      <p:sp>
+        <p:nvSpPr>
+          <p:cNvPr id="2" name="Rectangle 1"/>
+          <p:cNvSpPr/>
+          <p:nvPr/>
+        </p:nvSpPr>
+        <p:spPr>
+          <a:xfrm>
+            <a:off x="0" y="0"/>
+            <a:ext cx="12191695" cy="1005840"/>
+          </a:xfrm>
+          <a:prstGeom prst="rect">
+            <a:avLst/>
+          </a:prstGeom>
+          <a:solidFill>
+            <a:srgbClr val="00897B"/>
+          </a:solidFill>
+          <a:ln>
+            <a:noFill/>
+          </a:ln>
+        </p:spPr>
+        <p:style>
+          <a:lnRef idx="1">
+            <a:schemeClr val="accent1"/>
+          </a:lnRef>
+          <a:fillRef idx="3">
+            <a:schemeClr val="accent1"/>
+          </a:fillRef>
+          <a:effectRef idx="2">
+            <a:schemeClr val="accent1"/>
+          </a:effectRef>
+          <a:fontRef idx="minor">
+            <a:schemeClr val="lt1"/>
+          </a:fontRef>
+        </p:style>
+        <p:txBody>
+          <a:bodyPr rtlCol="0" anchor="ctr"/>
+          <a:lstStyle/>
+          <a:p>
+            <a:pPr algn="ctr"/>
+          </a:p>
+        </p:txBody>
+      </p:sp>
+      <p:sp>
+        <p:nvSpPr>
+          <p:cNvPr id="3" name="Rectangle 2"/>
+          <p:cNvSpPr/>
+          <p:nvPr/>
+        </p:nvSpPr>
+        <p:spPr>
+          <a:xfrm>
+            <a:off x="0" y="1005840"/>
+            <a:ext cx="12191695" cy="36576"/>
+          </a:xfrm>
+          <a:prstGeom prst="rect">
+            <a:avLst/>
+          </a:prstGeom>
+          <a:solidFill>
+            <a:srgbClr val="00BCD4"/>
+          </a:solidFill>
+          <a:ln>
+            <a:noFill/>
+          </a:ln>
+        </p:spPr>
+        <p:style>
+          <a:lnRef idx="1">
+            <a:schemeClr val="accent1"/>
+          </a:lnRef>
+          <a:fillRef idx="3">
+            <a:schemeClr val="accent1"/>
+          </a:fillRef>
+          <a:effectRef idx="2">
+            <a:schemeClr val="accent1"/>
+          </a:effectRef>
+          <a:fontRef idx="minor">
+            <a:schemeClr val="lt1"/>
+          </a:fontRef>
+        </p:style>
+        <p:txBody>
+          <a:bodyPr rtlCol="0" anchor="ctr"/>
+          <a:lstStyle/>
+          <a:p>
+            <a:pPr algn="ctr"/>
+          </a:p>
+        </p:txBody>
+      </p:sp>
+      <p:sp>
+        <p:nvSpPr>
+          <p:cNvPr id="4" name="TextBox 3"/>
+          <p:cNvSpPr txBox="1"/>
+          <p:nvPr/>
+        </p:nvSpPr>
+        <p:spPr>
+          <a:xfrm>
+            <a:off x="731520" y="228600"/>
+            <a:ext cx="9144000" cy="548640"/>
+          </a:xfrm>
+          <a:prstGeom prst="rect">
+            <a:avLst/>
+          </a:prstGeom>
+          <a:noFill/>
+        </p:spPr>
+        <p:txBody>
+          <a:bodyPr wrap="square">
+            <a:spAutoFit/>
+          </a:bodyPr>
+          <a:lstStyle/>
+          <a:p>
+            <a:pPr algn="l">
+              <a:defRPr sz="2800" b="1">
+                <a:solidFill>
+                  <a:srgbClr val="FFFFFF"/>
+                </a:solidFill>
+                <a:latin typeface="Calibri"/>
+              </a:defRPr>
+            </a:pPr>
+            <a:r>
+              <a:t>Municípios (2)</a:t>
+            </a:r>
+          </a:p>
+        </p:txBody>
+      </p:sp>
+      <p:pic>
+        <p:nvPicPr>
+          <p:cNvPr id="5" name="Picture 4" descr="nti.png"/>
+          <p:cNvPicPr>
+            <a:picLocks noChangeAspect="1"/>
+          </p:cNvPicPr>
+          <p:nvPr/>
+        </p:nvPicPr>
+        <p:blipFill>
+          <a:blip r:embed="rId2"/>
+          <a:stretch>
+            <a:fillRect/>
+          </a:stretch>
+        </p:blipFill>
+        <p:spPr>
+          <a:xfrm>
+            <a:off x="10241280" y="182880"/>
+            <a:ext cx="1626669" cy="594360"/>
+          </a:xfrm>
+          <a:prstGeom prst="rect">
+            <a:avLst/>
+          </a:prstGeom>
+        </p:spPr>
+      </p:pic>
+      <p:sp>
+        <p:nvSpPr>
+          <p:cNvPr id="6" name="TextBox 5"/>
+          <p:cNvSpPr txBox="1"/>
+          <p:nvPr/>
+        </p:nvSpPr>
+        <p:spPr>
+          <a:xfrm>
+            <a:off x="731520" y="1463040"/>
+            <a:ext cx="10515600" cy="4572000"/>
+          </a:xfrm>
+          <a:prstGeom prst="rect">
+            <a:avLst/>
+          </a:prstGeom>
+          <a:noFill/>
+        </p:spPr>
+        <p:txBody>
+          <a:bodyPr wrap="square">
+            <a:spAutoFit/>
+          </a:bodyPr>
+          <a:lstStyle/>
+          <a:p>
+            <a:pPr algn="l">
+              <a:defRPr sz="1400" b="0">
+                <a:solidFill>
+                  <a:srgbClr val="212121"/>
+                </a:solidFill>
+                <a:latin typeface="Calibri"/>
+              </a:defRPr>
+            </a:pPr>
+            <a:r>
+              <a:t>• Votuporanga — instalar sistema Shift na cidade (01/06)
+• Capacitar técnicos de TI dos municípios para suporte autônomo — grupo informado sobre como prosseguir perante ao bloqueio de acessos remotos (25/06)</a:t>
+            </a:r>
+          </a:p>
+        </p:txBody>
+      </p:sp>
+      <p:sp>
+        <p:nvSpPr>
+          <p:cNvPr id="7" name="Rectangle 6"/>
+          <p:cNvSpPr/>
+          <p:nvPr/>
+        </p:nvSpPr>
+        <p:spPr>
+          <a:xfrm>
+            <a:off x="0" y="6309360"/>
+            <a:ext cx="12191695" cy="548640"/>
+          </a:xfrm>
+          <a:prstGeom prst="rect">
+            <a:avLst/>
+          </a:prstGeom>
+          <a:solidFill>
+            <a:srgbClr val="F5F5F5"/>
+          </a:solidFill>
+          <a:ln>
+            <a:noFill/>
+          </a:ln>
+        </p:spPr>
+        <p:style>
+          <a:lnRef idx="1">
+            <a:schemeClr val="accent1"/>
+          </a:lnRef>
+          <a:fillRef idx="3">
+            <a:schemeClr val="accent1"/>
+          </a:fillRef>
+          <a:effectRef idx="2">
+            <a:schemeClr val="accent1"/>
+          </a:effectRef>
+          <a:fontRef idx="minor">
+            <a:schemeClr val="lt1"/>
+          </a:fontRef>
+        </p:style>
+        <p:txBody>
+          <a:bodyPr rtlCol="0" anchor="ctr"/>
+          <a:lstStyle/>
+          <a:p>
+            <a:pPr algn="ctr"/>
+          </a:p>
+        </p:txBody>
+      </p:sp>
+      <p:sp>
+        <p:nvSpPr>
+          <p:cNvPr id="8" name="TextBox 7"/>
+          <p:cNvSpPr txBox="1"/>
+          <p:nvPr/>
+        </p:nvSpPr>
+        <p:spPr>
+          <a:xfrm>
+            <a:off x="731520" y="6355080"/>
+            <a:ext cx="4572000" cy="365760"/>
+          </a:xfrm>
+          <a:prstGeom prst="rect">
+            <a:avLst/>
+          </a:prstGeom>
+          <a:noFill/>
+        </p:spPr>
+        <p:txBody>
+          <a:bodyPr wrap="square">
+            <a:spAutoFit/>
+          </a:bodyPr>
+          <a:lstStyle/>
+          <a:p>
+            <a:pPr algn="l">
+              <a:defRPr sz="1000" b="0">
+                <a:solidFill>
+                  <a:srgbClr val="757575"/>
+                </a:solidFill>
+                <a:latin typeface="Calibri"/>
+              </a:defRPr>
+            </a:pPr>
+            <a:r>
+              <a:t>Junho 2026</a:t>
+            </a:r>
+          </a:p>
+        </p:txBody>
+      </p:sp>
+      <p:sp>
+        <p:nvSpPr>
+          <p:cNvPr id="9" name="TextBox 8"/>
+          <p:cNvSpPr txBox="1"/>
+          <p:nvPr/>
+        </p:nvSpPr>
+        <p:spPr>
+          <a:xfrm>
+            <a:off x="6400800" y="6355080"/>
+            <a:ext cx="5029200" cy="365760"/>
+          </a:xfrm>
+          <a:prstGeom prst="rect">
+            <a:avLst/>
+          </a:prstGeom>
+          <a:noFill/>
+        </p:spPr>
+        <p:txBody>
+          <a:bodyPr wrap="square">
+            <a:spAutoFit/>
+          </a:bodyPr>
+          <a:lstStyle/>
+          <a:p>
+            <a:pPr algn="r">
+              <a:defRPr sz="1000" b="0">
+                <a:solidFill>
+                  <a:srgbClr val="757575"/>
+                </a:solidFill>
+                <a:latin typeface="Calibri"/>
+              </a:defRPr>
+            </a:pPr>
+            <a:r>
+              <a:t>TI Laboratório — FUNFARME</a:t>
+            </a:r>
+          </a:p>
+        </p:txBody>
+      </p:sp>
+    </p:spTree>
+  </p:cSld>
+  <p:clrMapOvr>
+    <a:masterClrMapping/>
+  </p:clrMapOvr>
+</p:sld>
+</file>
+
+<file path=ppt/slides/slide9.xml><?xml version="1.0" encoding="utf-8"?>
+<p:sld xmlns:a="http://schemas.openxmlformats.org/drawingml/2006/main" xmlns:p="http://schemas.openxmlformats.org/presentationml/2006/main" xmlns:r="http://schemas.openxmlformats.org/officeDocument/2006/relationships">
+  <p:cSld>
+    <p:spTree>
+      <p:nvGrpSpPr>
+        <p:cNvPr id="1" name=""/>
+        <p:cNvGrpSpPr/>
+        <p:nvPr/>
+      </p:nvGrpSpPr>
+      <p:grpSpPr/>
+      <p:sp>
+        <p:nvSpPr>
+          <p:cNvPr id="2" name="Rectangle 1"/>
+          <p:cNvSpPr/>
+          <p:nvPr/>
+        </p:nvSpPr>
+        <p:spPr>
+          <a:xfrm>
+            <a:off x="0" y="0"/>
+            <a:ext cx="12191695" cy="1005840"/>
+          </a:xfrm>
+          <a:prstGeom prst="rect">
+            <a:avLst/>
+          </a:prstGeom>
+          <a:solidFill>
+            <a:srgbClr val="005F56"/>
+          </a:solidFill>
+          <a:ln>
+            <a:noFill/>
+          </a:ln>
+        </p:spPr>
+        <p:style>
+          <a:lnRef idx="1">
+            <a:schemeClr val="accent1"/>
+          </a:lnRef>
+          <a:fillRef idx="3">
+            <a:schemeClr val="accent1"/>
+          </a:fillRef>
+          <a:effectRef idx="2">
+            <a:schemeClr val="accent1"/>
+          </a:effectRef>
+          <a:fontRef idx="minor">
+            <a:schemeClr val="lt1"/>
+          </a:fontRef>
+        </p:style>
+        <p:txBody>
+          <a:bodyPr rtlCol="0" anchor="ctr"/>
+          <a:lstStyle/>
+          <a:p>
+            <a:pPr algn="ctr"/>
+          </a:p>
+        </p:txBody>
+      </p:sp>
+      <p:sp>
+        <p:nvSpPr>
+          <p:cNvPr id="3" name="Rectangle 2"/>
+          <p:cNvSpPr/>
+          <p:nvPr/>
+        </p:nvSpPr>
+        <p:spPr>
+          <a:xfrm>
+            <a:off x="0" y="1005840"/>
+            <a:ext cx="12191695" cy="36576"/>
+          </a:xfrm>
+          <a:prstGeom prst="rect">
+            <a:avLst/>
+          </a:prstGeom>
+          <a:solidFill>
+            <a:srgbClr val="00BCD4"/>
+          </a:solidFill>
+          <a:ln>
+            <a:noFill/>
+          </a:ln>
+        </p:spPr>
+        <p:style>
+          <a:lnRef idx="1">
+            <a:schemeClr val="accent1"/>
+          </a:lnRef>
+          <a:fillRef idx="3">
+            <a:schemeClr val="accent1"/>
+          </a:fillRef>
+          <a:effectRef idx="2">
+            <a:schemeClr val="accent1"/>
+          </a:effectRef>
+          <a:fontRef idx="minor">
+            <a:schemeClr val="lt1"/>
+          </a:fontRef>
+        </p:style>
+        <p:txBody>
+          <a:bodyPr rtlCol="0" anchor="ctr"/>
+          <a:lstStyle/>
+          <a:p>
+            <a:pPr algn="ctr"/>
+          </a:p>
+        </p:txBody>
+      </p:sp>
+      <p:sp>
+        <p:nvSpPr>
+          <p:cNvPr id="4" name="TextBox 3"/>
+          <p:cNvSpPr txBox="1"/>
+          <p:nvPr/>
+        </p:nvSpPr>
+        <p:spPr>
+          <a:xfrm>
+            <a:off x="731520" y="228600"/>
+            <a:ext cx="9144000" cy="548640"/>
+          </a:xfrm>
+          <a:prstGeom prst="rect">
+            <a:avLst/>
+          </a:prstGeom>
+          <a:noFill/>
+        </p:spPr>
+        <p:txBody>
+          <a:bodyPr wrap="square">
+            <a:spAutoFit/>
+          </a:bodyPr>
+          <a:lstStyle/>
+          <a:p>
+            <a:pPr algn="l">
+              <a:defRPr sz="2800" b="1">
+                <a:solidFill>
+                  <a:srgbClr val="FFFFFF"/>
+                </a:solidFill>
+                <a:latin typeface="Calibri"/>
+              </a:defRPr>
+            </a:pPr>
+            <a:r>
+              <a:t>Pendências</a:t>
+            </a:r>
+          </a:p>
+        </p:txBody>
+      </p:sp>
+      <p:pic>
+        <p:nvPicPr>
+          <p:cNvPr id="5" name="Picture 4" descr="nti.png"/>
+          <p:cNvPicPr>
+            <a:picLocks noChangeAspect="1"/>
+          </p:cNvPicPr>
+          <p:nvPr/>
+        </p:nvPicPr>
+        <p:blipFill>
+          <a:blip r:embed="rId2"/>
+          <a:stretch>
+            <a:fillRect/>
+          </a:stretch>
+        </p:blipFill>
+        <p:spPr>
+          <a:xfrm>
+            <a:off x="10241280" y="182880"/>
+            <a:ext cx="1626669" cy="594360"/>
+          </a:xfrm>
+          <a:prstGeom prst="rect">
+            <a:avLst/>
+          </a:prstGeom>
+        </p:spPr>
+      </p:pic>
+      <p:sp>
+        <p:nvSpPr>
+          <p:cNvPr id="6" name="TextBox 5"/>
+          <p:cNvSpPr txBox="1"/>
+          <p:nvPr/>
+        </p:nvSpPr>
+        <p:spPr>
+          <a:xfrm>
+            <a:off x="731520" y="1463040"/>
+            <a:ext cx="10515600" cy="4572000"/>
+          </a:xfrm>
+          <a:prstGeom prst="rect">
+            <a:avLst/>
+          </a:prstGeom>
+          <a:noFill/>
+        </p:spPr>
+        <p:txBody>
+          <a:bodyPr wrap="square">
+            <a:spAutoFit/>
+          </a:bodyPr>
+          <a:lstStyle/>
+          <a:p>
+            <a:pPr algn="l">
+              <a:defRPr sz="1400" b="0">
+                <a:solidFill>
+                  <a:srgbClr val="212121"/>
+                </a:solidFill>
+                <a:latin typeface="Calibri"/>
+              </a:defRPr>
+            </a:pPr>
+            <a:r>
+              <a:t>• [Shift Automação] MAX ION 800 — equipamento recebido; testes de controle e treinamento com equipe da bioquímica concluídos; preparando infraestrutura para interfaceamento (previsão: semana de 30/06)</a:t>
             </a:r>
           </a:p>
         </p:txBody>

</xml_diff>

<commit_message>
feat: melhora template do relatório mensal e documenta fluxo de máscaras
- gera-relatorio.py: gráficos nativos (barras/colunas) em vez de texto,
  cores por categoria, listas com marcadores reais, layout em 2 colunas
  para categorias com muitas tarefas, correção do bug que quebrava as
  logos ao clonar slides (relação de imagem não era recriada)
- remove slide de distribuição semanal do PPTX (não usado)
- portal: checklist do fluxo completo de criação de máscara e tabela
  de assinaturas de laboratórios de apoio (Hermes Pardini, DB, Fleury,
  Instituto Adolfo Lutz)
- regenera relatório de junho/2026 com o novo template
</commit_message>
<xml_diff>
--- a/reports/2026-06_resumo-mensal.pptx
+++ b/reports/2026-06_resumo-mensal.pptx
@@ -114,6 +114,217 @@
     </a:lvl9pPr>
   </p:defaultTextStyle>
 </p:presentation>
+</file>
+
+<file path=ppt/charts/chart1.xml><?xml version="1.0" encoding="utf-8"?>
+<c:chartSpace xmlns:c="http://schemas.openxmlformats.org/drawingml/2006/chart" xmlns:a="http://schemas.openxmlformats.org/drawingml/2006/main" xmlns:r="http://schemas.openxmlformats.org/officeDocument/2006/relationships">
+  <c:date1904 val="0"/>
+  <c:chart>
+    <c:autoTitleDeleted val="0"/>
+    <c:plotArea>
+      <c:barChart>
+        <c:barDir val="bar"/>
+        <c:grouping val="clustered"/>
+        <c:ser>
+          <c:idx val="0"/>
+          <c:order val="0"/>
+          <c:tx>
+            <c:strRef>
+              <c:f>Sheet1!$B$1</c:f>
+              <c:strCache>
+                <c:ptCount val="1"/>
+                <c:pt idx="0">
+                  <c:v>Tarefas concluídas</c:v>
+                </c:pt>
+              </c:strCache>
+            </c:strRef>
+          </c:tx>
+          <c:dPt>
+            <c:idx val="0"/>
+            <c:spPr>
+              <a:solidFill>
+                <a:srgbClr val="00897B"/>
+              </a:solidFill>
+            </c:spPr>
+          </c:dPt>
+          <c:dPt>
+            <c:idx val="1"/>
+            <c:spPr>
+              <a:solidFill>
+                <a:srgbClr val="00ACC1"/>
+              </a:solidFill>
+            </c:spPr>
+          </c:dPt>
+          <c:dPt>
+            <c:idx val="2"/>
+            <c:spPr>
+              <a:solidFill>
+                <a:srgbClr val="546E7A"/>
+              </a:solidFill>
+            </c:spPr>
+          </c:dPt>
+          <c:dPt>
+            <c:idx val="3"/>
+            <c:spPr>
+              <a:solidFill>
+                <a:srgbClr val="5C6BC0"/>
+              </a:solidFill>
+            </c:spPr>
+          </c:dPt>
+          <c:dPt>
+            <c:idx val="4"/>
+            <c:spPr>
+              <a:solidFill>
+                <a:srgbClr val="FFA000"/>
+              </a:solidFill>
+            </c:spPr>
+          </c:dPt>
+          <c:dPt>
+            <c:idx val="5"/>
+            <c:spPr>
+              <a:solidFill>
+                <a:srgbClr val="8D6E63"/>
+              </a:solidFill>
+            </c:spPr>
+          </c:dPt>
+          <c:cat>
+            <c:strRef>
+              <c:f>Sheet1!$A$2:$A$7</c:f>
+              <c:strCache>
+                <c:ptCount val="6"/>
+                <c:pt idx="0">
+                  <c:v>Shift LIS</c:v>
+                </c:pt>
+                <c:pt idx="1">
+                  <c:v>Shift Integração</c:v>
+                </c:pt>
+                <c:pt idx="2">
+                  <c:v>Rede/Servidores</c:v>
+                </c:pt>
+                <c:pt idx="3">
+                  <c:v>Shift Automação</c:v>
+                </c:pt>
+                <c:pt idx="4">
+                  <c:v>Municípios</c:v>
+                </c:pt>
+                <c:pt idx="5">
+                  <c:v>Shift Cadastro</c:v>
+                </c:pt>
+              </c:strCache>
+            </c:strRef>
+          </c:cat>
+          <c:val>
+            <c:numRef>
+              <c:f>Sheet1!$B$2:$B$7</c:f>
+              <c:numCache>
+                <c:formatCode>General</c:formatCode>
+                <c:ptCount val="6"/>
+                <c:pt idx="0">
+                  <c:v>22</c:v>
+                </c:pt>
+                <c:pt idx="1">
+                  <c:v>8</c:v>
+                </c:pt>
+                <c:pt idx="2">
+                  <c:v>2</c:v>
+                </c:pt>
+                <c:pt idx="3">
+                  <c:v>2</c:v>
+                </c:pt>
+                <c:pt idx="4">
+                  <c:v>2</c:v>
+                </c:pt>
+                <c:pt idx="5">
+                  <c:v>1</c:v>
+                </c:pt>
+              </c:numCache>
+            </c:numRef>
+          </c:val>
+        </c:ser>
+        <c:dLbls>
+          <c:txPr>
+            <a:bodyPr/>
+            <a:lstStyle/>
+            <a:p>
+              <a:pPr>
+                <a:defRPr sz="1400" b="1">
+                  <a:solidFill>
+                    <a:srgbClr val="212121"/>
+                  </a:solidFill>
+                </a:defRPr>
+              </a:pPr>
+            </a:p>
+          </c:txPr>
+          <c:showLegendKey val="0"/>
+          <c:showVal val="1"/>
+          <c:showCatName val="0"/>
+          <c:showSerName val="0"/>
+          <c:showPercent val="0"/>
+          <c:showBubbleSize val="0"/>
+          <c:showLeaderLines val="1"/>
+        </c:dLbls>
+        <c:gapWidth val="60"/>
+        <c:axId val="-2068027336"/>
+        <c:axId val="-2113994440"/>
+      </c:barChart>
+      <c:catAx>
+        <c:axId val="-2068027336"/>
+        <c:scaling>
+          <c:orientation val="maxMin"/>
+        </c:scaling>
+        <c:delete val="0"/>
+        <c:axPos val="l"/>
+        <c:majorTickMark val="out"/>
+        <c:minorTickMark val="none"/>
+        <c:tickLblPos val="nextTo"/>
+        <c:txPr>
+          <a:bodyPr/>
+          <a:lstStyle/>
+          <a:p>
+            <a:pPr>
+              <a:defRPr sz="1400">
+                <a:solidFill>
+                  <a:srgbClr val="212121"/>
+                </a:solidFill>
+              </a:defRPr>
+            </a:pPr>
+          </a:p>
+        </c:txPr>
+        <c:crossAx val="-2113994440"/>
+        <c:crosses val="autoZero"/>
+        <c:auto val="1"/>
+        <c:lblAlgn val="ctr"/>
+        <c:lblOffset val="100"/>
+        <c:noMultiLvlLbl val="0"/>
+      </c:catAx>
+      <c:valAx>
+        <c:axId val="-2113994440"/>
+        <c:scaling/>
+        <c:delete/>
+        <c:axPos val="b"/>
+        <c:majorTickMark val="out"/>
+        <c:minorTickMark val="none"/>
+        <c:tickLblPos val="nextTo"/>
+        <c:crossAx val="-2068027336"/>
+        <c:crosses val="autoZero"/>
+      </c:valAx>
+    </c:plotArea>
+    <c:dispBlanksAs val="gap"/>
+  </c:chart>
+  <c:txPr>
+    <a:bodyPr/>
+    <a:lstStyle/>
+    <a:p>
+      <a:pPr>
+        <a:defRPr sz="1800"/>
+      </a:pPr>
+      <a:endParaRPr lang="en-US"/>
+    </a:p>
+  </c:txPr>
+  <c:externalData r:id="rId1">
+    <c:autoUpdate val="0"/>
+  </c:externalData>
+</c:chartSpace>
 </file>
 
 <file path=ppt/slideLayouts/slideLayout1.xml><?xml version="1.0" encoding="utf-8"?>
@@ -3449,7 +3660,12 @@
               </a:defRPr>
             </a:pPr>
             <a:r>
-              <a:t>30</a:t>
+              <a:rPr b="1">
+                <a:solidFill>
+                  <a:srgbClr val="00897B"/>
+                </a:solidFill>
+              </a:rPr>
+              <a:t>37</a:t>
             </a:r>
           </a:p>
         </p:txBody>
@@ -3564,6 +3780,11 @@
               </a:defRPr>
             </a:pPr>
             <a:r>
+              <a:rPr b="1">
+                <a:solidFill>
+                  <a:srgbClr val="F9A825"/>
+                </a:solidFill>
+              </a:rPr>
               <a:t>1</a:t>
             </a:r>
           </a:p>
@@ -3679,7 +3900,12 @@
               </a:defRPr>
             </a:pPr>
             <a:r>
-              <a:t>4</a:t>
+              <a:rPr b="1">
+                <a:solidFill>
+                  <a:srgbClr val="C62828"/>
+                </a:solidFill>
+              </a:rPr>
+              <a:t>5</a:t>
             </a:r>
           </a:p>
         </p:txBody>
@@ -3796,7 +4022,7 @@
             <a:avLst/>
           </a:prstGeom>
           <a:solidFill>
-            <a:srgbClr val="005F56"/>
+            <a:srgbClr val="C62828"/>
           </a:solidFill>
           <a:ln>
             <a:noFill/>
@@ -3945,11 +4171,23 @@
         </p:spPr>
         <p:txBody>
           <a:bodyPr wrap="square">
-            <a:spAutoFit/>
+            <a:noAutofit/>
           </a:bodyPr>
           <a:lstStyle/>
           <a:p>
-            <a:pPr algn="l">
+            <a:pPr algn="l" marL="228600" indent="-228600">
+              <a:lnSpc>
+                <a:spcPct val="115000"/>
+              </a:lnSpc>
+              <a:spcAft>
+                <a:spcPts val="1200"/>
+              </a:spcAft>
+              <a:buClr>
+                <a:srgbClr val="C62828"/>
+              </a:buClr>
+              <a:buSzPct val="65000"/>
+              <a:buFont typeface="Arial"/>
+              <a:buChar char="●"/>
               <a:defRPr sz="1400" b="0">
                 <a:solidFill>
                   <a:srgbClr val="212121"/>
@@ -3958,10 +4196,158 @@
               </a:defRPr>
             </a:pPr>
             <a:r>
-              <a:t>• 2026-06-16 — I1 — Bloqueio de ferramentas de acesso remoto externo
-• 2026-06-25 — I2 — Divergência de user-id entre Shift e MV — Caroline
-• 2026-06-25 — I3 — Imagens Cobas 6500 II não consumidas — 15/05/2026
-• 2026-06-25 — I4 — Queda geral do Shift LIS</a:t>
+              <a:rPr sz="1800" b="1" i="0">
+                <a:solidFill>
+                  <a:srgbClr val="C62828"/>
+                </a:solidFill>
+                <a:latin typeface="Arial"/>
+              </a:rPr>
+              <a:t>2026-06-16  </a:t>
+            </a:r>
+            <a:r>
+              <a:rPr sz="1800" b="0" i="0">
+                <a:solidFill>
+                  <a:srgbClr val="212121"/>
+                </a:solidFill>
+                <a:latin typeface="Arial"/>
+              </a:rPr>
+              <a:t>I1 — Bloqueio de ferramentas de acesso remoto externo</a:t>
+            </a:r>
+          </a:p>
+          <a:p>
+            <a:pPr marL="228600" indent="-228600">
+              <a:lnSpc>
+                <a:spcPct val="115000"/>
+              </a:lnSpc>
+              <a:spcAft>
+                <a:spcPts val="1200"/>
+              </a:spcAft>
+              <a:buClr>
+                <a:srgbClr val="C62828"/>
+              </a:buClr>
+              <a:buSzPct val="65000"/>
+              <a:buFont typeface="Arial"/>
+              <a:buChar char="●"/>
+            </a:pPr>
+            <a:r>
+              <a:rPr sz="1800" b="1" i="0">
+                <a:solidFill>
+                  <a:srgbClr val="C62828"/>
+                </a:solidFill>
+                <a:latin typeface="Arial"/>
+              </a:rPr>
+              <a:t>2026-06-25  </a:t>
+            </a:r>
+            <a:r>
+              <a:rPr sz="1800" b="0" i="0">
+                <a:solidFill>
+                  <a:srgbClr val="212121"/>
+                </a:solidFill>
+                <a:latin typeface="Arial"/>
+              </a:rPr>
+              <a:t>I2 — Divergência de user-id entre Shift e MV — Caroline</a:t>
+            </a:r>
+          </a:p>
+          <a:p>
+            <a:pPr marL="228600" indent="-228600">
+              <a:lnSpc>
+                <a:spcPct val="115000"/>
+              </a:lnSpc>
+              <a:spcAft>
+                <a:spcPts val="1200"/>
+              </a:spcAft>
+              <a:buClr>
+                <a:srgbClr val="C62828"/>
+              </a:buClr>
+              <a:buSzPct val="65000"/>
+              <a:buFont typeface="Arial"/>
+              <a:buChar char="●"/>
+            </a:pPr>
+            <a:r>
+              <a:rPr sz="1800" b="1" i="0">
+                <a:solidFill>
+                  <a:srgbClr val="C62828"/>
+                </a:solidFill>
+                <a:latin typeface="Arial"/>
+              </a:rPr>
+              <a:t>2026-06-25  </a:t>
+            </a:r>
+            <a:r>
+              <a:rPr sz="1800" b="0" i="0">
+                <a:solidFill>
+                  <a:srgbClr val="212121"/>
+                </a:solidFill>
+                <a:latin typeface="Arial"/>
+              </a:rPr>
+              <a:t>I3 — Imagens Cobas 6500 II não consumidas — 15/05/2026</a:t>
+            </a:r>
+          </a:p>
+          <a:p>
+            <a:pPr marL="228600" indent="-228600">
+              <a:lnSpc>
+                <a:spcPct val="115000"/>
+              </a:lnSpc>
+              <a:spcAft>
+                <a:spcPts val="1200"/>
+              </a:spcAft>
+              <a:buClr>
+                <a:srgbClr val="C62828"/>
+              </a:buClr>
+              <a:buSzPct val="65000"/>
+              <a:buFont typeface="Arial"/>
+              <a:buChar char="●"/>
+            </a:pPr>
+            <a:r>
+              <a:rPr sz="1800" b="1" i="0">
+                <a:solidFill>
+                  <a:srgbClr val="C62828"/>
+                </a:solidFill>
+                <a:latin typeface="Arial"/>
+              </a:rPr>
+              <a:t>2026-06-25  </a:t>
+            </a:r>
+            <a:r>
+              <a:rPr sz="1800" b="0" i="0">
+                <a:solidFill>
+                  <a:srgbClr val="212121"/>
+                </a:solidFill>
+                <a:latin typeface="Arial"/>
+              </a:rPr>
+              <a:t>I4 — Queda geral do Shift LIS</a:t>
+            </a:r>
+          </a:p>
+          <a:p>
+            <a:pPr marL="228600" indent="-228600">
+              <a:lnSpc>
+                <a:spcPct val="115000"/>
+              </a:lnSpc>
+              <a:spcAft>
+                <a:spcPts val="1200"/>
+              </a:spcAft>
+              <a:buClr>
+                <a:srgbClr val="C62828"/>
+              </a:buClr>
+              <a:buSzPct val="65000"/>
+              <a:buFont typeface="Arial"/>
+              <a:buChar char="●"/>
+            </a:pPr>
+            <a:r>
+              <a:rPr sz="1800" b="1" i="0">
+                <a:solidFill>
+                  <a:srgbClr val="C62828"/>
+                </a:solidFill>
+                <a:latin typeface="Arial"/>
+              </a:rPr>
+              <a:t>2026-06-30  </a:t>
+            </a:r>
+            <a:r>
+              <a:rPr sz="1800" b="0" i="0">
+                <a:solidFill>
+                  <a:srgbClr val="212121"/>
+                </a:solidFill>
+                <a:latin typeface="Arial"/>
+              </a:rPr>
+              <a:t>I5 — Erros de exportação por falta de de/para de antibiogramas</a:t>
             </a:r>
           </a:p>
         </p:txBody>
@@ -4247,47 +4633,6 @@
       </p:pic>
       <p:sp>
         <p:nvSpPr>
-          <p:cNvPr id="6" name="TextBox 5"/>
-          <p:cNvSpPr txBox="1"/>
-          <p:nvPr/>
-        </p:nvSpPr>
-        <p:spPr>
-          <a:xfrm>
-            <a:off x="731520" y="1463040"/>
-            <a:ext cx="10058400" cy="4572000"/>
-          </a:xfrm>
-          <a:prstGeom prst="rect">
-            <a:avLst/>
-          </a:prstGeom>
-          <a:noFill/>
-        </p:spPr>
-        <p:txBody>
-          <a:bodyPr wrap="square">
-            <a:spAutoFit/>
-          </a:bodyPr>
-          <a:lstStyle/>
-          <a:p>
-            <a:pPr algn="l">
-              <a:defRPr sz="1600" b="0">
-                <a:solidFill>
-                  <a:srgbClr val="212121"/>
-                </a:solidFill>
-                <a:latin typeface="Calibri"/>
-              </a:defRPr>
-            </a:pPr>
-            <a:r>
-              <a:t>Shift LIS: 22 tarefas
-Rede/Servidores: 2 tarefas
-Shift Integração: 2 tarefas
-Shift Automação: 2 tarefas
-Municípios: 2 tarefas
-Total: 30</a:t>
-            </a:r>
-          </a:p>
-        </p:txBody>
-      </p:sp>
-      <p:sp>
-        <p:nvSpPr>
           <p:cNvPr id="7" name="Rectangle 6"/>
           <p:cNvSpPr/>
           <p:nvPr/>
@@ -4401,6 +4746,58 @@
           </a:p>
         </p:txBody>
       </p:sp>
+      <p:sp>
+        <p:nvSpPr>
+          <p:cNvPr id="10" name="TextBox 9"/>
+          <p:cNvSpPr txBox="1"/>
+          <p:nvPr/>
+        </p:nvSpPr>
+        <p:spPr>
+          <a:xfrm>
+            <a:off x="731520" y="1107440"/>
+            <a:ext cx="10058400" cy="355600"/>
+          </a:xfrm>
+          <a:prstGeom prst="rect">
+            <a:avLst/>
+          </a:prstGeom>
+          <a:noFill/>
+        </p:spPr>
+        <p:txBody>
+          <a:bodyPr wrap="none">
+            <a:spAutoFit/>
+          </a:bodyPr>
+          <a:lstStyle/>
+          <a:p>
+            <a:r>
+              <a:rPr sz="1400" b="0" i="0">
+                <a:solidFill>
+                  <a:srgbClr val="757575"/>
+                </a:solidFill>
+                <a:latin typeface="Arial"/>
+              </a:rPr>
+              <a:t>Total: 37 tarefas concluídas</a:t>
+            </a:r>
+          </a:p>
+        </p:txBody>
+      </p:sp>
+      <p:graphicFrame>
+        <p:nvGraphicFramePr>
+          <p:cNvPr id="11" name="Chart 10"/>
+          <p:cNvGraphicFramePr>
+            <a:graphicFrameLocks noGrp="1"/>
+          </p:cNvGraphicFramePr>
+          <p:nvPr/>
+        </p:nvGraphicFramePr>
+        <p:xfrm>
+          <a:off x="731520" y="1463040"/>
+          <a:ext cx="10058400" cy="4572000"/>
+        </p:xfrm>
+        <a:graphic>
+          <a:graphicData uri="http://schemas.openxmlformats.org/drawingml/2006/chart">
+            <c:chart xmlns:c="http://schemas.openxmlformats.org/drawingml/2006/chart" r:id="rId3"/>
+          </a:graphicData>
+        </a:graphic>
+      </p:graphicFrame>
     </p:spTree>
   </p:cSld>
   <p:clrMapOvr>
@@ -4536,7 +4933,7 @@
               </a:defRPr>
             </a:pPr>
             <a:r>
-              <a:t>Distribuição Semanal</a:t>
+              <a:t>Shift LIS (22)</a:t>
             </a:r>
           </a:p>
         </p:txBody>
@@ -4567,47 +4964,6 @@
       </p:pic>
       <p:sp>
         <p:nvSpPr>
-          <p:cNvPr id="6" name="TextBox 5"/>
-          <p:cNvSpPr txBox="1"/>
-          <p:nvPr/>
-        </p:nvSpPr>
-        <p:spPr>
-          <a:xfrm>
-            <a:off x="731520" y="1463040"/>
-            <a:ext cx="10058400" cy="4572000"/>
-          </a:xfrm>
-          <a:prstGeom prst="rect">
-            <a:avLst/>
-          </a:prstGeom>
-          <a:noFill/>
-        </p:spPr>
-        <p:txBody>
-          <a:bodyPr wrap="square">
-            <a:spAutoFit/>
-          </a:bodyPr>
-          <a:lstStyle/>
-          <a:p>
-            <a:pPr algn="l">
-              <a:defRPr sz="1600" b="0">
-                <a:solidFill>
-                  <a:srgbClr val="212121"/>
-                </a:solidFill>
-                <a:latin typeface="Calibri"/>
-              </a:defRPr>
-            </a:pPr>
-            <a:r>
-              <a:t>Semana 1 (01/06–07/06): 4 tarefas
-Semana 2 (08/06–14/06): 5 tarefas
-Semana 3 (15/06–21/06): 8 tarefas
-Semana 4 (22/06–28/06): 9 tarefas
-Semana 5 (29/06–30/06): 4 tarefas
-</a:t>
-            </a:r>
-          </a:p>
-        </p:txBody>
-      </p:sp>
-      <p:sp>
-        <p:nvSpPr>
           <p:cNvPr id="7" name="Rectangle 6"/>
           <p:cNvSpPr/>
           <p:nvPr/>
@@ -4717,6 +5073,800 @@
             </a:pPr>
             <a:r>
               <a:t>TI Laboratório — FUNFARME</a:t>
+            </a:r>
+          </a:p>
+        </p:txBody>
+      </p:sp>
+      <p:sp>
+        <p:nvSpPr>
+          <p:cNvPr id="10" name="TextBox 9"/>
+          <p:cNvSpPr txBox="1"/>
+          <p:nvPr/>
+        </p:nvSpPr>
+        <p:spPr>
+          <a:xfrm>
+            <a:off x="731520" y="1463040"/>
+            <a:ext cx="5074920" cy="4572000"/>
+          </a:xfrm>
+          <a:prstGeom prst="rect">
+            <a:avLst/>
+          </a:prstGeom>
+          <a:noFill/>
+        </p:spPr>
+        <p:txBody>
+          <a:bodyPr wrap="square">
+            <a:noAutofit/>
+          </a:bodyPr>
+          <a:lstStyle/>
+          <a:p>
+            <a:pPr marL="228600" indent="-228600">
+              <a:lnSpc>
+                <a:spcPct val="115000"/>
+              </a:lnSpc>
+              <a:spcAft>
+                <a:spcPts val="800"/>
+              </a:spcAft>
+              <a:buClr>
+                <a:srgbClr val="00897B"/>
+              </a:buClr>
+              <a:buSzPct val="65000"/>
+              <a:buFont typeface="Arial"/>
+              <a:buChar char="●"/>
+            </a:pPr>
+            <a:r>
+              <a:rPr sz="1400" b="0" i="0">
+                <a:solidFill>
+                  <a:srgbClr val="212121"/>
+                </a:solidFill>
+                <a:latin typeface="Arial"/>
+              </a:rPr>
+              <a:t>Máscara SDHEA</a:t>
+            </a:r>
+            <a:r>
+              <a:rPr sz="1200" b="0" i="1">
+                <a:solidFill>
+                  <a:srgbClr val="757575"/>
+                </a:solidFill>
+                <a:latin typeface="Arial"/>
+              </a:rPr>
+              <a:t>   01/06</a:t>
+            </a:r>
+          </a:p>
+          <a:p>
+            <a:pPr marL="228600" indent="-228600">
+              <a:lnSpc>
+                <a:spcPct val="115000"/>
+              </a:lnSpc>
+              <a:spcAft>
+                <a:spcPts val="800"/>
+              </a:spcAft>
+              <a:buClr>
+                <a:srgbClr val="00897B"/>
+              </a:buClr>
+              <a:buSzPct val="65000"/>
+              <a:buFont typeface="Arial"/>
+              <a:buChar char="●"/>
+            </a:pPr>
+            <a:r>
+              <a:rPr sz="1400" b="0" i="0">
+                <a:solidFill>
+                  <a:srgbClr val="212121"/>
+                </a:solidFill>
+                <a:latin typeface="Arial"/>
+              </a:rPr>
+              <a:t>Máscara ANFETUR</a:t>
+            </a:r>
+            <a:r>
+              <a:rPr sz="1200" b="0" i="1">
+                <a:solidFill>
+                  <a:srgbClr val="757575"/>
+                </a:solidFill>
+                <a:latin typeface="Arial"/>
+              </a:rPr>
+              <a:t>   01/06</a:t>
+            </a:r>
+          </a:p>
+          <a:p>
+            <a:pPr marL="228600" indent="-228600">
+              <a:lnSpc>
+                <a:spcPct val="115000"/>
+              </a:lnSpc>
+              <a:spcAft>
+                <a:spcPts val="800"/>
+              </a:spcAft>
+              <a:buClr>
+                <a:srgbClr val="00897B"/>
+              </a:buClr>
+              <a:buSzPct val="65000"/>
+              <a:buFont typeface="Arial"/>
+              <a:buChar char="●"/>
+            </a:pPr>
+            <a:r>
+              <a:rPr sz="1400" b="0" i="0">
+                <a:solidFill>
+                  <a:srgbClr val="212121"/>
+                </a:solidFill>
+                <a:latin typeface="Arial"/>
+              </a:rPr>
+              <a:t>Máscara PQUINASE</a:t>
+            </a:r>
+            <a:r>
+              <a:rPr sz="1200" b="0" i="1">
+                <a:solidFill>
+                  <a:srgbClr val="757575"/>
+                </a:solidFill>
+                <a:latin typeface="Arial"/>
+              </a:rPr>
+              <a:t>   03/06</a:t>
+            </a:r>
+          </a:p>
+          <a:p>
+            <a:pPr marL="228600" indent="-228600">
+              <a:lnSpc>
+                <a:spcPct val="115000"/>
+              </a:lnSpc>
+              <a:spcAft>
+                <a:spcPts val="800"/>
+              </a:spcAft>
+              <a:buClr>
+                <a:srgbClr val="00897B"/>
+              </a:buClr>
+              <a:buSzPct val="65000"/>
+              <a:buFont typeface="Arial"/>
+              <a:buChar char="●"/>
+            </a:pPr>
+            <a:r>
+              <a:rPr sz="1400" b="0" i="0">
+                <a:solidFill>
+                  <a:srgbClr val="212121"/>
+                </a:solidFill>
+                <a:latin typeface="Arial"/>
+              </a:rPr>
+              <a:t>Máscara OSMOUR</a:t>
+            </a:r>
+            <a:r>
+              <a:rPr sz="1200" b="0" i="1">
+                <a:solidFill>
+                  <a:srgbClr val="757575"/>
+                </a:solidFill>
+                <a:latin typeface="Arial"/>
+              </a:rPr>
+              <a:t>   09/06</a:t>
+            </a:r>
+          </a:p>
+          <a:p>
+            <a:pPr marL="228600" indent="-228600">
+              <a:lnSpc>
+                <a:spcPct val="115000"/>
+              </a:lnSpc>
+              <a:spcAft>
+                <a:spcPts val="800"/>
+              </a:spcAft>
+              <a:buClr>
+                <a:srgbClr val="00897B"/>
+              </a:buClr>
+              <a:buSzPct val="65000"/>
+              <a:buFont typeface="Arial"/>
+              <a:buChar char="●"/>
+            </a:pPr>
+            <a:r>
+              <a:rPr sz="1400" b="0" i="0">
+                <a:solidFill>
+                  <a:srgbClr val="212121"/>
+                </a:solidFill>
+                <a:latin typeface="Arial"/>
+              </a:rPr>
+              <a:t>Máscara EBETV1</a:t>
+            </a:r>
+            <a:r>
+              <a:rPr sz="1200" b="0" i="1">
+                <a:solidFill>
+                  <a:srgbClr val="757575"/>
+                </a:solidFill>
+                <a:latin typeface="Arial"/>
+              </a:rPr>
+              <a:t>   09/06</a:t>
+            </a:r>
+          </a:p>
+          <a:p>
+            <a:pPr marL="228600" indent="-228600">
+              <a:lnSpc>
+                <a:spcPct val="115000"/>
+              </a:lnSpc>
+              <a:spcAft>
+                <a:spcPts val="800"/>
+              </a:spcAft>
+              <a:buClr>
+                <a:srgbClr val="00897B"/>
+              </a:buClr>
+              <a:buSzPct val="65000"/>
+              <a:buFont typeface="Arial"/>
+              <a:buChar char="●"/>
+            </a:pPr>
+            <a:r>
+              <a:rPr sz="1400" b="0" i="0">
+                <a:solidFill>
+                  <a:srgbClr val="212121"/>
+                </a:solidFill>
+                <a:latin typeface="Arial"/>
+              </a:rPr>
+              <a:t>Máscara BCRT315I</a:t>
+            </a:r>
+            <a:r>
+              <a:rPr sz="1200" b="0" i="1">
+                <a:solidFill>
+                  <a:srgbClr val="757575"/>
+                </a:solidFill>
+                <a:latin typeface="Arial"/>
+              </a:rPr>
+              <a:t>   12/06</a:t>
+            </a:r>
+          </a:p>
+          <a:p>
+            <a:pPr marL="228600" indent="-228600">
+              <a:lnSpc>
+                <a:spcPct val="115000"/>
+              </a:lnSpc>
+              <a:spcAft>
+                <a:spcPts val="800"/>
+              </a:spcAft>
+              <a:buClr>
+                <a:srgbClr val="00897B"/>
+              </a:buClr>
+              <a:buSzPct val="65000"/>
+              <a:buFont typeface="Arial"/>
+              <a:buChar char="●"/>
+            </a:pPr>
+            <a:r>
+              <a:rPr sz="1400" b="0" i="0">
+                <a:solidFill>
+                  <a:srgbClr val="212121"/>
+                </a:solidFill>
+                <a:latin typeface="Arial"/>
+              </a:rPr>
+              <a:t>Máscara DEMPARK — Fleury / inativo MV</a:t>
+            </a:r>
+            <a:r>
+              <a:rPr sz="1200" b="0" i="1">
+                <a:solidFill>
+                  <a:srgbClr val="757575"/>
+                </a:solidFill>
+                <a:latin typeface="Arial"/>
+              </a:rPr>
+              <a:t>   12/06</a:t>
+            </a:r>
+          </a:p>
+          <a:p>
+            <a:pPr marL="228600" indent="-228600">
+              <a:lnSpc>
+                <a:spcPct val="115000"/>
+              </a:lnSpc>
+              <a:spcAft>
+                <a:spcPts val="800"/>
+              </a:spcAft>
+              <a:buClr>
+                <a:srgbClr val="00897B"/>
+              </a:buClr>
+              <a:buSzPct val="65000"/>
+              <a:buFont typeface="Arial"/>
+              <a:buChar char="●"/>
+            </a:pPr>
+            <a:r>
+              <a:rPr sz="1400" b="0" i="0">
+                <a:solidFill>
+                  <a:srgbClr val="212121"/>
+                </a:solidFill>
+                <a:latin typeface="Arial"/>
+              </a:rPr>
+              <a:t>Máscara LIPODIS — Fleury / inativo MV</a:t>
+            </a:r>
+            <a:r>
+              <a:rPr sz="1200" b="0" i="1">
+                <a:solidFill>
+                  <a:srgbClr val="757575"/>
+                </a:solidFill>
+                <a:latin typeface="Arial"/>
+              </a:rPr>
+              <a:t>   12/06</a:t>
+            </a:r>
+          </a:p>
+          <a:p>
+            <a:pPr marL="228600" indent="-228600">
+              <a:lnSpc>
+                <a:spcPct val="115000"/>
+              </a:lnSpc>
+              <a:spcAft>
+                <a:spcPts val="800"/>
+              </a:spcAft>
+              <a:buClr>
+                <a:srgbClr val="00897B"/>
+              </a:buClr>
+              <a:buSzPct val="65000"/>
+              <a:buFont typeface="Arial"/>
+              <a:buChar char="●"/>
+            </a:pPr>
+            <a:r>
+              <a:rPr sz="1400" b="0" i="0">
+                <a:solidFill>
+                  <a:srgbClr val="212121"/>
+                </a:solidFill>
+                <a:latin typeface="Arial"/>
+              </a:rPr>
+              <a:t>Máscara CBFB</a:t>
+            </a:r>
+            <a:r>
+              <a:rPr sz="1200" b="0" i="1">
+                <a:solidFill>
+                  <a:srgbClr val="757575"/>
+                </a:solidFill>
+                <a:latin typeface="Arial"/>
+              </a:rPr>
+              <a:t>   15/06</a:t>
+            </a:r>
+          </a:p>
+          <a:p>
+            <a:pPr marL="228600" indent="-228600">
+              <a:lnSpc>
+                <a:spcPct val="115000"/>
+              </a:lnSpc>
+              <a:spcAft>
+                <a:spcPts val="800"/>
+              </a:spcAft>
+              <a:buClr>
+                <a:srgbClr val="00897B"/>
+              </a:buClr>
+              <a:buSzPct val="65000"/>
+              <a:buFont typeface="Arial"/>
+              <a:buChar char="●"/>
+            </a:pPr>
+            <a:r>
+              <a:rPr sz="1400" b="0" i="0">
+                <a:solidFill>
+                  <a:srgbClr val="212121"/>
+                </a:solidFill>
+                <a:latin typeface="Arial"/>
+              </a:rPr>
+              <a:t>Máscara M1</a:t>
+            </a:r>
+            <a:r>
+              <a:rPr sz="1200" b="0" i="1">
+                <a:solidFill>
+                  <a:srgbClr val="757575"/>
+                </a:solidFill>
+                <a:latin typeface="Arial"/>
+              </a:rPr>
+              <a:t>   15/06</a:t>
+            </a:r>
+          </a:p>
+          <a:p>
+            <a:pPr marL="228600" indent="-228600">
+              <a:lnSpc>
+                <a:spcPct val="115000"/>
+              </a:lnSpc>
+              <a:spcAft>
+                <a:spcPts val="800"/>
+              </a:spcAft>
+              <a:buClr>
+                <a:srgbClr val="00897B"/>
+              </a:buClr>
+              <a:buSzPct val="65000"/>
+              <a:buFont typeface="Arial"/>
+              <a:buChar char="●"/>
+            </a:pPr>
+            <a:r>
+              <a:rPr sz="1400" b="0" i="0">
+                <a:solidFill>
+                  <a:srgbClr val="212121"/>
+                </a:solidFill>
+                <a:latin typeface="Arial"/>
+              </a:rPr>
+              <a:t>Máscara VIT125</a:t>
+            </a:r>
+            <a:r>
+              <a:rPr sz="1200" b="0" i="1">
+                <a:solidFill>
+                  <a:srgbClr val="757575"/>
+                </a:solidFill>
+                <a:latin typeface="Arial"/>
+              </a:rPr>
+              <a:t>   17/06</a:t>
+            </a:r>
+          </a:p>
+        </p:txBody>
+      </p:sp>
+      <p:sp>
+        <p:nvSpPr>
+          <p:cNvPr id="11" name="TextBox 10"/>
+          <p:cNvSpPr txBox="1"/>
+          <p:nvPr/>
+        </p:nvSpPr>
+        <p:spPr>
+          <a:xfrm>
+            <a:off x="6172200" y="1463040"/>
+            <a:ext cx="5074920" cy="4572000"/>
+          </a:xfrm>
+          <a:prstGeom prst="rect">
+            <a:avLst/>
+          </a:prstGeom>
+          <a:noFill/>
+        </p:spPr>
+        <p:txBody>
+          <a:bodyPr wrap="square">
+            <a:noAutofit/>
+          </a:bodyPr>
+          <a:lstStyle/>
+          <a:p>
+            <a:pPr marL="228600" indent="-228600">
+              <a:lnSpc>
+                <a:spcPct val="115000"/>
+              </a:lnSpc>
+              <a:spcAft>
+                <a:spcPts val="800"/>
+              </a:spcAft>
+              <a:buClr>
+                <a:srgbClr val="00897B"/>
+              </a:buClr>
+              <a:buSzPct val="65000"/>
+              <a:buFont typeface="Arial"/>
+              <a:buChar char="●"/>
+            </a:pPr>
+            <a:r>
+              <a:rPr sz="1400" b="0" i="0">
+                <a:solidFill>
+                  <a:srgbClr val="212121"/>
+                </a:solidFill>
+                <a:latin typeface="Arial"/>
+              </a:rPr>
+              <a:t>Máscara C3</a:t>
+            </a:r>
+            <a:r>
+              <a:rPr sz="1200" b="0" i="1">
+                <a:solidFill>
+                  <a:srgbClr val="757575"/>
+                </a:solidFill>
+                <a:latin typeface="Arial"/>
+              </a:rPr>
+              <a:t>   17/06</a:t>
+            </a:r>
+          </a:p>
+          <a:p>
+            <a:pPr marL="228600" indent="-228600">
+              <a:lnSpc>
+                <a:spcPct val="115000"/>
+              </a:lnSpc>
+              <a:spcAft>
+                <a:spcPts val="800"/>
+              </a:spcAft>
+              <a:buClr>
+                <a:srgbClr val="00897B"/>
+              </a:buClr>
+              <a:buSzPct val="65000"/>
+              <a:buFont typeface="Arial"/>
+              <a:buChar char="●"/>
+            </a:pPr>
+            <a:r>
+              <a:rPr sz="1400" b="0" i="0">
+                <a:solidFill>
+                  <a:srgbClr val="212121"/>
+                </a:solidFill>
+                <a:latin typeface="Arial"/>
+              </a:rPr>
+              <a:t>Máscara PEPI</a:t>
+            </a:r>
+            <a:r>
+              <a:rPr sz="1200" b="0" i="1">
+                <a:solidFill>
+                  <a:srgbClr val="757575"/>
+                </a:solidFill>
+                <a:latin typeface="Arial"/>
+              </a:rPr>
+              <a:t>   17/06</a:t>
+            </a:r>
+          </a:p>
+          <a:p>
+            <a:pPr marL="228600" indent="-228600">
+              <a:lnSpc>
+                <a:spcPct val="115000"/>
+              </a:lnSpc>
+              <a:spcAft>
+                <a:spcPts val="800"/>
+              </a:spcAft>
+              <a:buClr>
+                <a:srgbClr val="00897B"/>
+              </a:buClr>
+              <a:buSzPct val="65000"/>
+              <a:buFont typeface="Arial"/>
+              <a:buChar char="●"/>
+            </a:pPr>
+            <a:r>
+              <a:rPr sz="1400" b="0" i="0">
+                <a:solidFill>
+                  <a:srgbClr val="212121"/>
+                </a:solidFill>
+                <a:latin typeface="Arial"/>
+              </a:rPr>
+              <a:t>Máscara COQ10</a:t>
+            </a:r>
+            <a:r>
+              <a:rPr sz="1200" b="0" i="1">
+                <a:solidFill>
+                  <a:srgbClr val="757575"/>
+                </a:solidFill>
+                <a:latin typeface="Arial"/>
+              </a:rPr>
+              <a:t>   17/06</a:t>
+            </a:r>
+          </a:p>
+          <a:p>
+            <a:pPr marL="228600" indent="-228600">
+              <a:lnSpc>
+                <a:spcPct val="115000"/>
+              </a:lnSpc>
+              <a:spcAft>
+                <a:spcPts val="800"/>
+              </a:spcAft>
+              <a:buClr>
+                <a:srgbClr val="00897B"/>
+              </a:buClr>
+              <a:buSzPct val="65000"/>
+              <a:buFont typeface="Arial"/>
+              <a:buChar char="●"/>
+            </a:pPr>
+            <a:r>
+              <a:rPr sz="1400" b="0" i="0">
+                <a:solidFill>
+                  <a:srgbClr val="212121"/>
+                </a:solidFill>
+                <a:latin typeface="Arial"/>
+              </a:rPr>
+              <a:t>Máscara DOEIMU</a:t>
+            </a:r>
+            <a:r>
+              <a:rPr sz="1200" b="0" i="1">
+                <a:solidFill>
+                  <a:srgbClr val="757575"/>
+                </a:solidFill>
+                <a:latin typeface="Arial"/>
+              </a:rPr>
+              <a:t>   18/06</a:t>
+            </a:r>
+          </a:p>
+          <a:p>
+            <a:pPr marL="228600" indent="-228600">
+              <a:lnSpc>
+                <a:spcPct val="115000"/>
+              </a:lnSpc>
+              <a:spcAft>
+                <a:spcPts val="800"/>
+              </a:spcAft>
+              <a:buClr>
+                <a:srgbClr val="00897B"/>
+              </a:buClr>
+              <a:buSzPct val="65000"/>
+              <a:buFont typeface="Arial"/>
+              <a:buChar char="●"/>
+            </a:pPr>
+            <a:r>
+              <a:rPr sz="1400" b="0" i="0">
+                <a:solidFill>
+                  <a:srgbClr val="212121"/>
+                </a:solidFill>
+                <a:latin typeface="Arial"/>
+              </a:rPr>
+              <a:t>Máscara RECALCRE</a:t>
+            </a:r>
+            <a:r>
+              <a:rPr sz="1200" b="0" i="1">
+                <a:solidFill>
+                  <a:srgbClr val="757575"/>
+                </a:solidFill>
+                <a:latin typeface="Arial"/>
+              </a:rPr>
+              <a:t>   25/06</a:t>
+            </a:r>
+          </a:p>
+          <a:p>
+            <a:pPr marL="228600" indent="-228600">
+              <a:lnSpc>
+                <a:spcPct val="115000"/>
+              </a:lnSpc>
+              <a:spcAft>
+                <a:spcPts val="800"/>
+              </a:spcAft>
+              <a:buClr>
+                <a:srgbClr val="00897B"/>
+              </a:buClr>
+              <a:buSzPct val="65000"/>
+              <a:buFont typeface="Arial"/>
+              <a:buChar char="●"/>
+            </a:pPr>
+            <a:r>
+              <a:rPr sz="1400" b="0" i="0">
+                <a:solidFill>
+                  <a:srgbClr val="212121"/>
+                </a:solidFill>
+                <a:latin typeface="Arial"/>
+              </a:rPr>
+              <a:t>Máscara IGE I5</a:t>
+            </a:r>
+            <a:r>
+              <a:rPr sz="1200" b="0" i="1">
+                <a:solidFill>
+                  <a:srgbClr val="757575"/>
+                </a:solidFill>
+                <a:latin typeface="Arial"/>
+              </a:rPr>
+              <a:t>   25/06</a:t>
+            </a:r>
+          </a:p>
+          <a:p>
+            <a:pPr marL="228600" indent="-228600">
+              <a:lnSpc>
+                <a:spcPct val="115000"/>
+              </a:lnSpc>
+              <a:spcAft>
+                <a:spcPts val="800"/>
+              </a:spcAft>
+              <a:buClr>
+                <a:srgbClr val="00897B"/>
+              </a:buClr>
+              <a:buSzPct val="65000"/>
+              <a:buFont typeface="Arial"/>
+              <a:buChar char="●"/>
+            </a:pPr>
+            <a:r>
+              <a:rPr sz="1400" b="0" i="0">
+                <a:solidFill>
+                  <a:srgbClr val="212121"/>
+                </a:solidFill>
+                <a:latin typeface="Arial"/>
+              </a:rPr>
+              <a:t>Máscara MECP2</a:t>
+            </a:r>
+            <a:r>
+              <a:rPr sz="1200" b="0" i="1">
+                <a:solidFill>
+                  <a:srgbClr val="757575"/>
+                </a:solidFill>
+                <a:latin typeface="Arial"/>
+              </a:rPr>
+              <a:t>   25/06</a:t>
+            </a:r>
+          </a:p>
+          <a:p>
+            <a:pPr marL="228600" indent="-228600">
+              <a:lnSpc>
+                <a:spcPct val="115000"/>
+              </a:lnSpc>
+              <a:spcAft>
+                <a:spcPts val="800"/>
+              </a:spcAft>
+              <a:buClr>
+                <a:srgbClr val="00897B"/>
+              </a:buClr>
+              <a:buSzPct val="65000"/>
+              <a:buFont typeface="Arial"/>
+              <a:buChar char="●"/>
+            </a:pPr>
+            <a:r>
+              <a:rPr sz="1400" b="0" i="0">
+                <a:solidFill>
+                  <a:srgbClr val="212121"/>
+                </a:solidFill>
+                <a:latin typeface="Arial"/>
+              </a:rPr>
+              <a:t>Máscara IMUNOF24</a:t>
+            </a:r>
+            <a:r>
+              <a:rPr sz="1200" b="0" i="1">
+                <a:solidFill>
+                  <a:srgbClr val="757575"/>
+                </a:solidFill>
+                <a:latin typeface="Arial"/>
+              </a:rPr>
+              <a:t>   25/06</a:t>
+            </a:r>
+          </a:p>
+          <a:p>
+            <a:pPr marL="228600" indent="-228600">
+              <a:lnSpc>
+                <a:spcPct val="115000"/>
+              </a:lnSpc>
+              <a:spcAft>
+                <a:spcPts val="800"/>
+              </a:spcAft>
+              <a:buClr>
+                <a:srgbClr val="00897B"/>
+              </a:buClr>
+              <a:buSzPct val="65000"/>
+              <a:buFont typeface="Arial"/>
+              <a:buChar char="●"/>
+            </a:pPr>
+            <a:r>
+              <a:rPr sz="1400" b="0" i="0">
+                <a:solidFill>
+                  <a:srgbClr val="212121"/>
+                </a:solidFill>
+                <a:latin typeface="Arial"/>
+              </a:rPr>
+              <a:t>Máscara PB19PCR</a:t>
+            </a:r>
+            <a:r>
+              <a:rPr sz="1200" b="0" i="1">
+                <a:solidFill>
+                  <a:srgbClr val="757575"/>
+                </a:solidFill>
+                <a:latin typeface="Arial"/>
+              </a:rPr>
+              <a:t>   25/06</a:t>
+            </a:r>
+          </a:p>
+          <a:p>
+            <a:pPr marL="228600" indent="-228600">
+              <a:lnSpc>
+                <a:spcPct val="115000"/>
+              </a:lnSpc>
+              <a:spcAft>
+                <a:spcPts val="800"/>
+              </a:spcAft>
+              <a:buClr>
+                <a:srgbClr val="00897B"/>
+              </a:buClr>
+              <a:buSzPct val="65000"/>
+              <a:buFont typeface="Arial"/>
+              <a:buChar char="●"/>
+            </a:pPr>
+            <a:r>
+              <a:rPr sz="1400" b="0" i="0">
+                <a:solidFill>
+                  <a:srgbClr val="212121"/>
+                </a:solidFill>
+                <a:latin typeface="Arial"/>
+              </a:rPr>
+              <a:t>Máscara Metil. Russell P.G. — painel genético Pardini</a:t>
+            </a:r>
+            <a:r>
+              <a:rPr sz="1200" b="0" i="1">
+                <a:solidFill>
+                  <a:srgbClr val="757575"/>
+                </a:solidFill>
+                <a:latin typeface="Arial"/>
+              </a:rPr>
+              <a:t>   25/06</a:t>
+            </a:r>
+          </a:p>
+          <a:p>
+            <a:pPr marL="228600" indent="-228600">
+              <a:lnSpc>
+                <a:spcPct val="115000"/>
+              </a:lnSpc>
+              <a:spcAft>
+                <a:spcPts val="800"/>
+              </a:spcAft>
+              <a:buClr>
+                <a:srgbClr val="00897B"/>
+              </a:buClr>
+              <a:buSzPct val="65000"/>
+              <a:buFont typeface="Arial"/>
+              <a:buChar char="●"/>
+            </a:pPr>
+            <a:r>
+              <a:rPr sz="1400" b="0" i="0">
+                <a:solidFill>
+                  <a:srgbClr val="212121"/>
+                </a:solidFill>
+                <a:latin typeface="Arial"/>
+              </a:rPr>
+              <a:t>Máscara C216 — novo procedimento</a:t>
+            </a:r>
+            <a:r>
+              <a:rPr sz="1200" b="0" i="1">
+                <a:solidFill>
+                  <a:srgbClr val="757575"/>
+                </a:solidFill>
+                <a:latin typeface="Arial"/>
+              </a:rPr>
+              <a:t>   25/06</a:t>
             </a:r>
           </a:p>
         </p:txBody>
@@ -4754,7 +5904,7 @@
             <a:avLst/>
           </a:prstGeom>
           <a:solidFill>
-            <a:srgbClr val="00897B"/>
+            <a:srgbClr val="00ACC1"/>
           </a:solidFill>
           <a:ln>
             <a:noFill/>
@@ -4856,7 +6006,7 @@
               </a:defRPr>
             </a:pPr>
             <a:r>
-              <a:t>Shift LIS (22)</a:t>
+              <a:t>Shift Integração (8)</a:t>
             </a:r>
           </a:p>
         </p:txBody>
@@ -4903,11 +6053,23 @@
         </p:spPr>
         <p:txBody>
           <a:bodyPr wrap="square">
-            <a:spAutoFit/>
+            <a:noAutofit/>
           </a:bodyPr>
           <a:lstStyle/>
           <a:p>
-            <a:pPr algn="l">
+            <a:pPr algn="l" marL="228600" indent="-228600">
+              <a:lnSpc>
+                <a:spcPct val="115000"/>
+              </a:lnSpc>
+              <a:spcAft>
+                <a:spcPts val="1000"/>
+              </a:spcAft>
+              <a:buClr>
+                <a:srgbClr val="00ACC1"/>
+              </a:buClr>
+              <a:buSzPct val="65000"/>
+              <a:buFont typeface="Arial"/>
+              <a:buChar char="●"/>
               <a:defRPr sz="1400" b="0">
                 <a:solidFill>
                   <a:srgbClr val="212121"/>
@@ -4916,28 +6078,260 @@
               </a:defRPr>
             </a:pPr>
             <a:r>
-              <a:t>• Máscara SDHEA (01/06)
-• Máscara ANFETUR (01/06)
-• Máscara PQUINASE (03/06)
-• Máscara OSMOUR (09/06)
-• Máscara EBETV1 (09/06)
-• Máscara BCRT315I (12/06)
-• Máscara DEMPARK — Fleury / inativo MV (12/06)
-• Máscara LIPODIS — Fleury / inativo MV (12/06)
-• Máscara CBFB (15/06)
-• Máscara M1 (15/06)
-• Máscara VIT125 (17/06)
-• Máscara C3 (17/06)
-• Máscara PEPI (17/06)
-• Máscara COQ10 (17/06)
-• Máscara DOEIMU (18/06)
-• Máscara RECALCRE (25/06)
-• Máscara IGE I5 (25/06)
-• Máscara MECP2 (25/06)
-• Máscara IMUNOF24 (25/06)
-• Máscara PB19PCR (25/06)
-• Máscara Metil. Russell P.G. — painel genético Pardini (25/06)
-• Máscara C216 — novo procedimento (25/06)</a:t>
+              <a:rPr sz="1600" b="0" i="0">
+                <a:solidFill>
+                  <a:srgbClr val="212121"/>
+                </a:solidFill>
+                <a:latin typeface="Arial"/>
+              </a:rPr>
+              <a:t>De/para antimicrobiano — Isoniazida (código Shift 635 → código MV 231)</a:t>
+            </a:r>
+            <a:r>
+              <a:rPr sz="1400" b="0" i="1">
+                <a:solidFill>
+                  <a:srgbClr val="757575"/>
+                </a:solidFill>
+                <a:latin typeface="Arial"/>
+              </a:rPr>
+              <a:t>   29/06</a:t>
+            </a:r>
+          </a:p>
+          <a:p>
+            <a:pPr marL="228600" indent="-228600">
+              <a:lnSpc>
+                <a:spcPct val="115000"/>
+              </a:lnSpc>
+              <a:spcAft>
+                <a:spcPts val="1000"/>
+              </a:spcAft>
+              <a:buClr>
+                <a:srgbClr val="00ACC1"/>
+              </a:buClr>
+              <a:buSzPct val="65000"/>
+              <a:buFont typeface="Arial"/>
+              <a:buChar char="●"/>
+            </a:pPr>
+            <a:r>
+              <a:rPr sz="1600" b="0" i="0">
+                <a:solidFill>
+                  <a:srgbClr val="212121"/>
+                </a:solidFill>
+                <a:latin typeface="Arial"/>
+              </a:rPr>
+              <a:t>Criação da unidade de coleta "AMB CENTRO DE TRATAMENTO LABIOPALATAL" e de/para de integração (código Shift 423 → código MV 1230)</a:t>
+            </a:r>
+            <a:r>
+              <a:rPr sz="1400" b="0" i="1">
+                <a:solidFill>
+                  <a:srgbClr val="757575"/>
+                </a:solidFill>
+                <a:latin typeface="Arial"/>
+              </a:rPr>
+              <a:t>   29/06</a:t>
+            </a:r>
+          </a:p>
+          <a:p>
+            <a:pPr marL="228600" indent="-228600">
+              <a:lnSpc>
+                <a:spcPct val="115000"/>
+              </a:lnSpc>
+              <a:spcAft>
+                <a:spcPts val="1000"/>
+              </a:spcAft>
+              <a:buClr>
+                <a:srgbClr val="00ACC1"/>
+              </a:buClr>
+              <a:buSzPct val="65000"/>
+              <a:buFont typeface="Arial"/>
+              <a:buChar char="●"/>
+            </a:pPr>
+            <a:r>
+              <a:rPr sz="1600" b="0" i="0">
+                <a:solidFill>
+                  <a:srgbClr val="212121"/>
+                </a:solidFill>
+                <a:latin typeface="Arial"/>
+              </a:rPr>
+              <a:t>De/para antibiograma — Imipenem (código Shift IPM4 → código MV 215)</a:t>
+            </a:r>
+            <a:r>
+              <a:rPr sz="1400" b="0" i="1">
+                <a:solidFill>
+                  <a:srgbClr val="757575"/>
+                </a:solidFill>
+                <a:latin typeface="Arial"/>
+              </a:rPr>
+              <a:t>   30/06</a:t>
+            </a:r>
+          </a:p>
+          <a:p>
+            <a:pPr marL="228600" indent="-228600">
+              <a:lnSpc>
+                <a:spcPct val="115000"/>
+              </a:lnSpc>
+              <a:spcAft>
+                <a:spcPts val="1000"/>
+              </a:spcAft>
+              <a:buClr>
+                <a:srgbClr val="00ACC1"/>
+              </a:buClr>
+              <a:buSzPct val="65000"/>
+              <a:buFont typeface="Arial"/>
+              <a:buChar char="●"/>
+            </a:pPr>
+            <a:r>
+              <a:rPr sz="1600" b="0" i="0">
+                <a:solidFill>
+                  <a:srgbClr val="212121"/>
+                </a:solidFill>
+                <a:latin typeface="Arial"/>
+              </a:rPr>
+              <a:t>De/para antibiograma — antimicrobiano IMR (código Shift IMR → código MV 551)</a:t>
+            </a:r>
+            <a:r>
+              <a:rPr sz="1400" b="0" i="1">
+                <a:solidFill>
+                  <a:srgbClr val="757575"/>
+                </a:solidFill>
+                <a:latin typeface="Arial"/>
+              </a:rPr>
+              <a:t>   30/06</a:t>
+            </a:r>
+          </a:p>
+          <a:p>
+            <a:pPr marL="228600" indent="-228600">
+              <a:lnSpc>
+                <a:spcPct val="115000"/>
+              </a:lnSpc>
+              <a:spcAft>
+                <a:spcPts val="1000"/>
+              </a:spcAft>
+              <a:buClr>
+                <a:srgbClr val="00ACC1"/>
+              </a:buClr>
+              <a:buSzPct val="65000"/>
+              <a:buFont typeface="Arial"/>
+              <a:buChar char="●"/>
+            </a:pPr>
+            <a:r>
+              <a:rPr sz="1600" b="0" i="0">
+                <a:solidFill>
+                  <a:srgbClr val="212121"/>
+                </a:solidFill>
+                <a:latin typeface="Arial"/>
+              </a:rPr>
+              <a:t>De/para resultado de log Hepatite C — "0.0" → "-"</a:t>
+            </a:r>
+            <a:r>
+              <a:rPr sz="1400" b="0" i="1">
+                <a:solidFill>
+                  <a:srgbClr val="757575"/>
+                </a:solidFill>
+                <a:latin typeface="Arial"/>
+              </a:rPr>
+              <a:t>   30/06</a:t>
+            </a:r>
+          </a:p>
+          <a:p>
+            <a:pPr marL="228600" indent="-228600">
+              <a:lnSpc>
+                <a:spcPct val="115000"/>
+              </a:lnSpc>
+              <a:spcAft>
+                <a:spcPts val="1000"/>
+              </a:spcAft>
+              <a:buClr>
+                <a:srgbClr val="00ACC1"/>
+              </a:buClr>
+              <a:buSzPct val="65000"/>
+              <a:buFont typeface="Arial"/>
+              <a:buChar char="●"/>
+            </a:pPr>
+            <a:r>
+              <a:rPr sz="1600" b="0" i="0">
+                <a:solidFill>
+                  <a:srgbClr val="212121"/>
+                </a:solidFill>
+                <a:latin typeface="Arial"/>
+              </a:rPr>
+              <a:t>SDHEA — rota reconfigurada de Apoio (provisório) para rota interna após chegada de novos kits</a:t>
+            </a:r>
+            <a:r>
+              <a:rPr sz="1400" b="0" i="1">
+                <a:solidFill>
+                  <a:srgbClr val="757575"/>
+                </a:solidFill>
+                <a:latin typeface="Arial"/>
+              </a:rPr>
+              <a:t>   30/06</a:t>
+            </a:r>
+          </a:p>
+          <a:p>
+            <a:pPr marL="228600" indent="-228600">
+              <a:lnSpc>
+                <a:spcPct val="115000"/>
+              </a:lnSpc>
+              <a:spcAft>
+                <a:spcPts val="1000"/>
+              </a:spcAft>
+              <a:buClr>
+                <a:srgbClr val="00ACC1"/>
+              </a:buClr>
+              <a:buSzPct val="65000"/>
+              <a:buFont typeface="Arial"/>
+              <a:buChar char="●"/>
+            </a:pPr>
+            <a:r>
+              <a:rPr sz="1600" b="0" i="0">
+                <a:solidFill>
+                  <a:srgbClr val="212121"/>
+                </a:solidFill>
+                <a:latin typeface="Arial"/>
+              </a:rPr>
+              <a:t>De/para antibiograma — Rifabutina (Shift RFB → MV 268)</a:t>
+            </a:r>
+            <a:r>
+              <a:rPr sz="1400" b="0" i="1">
+                <a:solidFill>
+                  <a:srgbClr val="757575"/>
+                </a:solidFill>
+                <a:latin typeface="Arial"/>
+              </a:rPr>
+              <a:t>   30/06</a:t>
+            </a:r>
+          </a:p>
+          <a:p>
+            <a:pPr marL="228600" indent="-228600">
+              <a:lnSpc>
+                <a:spcPct val="115000"/>
+              </a:lnSpc>
+              <a:spcAft>
+                <a:spcPts val="1000"/>
+              </a:spcAft>
+              <a:buClr>
+                <a:srgbClr val="00ACC1"/>
+              </a:buClr>
+              <a:buSzPct val="65000"/>
+              <a:buFont typeface="Arial"/>
+              <a:buChar char="●"/>
+            </a:pPr>
+            <a:r>
+              <a:rPr sz="1600" b="0" i="0">
+                <a:solidFill>
+                  <a:srgbClr val="212121"/>
+                </a:solidFill>
+                <a:latin typeface="Arial"/>
+              </a:rPr>
+              <a:t>De/para antibiograma — Isoniazida (Shift IZ → MV 231)</a:t>
+            </a:r>
+            <a:r>
+              <a:rPr sz="1400" b="0" i="1">
+                <a:solidFill>
+                  <a:srgbClr val="757575"/>
+                </a:solidFill>
+                <a:latin typeface="Arial"/>
+              </a:rPr>
+              <a:t>   30/06</a:t>
             </a:r>
           </a:p>
         </p:txBody>
@@ -5090,7 +6484,7 @@
             <a:avLst/>
           </a:prstGeom>
           <a:solidFill>
-            <a:srgbClr val="00897B"/>
+            <a:srgbClr val="546E7A"/>
           </a:solidFill>
           <a:ln>
             <a:noFill/>
@@ -5239,11 +6633,23 @@
         </p:spPr>
         <p:txBody>
           <a:bodyPr wrap="square">
-            <a:spAutoFit/>
+            <a:noAutofit/>
           </a:bodyPr>
           <a:lstStyle/>
           <a:p>
-            <a:pPr algn="l">
+            <a:pPr algn="l" marL="228600" indent="-228600">
+              <a:lnSpc>
+                <a:spcPct val="115000"/>
+              </a:lnSpc>
+              <a:spcAft>
+                <a:spcPts val="1200"/>
+              </a:spcAft>
+              <a:buClr>
+                <a:srgbClr val="546E7A"/>
+              </a:buClr>
+              <a:buSzPct val="65000"/>
+              <a:buFont typeface="Arial"/>
+              <a:buChar char="●"/>
               <a:defRPr sz="1400" b="0">
                 <a:solidFill>
                   <a:srgbClr val="212121"/>
@@ -5252,8 +6658,56 @@
               </a:defRPr>
             </a:pPr>
             <a:r>
-              <a:t>• Avaliar alternativa de acesso remoto para Shift ao SRV-AUTOMA — equipe de redes avaliará riscos; acesso remoto permanece bloqueado por enquanto (25/06)
-• Cofre KeePass criado e senhas de docs/credenciais.md armazenadas (29/06)</a:t>
+              <a:rPr sz="1800" b="0" i="0">
+                <a:solidFill>
+                  <a:srgbClr val="212121"/>
+                </a:solidFill>
+                <a:latin typeface="Arial"/>
+              </a:rPr>
+              <a:t>Avaliar alternativa de acesso remoto para Shift ao SRV-AUTOMA — equipe de redes avaliará riscos; acesso remoto permanece bloqueado por enquanto</a:t>
+            </a:r>
+            <a:r>
+              <a:rPr sz="1600" b="0" i="1">
+                <a:solidFill>
+                  <a:srgbClr val="757575"/>
+                </a:solidFill>
+                <a:latin typeface="Arial"/>
+              </a:rPr>
+              <a:t>   25/06</a:t>
+            </a:r>
+          </a:p>
+          <a:p>
+            <a:pPr marL="228600" indent="-228600">
+              <a:lnSpc>
+                <a:spcPct val="115000"/>
+              </a:lnSpc>
+              <a:spcAft>
+                <a:spcPts val="1200"/>
+              </a:spcAft>
+              <a:buClr>
+                <a:srgbClr val="546E7A"/>
+              </a:buClr>
+              <a:buSzPct val="65000"/>
+              <a:buFont typeface="Arial"/>
+              <a:buChar char="●"/>
+            </a:pPr>
+            <a:r>
+              <a:rPr sz="1800" b="0" i="0">
+                <a:solidFill>
+                  <a:srgbClr val="212121"/>
+                </a:solidFill>
+                <a:latin typeface="Arial"/>
+              </a:rPr>
+              <a:t>Cofre KeePass criado e senhas de docs/credenciais.md armazenadas</a:t>
+            </a:r>
+            <a:r>
+              <a:rPr sz="1600" b="0" i="1">
+                <a:solidFill>
+                  <a:srgbClr val="757575"/>
+                </a:solidFill>
+                <a:latin typeface="Arial"/>
+              </a:rPr>
+              <a:t>   29/06</a:t>
             </a:r>
           </a:p>
         </p:txBody>
@@ -5406,7 +6860,7 @@
             <a:avLst/>
           </a:prstGeom>
           <a:solidFill>
-            <a:srgbClr val="00897B"/>
+            <a:srgbClr val="5C6BC0"/>
           </a:solidFill>
           <a:ln>
             <a:noFill/>
@@ -5508,7 +6962,7 @@
               </a:defRPr>
             </a:pPr>
             <a:r>
-              <a:t>Shift Integração (2)</a:t>
+              <a:t>Shift Automação (2)</a:t>
             </a:r>
           </a:p>
         </p:txBody>
@@ -5555,11 +7009,23 @@
         </p:spPr>
         <p:txBody>
           <a:bodyPr wrap="square">
-            <a:spAutoFit/>
+            <a:noAutofit/>
           </a:bodyPr>
           <a:lstStyle/>
           <a:p>
-            <a:pPr algn="l">
+            <a:pPr algn="l" marL="228600" indent="-228600">
+              <a:lnSpc>
+                <a:spcPct val="115000"/>
+              </a:lnSpc>
+              <a:spcAft>
+                <a:spcPts val="1200"/>
+              </a:spcAft>
+              <a:buClr>
+                <a:srgbClr val="5C6BC0"/>
+              </a:buClr>
+              <a:buSzPct val="65000"/>
+              <a:buFont typeface="Arial"/>
+              <a:buChar char="●"/>
               <a:defRPr sz="1400" b="0">
                 <a:solidFill>
                   <a:srgbClr val="212121"/>
@@ -5568,8 +7034,56 @@
               </a:defRPr>
             </a:pPr>
             <a:r>
-              <a:t>• De/para antimicrobiano — Isoniazida (código Shift 635 → código MV 231) (29/06)
-• Criação da unidade de coleta "AMB CENTRO DE TRATAMENTO LABIOPALATAL" e de/para de integração (código Shift 423 → código MV 1230) (29/06)</a:t>
+              <a:rPr sz="1800" b="0" i="0">
+                <a:solidFill>
+                  <a:srgbClr val="212121"/>
+                </a:solidFill>
+                <a:latin typeface="Arial"/>
+              </a:rPr>
+              <a:t>ABL-800 — interface do gasômetro do HCM configurada para incorporar resultados de hemoglobinas</a:t>
+            </a:r>
+            <a:r>
+              <a:rPr sz="1600" b="0" i="1">
+                <a:solidFill>
+                  <a:srgbClr val="757575"/>
+                </a:solidFill>
+                <a:latin typeface="Arial"/>
+              </a:rPr>
+              <a:t>   18/06</a:t>
+            </a:r>
+          </a:p>
+          <a:p>
+            <a:pPr marL="228600" indent="-228600">
+              <a:lnSpc>
+                <a:spcPct val="115000"/>
+              </a:lnSpc>
+              <a:spcAft>
+                <a:spcPts val="1200"/>
+              </a:spcAft>
+              <a:buClr>
+                <a:srgbClr val="5C6BC0"/>
+              </a:buClr>
+              <a:buSzPct val="65000"/>
+              <a:buFont typeface="Arial"/>
+              <a:buChar char="●"/>
+            </a:pPr>
+            <a:r>
+              <a:rPr sz="1800" b="0" i="0">
+                <a:solidFill>
+                  <a:srgbClr val="212121"/>
+                </a:solidFill>
+                <a:latin typeface="Arial"/>
+              </a:rPr>
+              <a:t>CMV PCR (biomol) — tradução automática de resultado negativo: "-" → "Negativo", eliminando necessidade de correção manual pelos colaboradores</a:t>
+            </a:r>
+            <a:r>
+              <a:rPr sz="1600" b="0" i="1">
+                <a:solidFill>
+                  <a:srgbClr val="757575"/>
+                </a:solidFill>
+                <a:latin typeface="Arial"/>
+              </a:rPr>
+              <a:t>   29/06</a:t>
             </a:r>
           </a:p>
         </p:txBody>
@@ -5722,7 +7236,7 @@
             <a:avLst/>
           </a:prstGeom>
           <a:solidFill>
-            <a:srgbClr val="00897B"/>
+            <a:srgbClr val="FFA000"/>
           </a:solidFill>
           <a:ln>
             <a:noFill/>
@@ -5824,7 +7338,7 @@
               </a:defRPr>
             </a:pPr>
             <a:r>
-              <a:t>Shift Automação (2)</a:t>
+              <a:t>Municípios (2)</a:t>
             </a:r>
           </a:p>
         </p:txBody>
@@ -5871,11 +7385,23 @@
         </p:spPr>
         <p:txBody>
           <a:bodyPr wrap="square">
-            <a:spAutoFit/>
+            <a:noAutofit/>
           </a:bodyPr>
           <a:lstStyle/>
           <a:p>
-            <a:pPr algn="l">
+            <a:pPr algn="l" marL="228600" indent="-228600">
+              <a:lnSpc>
+                <a:spcPct val="115000"/>
+              </a:lnSpc>
+              <a:spcAft>
+                <a:spcPts val="1200"/>
+              </a:spcAft>
+              <a:buClr>
+                <a:srgbClr val="FFA000"/>
+              </a:buClr>
+              <a:buSzPct val="65000"/>
+              <a:buFont typeface="Arial"/>
+              <a:buChar char="●"/>
               <a:defRPr sz="1400" b="0">
                 <a:solidFill>
                   <a:srgbClr val="212121"/>
@@ -5884,8 +7410,56 @@
               </a:defRPr>
             </a:pPr>
             <a:r>
-              <a:t>• ABL-800 — interface do gasômetro do HCM configurada para incorporar resultados de hemoglobinas (18/06)
-• CMV PCR (biomol) — tradução automática de resultado negativo: "-" → "Negativo", eliminando necessidade de correção manual pelos colaboradores (29/06)</a:t>
+              <a:rPr sz="1800" b="0" i="0">
+                <a:solidFill>
+                  <a:srgbClr val="212121"/>
+                </a:solidFill>
+                <a:latin typeface="Arial"/>
+              </a:rPr>
+              <a:t>Votuporanga — instalar sistema Shift na cidade</a:t>
+            </a:r>
+            <a:r>
+              <a:rPr sz="1600" b="0" i="1">
+                <a:solidFill>
+                  <a:srgbClr val="757575"/>
+                </a:solidFill>
+                <a:latin typeface="Arial"/>
+              </a:rPr>
+              <a:t>   01/06</a:t>
+            </a:r>
+          </a:p>
+          <a:p>
+            <a:pPr marL="228600" indent="-228600">
+              <a:lnSpc>
+                <a:spcPct val="115000"/>
+              </a:lnSpc>
+              <a:spcAft>
+                <a:spcPts val="1200"/>
+              </a:spcAft>
+              <a:buClr>
+                <a:srgbClr val="FFA000"/>
+              </a:buClr>
+              <a:buSzPct val="65000"/>
+              <a:buFont typeface="Arial"/>
+              <a:buChar char="●"/>
+            </a:pPr>
+            <a:r>
+              <a:rPr sz="1800" b="0" i="0">
+                <a:solidFill>
+                  <a:srgbClr val="212121"/>
+                </a:solidFill>
+                <a:latin typeface="Arial"/>
+              </a:rPr>
+              <a:t>Capacitar técnicos de TI dos municípios para suporte autônomo — grupo informado sobre como prosseguir perante ao bloqueio de acessos remotos</a:t>
+            </a:r>
+            <a:r>
+              <a:rPr sz="1600" b="0" i="1">
+                <a:solidFill>
+                  <a:srgbClr val="757575"/>
+                </a:solidFill>
+                <a:latin typeface="Arial"/>
+              </a:rPr>
+              <a:t>   25/06</a:t>
             </a:r>
           </a:p>
         </p:txBody>
@@ -6038,7 +7612,7 @@
             <a:avLst/>
           </a:prstGeom>
           <a:solidFill>
-            <a:srgbClr val="00897B"/>
+            <a:srgbClr val="8D6E63"/>
           </a:solidFill>
           <a:ln>
             <a:noFill/>
@@ -6140,7 +7714,7 @@
               </a:defRPr>
             </a:pPr>
             <a:r>
-              <a:t>Municípios (2)</a:t>
+              <a:t>Shift Cadastro (1)</a:t>
             </a:r>
           </a:p>
         </p:txBody>
@@ -6187,11 +7761,23 @@
         </p:spPr>
         <p:txBody>
           <a:bodyPr wrap="square">
-            <a:spAutoFit/>
+            <a:noAutofit/>
           </a:bodyPr>
           <a:lstStyle/>
           <a:p>
-            <a:pPr algn="l">
+            <a:pPr algn="l" marL="228600" indent="-228600">
+              <a:lnSpc>
+                <a:spcPct val="115000"/>
+              </a:lnSpc>
+              <a:spcAft>
+                <a:spcPts val="1200"/>
+              </a:spcAft>
+              <a:buClr>
+                <a:srgbClr val="8D6E63"/>
+              </a:buClr>
+              <a:buSzPct val="65000"/>
+              <a:buFont typeface="Arial"/>
+              <a:buChar char="●"/>
               <a:defRPr sz="1400" b="0">
                 <a:solidFill>
                   <a:srgbClr val="212121"/>
@@ -6200,8 +7786,22 @@
               </a:defRPr>
             </a:pPr>
             <a:r>
-              <a:t>• Votuporanga — instalar sistema Shift na cidade (01/06)
-• Capacitar técnicos de TI dos municípios para suporte autônomo — grupo informado sobre como prosseguir perante ao bloqueio de acessos remotos (25/06)</a:t>
+              <a:rPr sz="1800" b="0" i="0">
+                <a:solidFill>
+                  <a:srgbClr val="212121"/>
+                </a:solidFill>
+                <a:latin typeface="Arial"/>
+              </a:rPr>
+              <a:t>Exame e máscara criados — RECEPTRA (Shift 2371 → MV 2491), campo formatado; req. Ana Paula Galdiano — Kauã</a:t>
+            </a:r>
+            <a:r>
+              <a:rPr sz="1600" b="0" i="1">
+                <a:solidFill>
+                  <a:srgbClr val="757575"/>
+                </a:solidFill>
+                <a:latin typeface="Arial"/>
+              </a:rPr>
+              <a:t>   29/06</a:t>
             </a:r>
           </a:p>
         </p:txBody>
@@ -6354,7 +7954,7 @@
             <a:avLst/>
           </a:prstGeom>
           <a:solidFill>
-            <a:srgbClr val="005F56"/>
+            <a:srgbClr val="F9A825"/>
           </a:solidFill>
           <a:ln>
             <a:noFill/>
@@ -6503,11 +8103,23 @@
         </p:spPr>
         <p:txBody>
           <a:bodyPr wrap="square">
-            <a:spAutoFit/>
+            <a:noAutofit/>
           </a:bodyPr>
           <a:lstStyle/>
           <a:p>
-            <a:pPr algn="l">
+            <a:pPr algn="l" marL="228600" indent="-228600">
+              <a:lnSpc>
+                <a:spcPct val="115000"/>
+              </a:lnSpc>
+              <a:spcAft>
+                <a:spcPts val="1200"/>
+              </a:spcAft>
+              <a:buClr>
+                <a:srgbClr val="5C6BC0"/>
+              </a:buClr>
+              <a:buSzPct val="65000"/>
+              <a:buFont typeface="Arial"/>
+              <a:buChar char="●"/>
               <a:defRPr sz="1400" b="0">
                 <a:solidFill>
                   <a:srgbClr val="212121"/>
@@ -6516,7 +8128,22 @@
               </a:defRPr>
             </a:pPr>
             <a:r>
-              <a:t>• [Shift Automação] MAX ION 800 — equipamento recebido; testes de controle e treinamento com equipe da bioquímica concluídos; preparando infraestrutura para interfaceamento (previsão: semana de 30/06)</a:t>
+              <a:rPr sz="1800" b="1" i="0">
+                <a:solidFill>
+                  <a:srgbClr val="5C6BC0"/>
+                </a:solidFill>
+                <a:latin typeface="Arial"/>
+              </a:rPr>
+              <a:t>[Shift Automação] </a:t>
+            </a:r>
+            <a:r>
+              <a:rPr sz="1800" b="0" i="0">
+                <a:solidFill>
+                  <a:srgbClr val="212121"/>
+                </a:solidFill>
+                <a:latin typeface="Arial"/>
+              </a:rPr>
+              <a:t>MAX ION 800 — equipamento recebido; testes de controle e treinamento com equipe da bioquímica concluídos; aguardando assinatura de protocolo/pagamento pela Shift para prosseguir com interfaceamento</a:t>
             </a:r>
           </a:p>
         </p:txBody>

</xml_diff>